<commit_message>
Add closing indicative term-sheet slide (p.22)
New last page matching the deck template:
- Key commercial terms for discussion: £1bn min size; operating-cost
  budget vs AUM fee; conversion special-share incentive (2.5x NAV/share);
  10%/10-day-VWAP discount buyback; trust-borne launch costs offset by
  AIP's initial-share subscription
- Headings for standard UK investment-trust terms (structure, listing,
  policy, gearing, dividends, governance, service providers, liquidity, etc.)
- Non-binding/subject-to-contract footnote; added to the table of contents

https://claude.ai/code/session_01HRMxSvt6t94q3GFGUqavQe
</commit_message>
<xml_diff>
--- a/UK_Investment_Trust_Proposal.pptx
+++ b/UK_Investment_Trust_Proposal.pptx
@@ -29,6 +29,7 @@
     <p:sldId id="325" r:id="rId23"/>
     <p:sldId id="329" r:id="rId24"/>
     <p:sldId id="321" r:id="rId26"/>
+    <p:sldId id="344" r:id="rId25"/>
   </p:sldIdLst>
   <p:sldSz cx="9753600" cy="7315200"/>
   <p:notesSz cx="6858000" cy="9144000"/>
@@ -22351,6 +22352,34 @@
               <a:t>Independently validated: 20 years, net of fees</a:t>
             </a:r>
           </a:p>
+          <a:p>
+            <a:pPr>
+              <a:lnSpc>
+                <a:spcPct val="102000"/>
+              </a:lnSpc>
+              <a:spcAft>
+                <a:spcPts val="300"/>
+              </a:spcAft>
+            </a:pPr>
+            <a:r>
+              <a:rPr sz="800" b="1">
+                <a:solidFill>
+                  <a:srgbClr val="314359"/>
+                </a:solidFill>
+                <a:latin typeface="Arial"/>
+              </a:rPr>
+              <a:t>22   </a:t>
+            </a:r>
+            <a:r>
+              <a:rPr sz="800">
+                <a:solidFill>
+                  <a:srgbClr val="314359"/>
+                </a:solidFill>
+                <a:latin typeface="Arial"/>
+              </a:rPr>
+              <a:t>Indicative term sheet</a:t>
+            </a:r>
+          </a:p>
         </p:txBody>
       </p:sp>
     </p:spTree>
@@ -24296,6 +24325,1118 @@
                 <a:latin typeface="Arial"/>
               </a:rPr>
               <a:t>Source: independent institutional due-diligence review, May 2026, on StatPro security-level data and LP-level NET monthly returns (2006–2026).</a:t>
+            </a:r>
+          </a:p>
+        </p:txBody>
+      </p:sp>
+    </p:spTree>
+  </p:cSld>
+  <p:clrMapOvr>
+    <a:masterClrMapping/>
+  </p:clrMapOvr>
+</p:sld>
+</file>
+
+<file path=ppt/slides/slide22.xml><?xml version="1.0" encoding="utf-8"?>
+<p:sld xmlns:a="http://schemas.openxmlformats.org/drawingml/2006/main" xmlns:p="http://schemas.openxmlformats.org/presentationml/2006/main" xmlns:r="http://schemas.openxmlformats.org/officeDocument/2006/relationships">
+  <p:cSld>
+    <p:spTree>
+      <p:nvGrpSpPr>
+        <p:cNvPr id="1" name=""/>
+        <p:cNvGrpSpPr/>
+        <p:nvPr/>
+      </p:nvGrpSpPr>
+      <p:grpSpPr/>
+      <p:sp>
+        <p:nvSpPr>
+          <p:cNvPr id="2" name="Rectangle 1"/>
+          <p:cNvSpPr/>
+          <p:nvPr/>
+        </p:nvSpPr>
+        <p:spPr>
+          <a:xfrm>
+            <a:off x="0" y="0"/>
+            <a:ext cx="9753600" cy="7315200"/>
+          </a:xfrm>
+          <a:prstGeom prst="rect">
+            <a:avLst/>
+          </a:prstGeom>
+          <a:solidFill>
+            <a:srgbClr val="FFFFFF"/>
+          </a:solidFill>
+          <a:ln>
+            <a:noFill/>
+          </a:ln>
+          <a:effectLst/>
+        </p:spPr>
+        <p:style>
+          <a:lnRef idx="1">
+            <a:schemeClr val="accent1"/>
+          </a:lnRef>
+          <a:fillRef idx="3">
+            <a:schemeClr val="accent1"/>
+          </a:fillRef>
+          <a:effectRef idx="2">
+            <a:schemeClr val="accent1"/>
+          </a:effectRef>
+          <a:fontRef idx="minor">
+            <a:schemeClr val="lt1"/>
+          </a:fontRef>
+        </p:style>
+        <p:txBody>
+          <a:bodyPr rtlCol="0" anchor="ctr"/>
+          <a:lstStyle/>
+          <a:p>
+            <a:pPr algn="ctr"/>
+            <a:endParaRPr/>
+          </a:p>
+        </p:txBody>
+      </p:sp>
+      <p:pic>
+        <p:nvPicPr>
+          <p:cNvPr id="3" name="Picture 2" descr="mark_dark.png"/>
+          <p:cNvPicPr>
+            <a:picLocks noChangeAspect="1"/>
+          </p:cNvPicPr>
+          <p:nvPr/>
+        </p:nvPicPr>
+        <p:blipFill>
+          <a:blip r:embed="rId2"/>
+          <a:stretch>
+            <a:fillRect/>
+          </a:stretch>
+        </p:blipFill>
+        <p:spPr>
+          <a:xfrm>
+            <a:off x="402346" y="234086"/>
+            <a:ext cx="224012" cy="190199"/>
+          </a:xfrm>
+          <a:prstGeom prst="rect">
+            <a:avLst/>
+          </a:prstGeom>
+        </p:spPr>
+      </p:pic>
+      <p:sp>
+        <p:nvSpPr>
+          <p:cNvPr id="4" name="TextBox 3"/>
+          <p:cNvSpPr txBox="1"/>
+          <p:nvPr/>
+        </p:nvSpPr>
+        <p:spPr>
+          <a:xfrm>
+            <a:off x="716907" y="263347"/>
+            <a:ext cx="5120768" cy="292608"/>
+          </a:xfrm>
+          <a:prstGeom prst="rect">
+            <a:avLst/>
+          </a:prstGeom>
+          <a:noFill/>
+        </p:spPr>
+        <p:txBody>
+          <a:bodyPr wrap="square" lIns="0" tIns="0" rIns="0" bIns="0" anchor="t">
+            <a:spAutoFit/>
+          </a:bodyPr>
+          <a:lstStyle/>
+          <a:p>
+            <a:pPr algn="l">
+              <a:lnSpc>
+                <a:spcPct val="110000"/>
+              </a:lnSpc>
+              <a:spcAft>
+                <a:spcPts val="0"/>
+              </a:spcAft>
+            </a:pPr>
+            <a:r>
+              <a:rPr sz="880" b="0" i="0">
+                <a:solidFill>
+                  <a:srgbClr val="556A83"/>
+                </a:solidFill>
+                <a:latin typeface="Arial"/>
+              </a:rPr>
+              <a:t>Proposed Terms</a:t>
+            </a:r>
+          </a:p>
+        </p:txBody>
+      </p:sp>
+      <p:sp>
+        <p:nvSpPr>
+          <p:cNvPr id="6" name="Rectangle 5"/>
+          <p:cNvSpPr/>
+          <p:nvPr/>
+        </p:nvSpPr>
+        <p:spPr>
+          <a:xfrm>
+            <a:off x="0" y="604723"/>
+            <a:ext cx="9753600" cy="1414272"/>
+          </a:xfrm>
+          <a:prstGeom prst="rect">
+            <a:avLst/>
+          </a:prstGeom>
+          <a:solidFill>
+            <a:srgbClr val="F6F7F9"/>
+          </a:solidFill>
+          <a:ln>
+            <a:noFill/>
+          </a:ln>
+          <a:effectLst/>
+        </p:spPr>
+        <p:style>
+          <a:lnRef idx="1">
+            <a:schemeClr val="accent1"/>
+          </a:lnRef>
+          <a:fillRef idx="3">
+            <a:schemeClr val="accent1"/>
+          </a:fillRef>
+          <a:effectRef idx="2">
+            <a:schemeClr val="accent1"/>
+          </a:effectRef>
+          <a:fontRef idx="minor">
+            <a:schemeClr val="lt1"/>
+          </a:fontRef>
+        </p:style>
+        <p:txBody>
+          <a:bodyPr rtlCol="0" anchor="ctr"/>
+          <a:lstStyle/>
+          <a:p>
+            <a:pPr algn="ctr"/>
+            <a:endParaRPr/>
+          </a:p>
+        </p:txBody>
+      </p:sp>
+      <p:sp>
+        <p:nvSpPr>
+          <p:cNvPr id="7" name="TextBox 6"/>
+          <p:cNvSpPr txBox="1"/>
+          <p:nvPr/>
+        </p:nvSpPr>
+        <p:spPr>
+          <a:xfrm>
+            <a:off x="438922" y="721766"/>
+            <a:ext cx="8851613" cy="829056"/>
+          </a:xfrm>
+          <a:prstGeom prst="rect">
+            <a:avLst/>
+          </a:prstGeom>
+          <a:noFill/>
+        </p:spPr>
+        <p:txBody>
+          <a:bodyPr wrap="square" lIns="0" tIns="0" rIns="0" bIns="0" anchor="t">
+            <a:spAutoFit/>
+          </a:bodyPr>
+          <a:lstStyle/>
+          <a:p>
+            <a:pPr algn="l">
+              <a:lnSpc>
+                <a:spcPct val="110000"/>
+              </a:lnSpc>
+              <a:spcAft>
+                <a:spcPts val="200"/>
+              </a:spcAft>
+            </a:pPr>
+            <a:r>
+              <a:rPr sz="2400" b="0" i="0" spc="-90">
+                <a:solidFill>
+                  <a:srgbClr val="314359"/>
+                </a:solidFill>
+                <a:latin typeface="Times New Roman"/>
+              </a:rPr>
+              <a:t>Indicative term sheet</a:t>
+            </a:r>
+          </a:p>
+        </p:txBody>
+      </p:sp>
+      <p:sp>
+        <p:nvSpPr>
+          <p:cNvPr id="8" name="TextBox 7"/>
+          <p:cNvSpPr txBox="1"/>
+          <p:nvPr/>
+        </p:nvSpPr>
+        <p:spPr>
+          <a:xfrm>
+            <a:off x="453553" y="1511808"/>
+            <a:ext cx="8705305" cy="487680"/>
+          </a:xfrm>
+          <a:prstGeom prst="rect">
+            <a:avLst/>
+          </a:prstGeom>
+          <a:noFill/>
+        </p:spPr>
+        <p:txBody>
+          <a:bodyPr wrap="square" lIns="0" tIns="0" rIns="0" bIns="0" anchor="t">
+            <a:spAutoFit/>
+          </a:bodyPr>
+          <a:lstStyle/>
+          <a:p>
+            <a:pPr algn="l">
+              <a:lnSpc>
+                <a:spcPct val="110000"/>
+              </a:lnSpc>
+              <a:spcAft>
+                <a:spcPts val="0"/>
+              </a:spcAft>
+            </a:pPr>
+            <a:r>
+              <a:rPr sz="1040" b="0" i="1">
+                <a:solidFill>
+                  <a:srgbClr val="556A83"/>
+                </a:solidFill>
+                <a:latin typeface="Arial"/>
+              </a:rPr>
+              <a:t>Key commercial points for discussion; standard investment-trust terms to be documented.</a:t>
+            </a:r>
+          </a:p>
+        </p:txBody>
+      </p:sp>
+      <p:sp>
+        <p:nvSpPr>
+          <p:cNvPr id="9" name="TextBox 8"/>
+          <p:cNvSpPr txBox="1"/>
+          <p:nvPr/>
+        </p:nvSpPr>
+        <p:spPr>
+          <a:xfrm>
+            <a:off x="6583844" y="6876288"/>
+            <a:ext cx="2926153" cy="292608"/>
+          </a:xfrm>
+          <a:prstGeom prst="rect">
+            <a:avLst/>
+          </a:prstGeom>
+          <a:noFill/>
+        </p:spPr>
+        <p:txBody>
+          <a:bodyPr wrap="square" lIns="0" tIns="0" rIns="0" bIns="0" anchor="t">
+            <a:spAutoFit/>
+          </a:bodyPr>
+          <a:lstStyle/>
+          <a:p>
+            <a:pPr algn="r">
+              <a:lnSpc>
+                <a:spcPct val="110000"/>
+              </a:lnSpc>
+              <a:spcAft>
+                <a:spcPts val="0"/>
+              </a:spcAft>
+            </a:pPr>
+            <a:r>
+              <a:rPr sz="680" b="0" i="0">
+                <a:solidFill>
+                  <a:srgbClr val="556A83"/>
+                </a:solidFill>
+                <a:latin typeface="Arial"/>
+              </a:rPr>
+              <a:t>Strictly confidential          22</a:t>
+            </a:r>
+          </a:p>
+        </p:txBody>
+      </p:sp>
+      <p:sp>
+        <p:nvSpPr>
+          <p:cNvPr id="10" name="TextBox 9"/>
+          <p:cNvSpPr txBox="1"/>
+          <p:nvPr/>
+        </p:nvSpPr>
+        <p:spPr>
+          <a:xfrm>
+            <a:off x="512064" y="2212848"/>
+            <a:ext cx="4572000" cy="274320"/>
+          </a:xfrm>
+          <a:prstGeom prst="rect">
+            <a:avLst/>
+          </a:prstGeom>
+          <a:noFill/>
+        </p:spPr>
+        <p:txBody>
+          <a:bodyPr wrap="square" lIns="0" rIns="0" tIns="0" bIns="0">
+            <a:spAutoFit/>
+          </a:bodyPr>
+          <a:lstStyle/>
+          <a:p>
+            <a:r>
+              <a:rPr sz="950" b="1">
+                <a:solidFill>
+                  <a:srgbClr val="556A83"/>
+                </a:solidFill>
+                <a:latin typeface="Arial"/>
+              </a:rPr>
+              <a:t>KEY COMMERCIAL TERMS   ·   TO BE DISCUSSED</a:t>
+            </a:r>
+          </a:p>
+        </p:txBody>
+      </p:sp>
+      <p:sp>
+        <p:nvSpPr>
+          <p:cNvPr id="11" name="TextBox 10"/>
+          <p:cNvSpPr txBox="1"/>
+          <p:nvPr/>
+        </p:nvSpPr>
+        <p:spPr>
+          <a:xfrm>
+            <a:off x="5440680" y="2212848"/>
+            <a:ext cx="3886200" cy="274320"/>
+          </a:xfrm>
+          <a:prstGeom prst="rect">
+            <a:avLst/>
+          </a:prstGeom>
+          <a:noFill/>
+        </p:spPr>
+        <p:txBody>
+          <a:bodyPr wrap="square" lIns="0" rIns="0" tIns="0" bIns="0">
+            <a:spAutoFit/>
+          </a:bodyPr>
+          <a:lstStyle/>
+          <a:p>
+            <a:r>
+              <a:rPr sz="950" b="1">
+                <a:solidFill>
+                  <a:srgbClr val="556A83"/>
+                </a:solidFill>
+                <a:latin typeface="Arial"/>
+              </a:rPr>
+              <a:t>STANDARD TRUST TERMS   ·   TO BE DOCUMENTED</a:t>
+            </a:r>
+          </a:p>
+        </p:txBody>
+      </p:sp>
+      <p:sp>
+        <p:nvSpPr>
+          <p:cNvPr id="12" name="Rectangle 11"/>
+          <p:cNvSpPr/>
+          <p:nvPr/>
+        </p:nvSpPr>
+        <p:spPr>
+          <a:xfrm>
+            <a:off x="5230368" y="2240280"/>
+            <a:ext cx="10972" cy="4069080"/>
+          </a:xfrm>
+          <a:prstGeom prst="rect">
+            <a:avLst/>
+          </a:prstGeom>
+          <a:solidFill>
+            <a:srgbClr val="DDE1E7"/>
+          </a:solidFill>
+          <a:ln>
+            <a:noFill/>
+          </a:ln>
+          <a:effectLst/>
+        </p:spPr>
+        <p:style>
+          <a:lnRef idx="1">
+            <a:schemeClr val="accent1"/>
+          </a:lnRef>
+          <a:fillRef idx="3">
+            <a:schemeClr val="accent1"/>
+          </a:fillRef>
+          <a:effectRef idx="2">
+            <a:schemeClr val="accent1"/>
+          </a:effectRef>
+          <a:fontRef idx="minor">
+            <a:schemeClr val="lt1"/>
+          </a:fontRef>
+        </p:style>
+        <p:txBody>
+          <a:bodyPr rtlCol="0" anchor="ctr"/>
+          <a:lstStyle/>
+          <a:p>
+            <a:pPr algn="ctr"/>
+          </a:p>
+        </p:txBody>
+      </p:sp>
+      <p:sp>
+        <p:nvSpPr>
+          <p:cNvPr id="13" name="TextBox 12"/>
+          <p:cNvSpPr txBox="1"/>
+          <p:nvPr/>
+        </p:nvSpPr>
+        <p:spPr>
+          <a:xfrm>
+            <a:off x="512064" y="2578608"/>
+            <a:ext cx="4590288" cy="3749039"/>
+          </a:xfrm>
+          <a:prstGeom prst="rect">
+            <a:avLst/>
+          </a:prstGeom>
+          <a:noFill/>
+        </p:spPr>
+        <p:txBody>
+          <a:bodyPr wrap="square" lIns="0" rIns="0" tIns="0" bIns="0">
+            <a:spAutoFit/>
+          </a:bodyPr>
+          <a:lstStyle/>
+          <a:p>
+            <a:pPr>
+              <a:spcAft>
+                <a:spcPts val="700"/>
+              </a:spcAft>
+            </a:pPr>
+            <a:r>
+              <a:rPr sz="1050" b="1">
+                <a:solidFill>
+                  <a:srgbClr val="314359"/>
+                </a:solidFill>
+                <a:latin typeface="Arial"/>
+              </a:rPr>
+              <a:t>›  </a:t>
+            </a:r>
+            <a:r>
+              <a:rPr sz="1050" b="1">
+                <a:solidFill>
+                  <a:srgbClr val="314359"/>
+                </a:solidFill>
+                <a:latin typeface="Arial"/>
+              </a:rPr>
+              <a:t>Size.  </a:t>
+            </a:r>
+            <a:r>
+              <a:rPr sz="1050" b="0">
+                <a:solidFill>
+                  <a:srgbClr val="0E1620"/>
+                </a:solidFill>
+                <a:latin typeface="Arial"/>
+              </a:rPr>
+              <a:t>Minimum £1bn raised at IPO — the scale needed to run the operating-cost model and take meaningful, board-level stakes across the mid-market.</a:t>
+            </a:r>
+          </a:p>
+          <a:p>
+            <a:pPr>
+              <a:spcAft>
+                <a:spcPts val="700"/>
+              </a:spcAft>
+            </a:pPr>
+            <a:r>
+              <a:rPr sz="1050" b="1">
+                <a:solidFill>
+                  <a:srgbClr val="314359"/>
+                </a:solidFill>
+                <a:latin typeface="Arial"/>
+              </a:rPr>
+              <a:t>›  </a:t>
+            </a:r>
+            <a:r>
+              <a:rPr sz="1050" b="1">
+                <a:solidFill>
+                  <a:srgbClr val="314359"/>
+                </a:solidFill>
+                <a:latin typeface="Arial"/>
+              </a:rPr>
+              <a:t>Operating costs, not a fee on assets.  </a:t>
+            </a:r>
+            <a:r>
+              <a:rPr sz="1050" b="0">
+                <a:solidFill>
+                  <a:srgbClr val="0E1620"/>
+                </a:solidFill>
+                <a:latin typeface="Arial"/>
+              </a:rPr>
+              <a:t>The manager is reimbursed a capped operating-cost budget rather than an ad valorem management fee on AUM; the cost base falls as a share of NAV as the trust grows.</a:t>
+            </a:r>
+          </a:p>
+          <a:p>
+            <a:pPr>
+              <a:spcAft>
+                <a:spcPts val="700"/>
+              </a:spcAft>
+            </a:pPr>
+            <a:r>
+              <a:rPr sz="1050" b="1">
+                <a:solidFill>
+                  <a:srgbClr val="314359"/>
+                </a:solidFill>
+                <a:latin typeface="Arial"/>
+              </a:rPr>
+              <a:t>›  </a:t>
+            </a:r>
+            <a:r>
+              <a:rPr sz="1050" b="1">
+                <a:solidFill>
+                  <a:srgbClr val="314359"/>
+                </a:solidFill>
+                <a:latin typeface="Arial"/>
+              </a:rPr>
+              <a:t>Manager incentive — conversion share.  </a:t>
+            </a:r>
+            <a:r>
+              <a:rPr sz="1050" b="0">
+                <a:solidFill>
+                  <a:srgbClr val="0E1620"/>
+                </a:solidFill>
+                <a:latin typeface="Arial"/>
+              </a:rPr>
+              <a:t>AIP subscribes for a special share carrying no economic rights that converts into economic rights only once NAV per share reaches 2.5× its initial value — aligning the manager to absolute, compounding growth, not assets gathered.</a:t>
+            </a:r>
+          </a:p>
+          <a:p>
+            <a:pPr>
+              <a:spcAft>
+                <a:spcPts val="700"/>
+              </a:spcAft>
+            </a:pPr>
+            <a:r>
+              <a:rPr sz="1050" b="1">
+                <a:solidFill>
+                  <a:srgbClr val="314359"/>
+                </a:solidFill>
+                <a:latin typeface="Arial"/>
+              </a:rPr>
+              <a:t>›  </a:t>
+            </a:r>
+            <a:r>
+              <a:rPr sz="1050" b="1">
+                <a:solidFill>
+                  <a:srgbClr val="314359"/>
+                </a:solidFill>
+                <a:latin typeface="Arial"/>
+              </a:rPr>
+              <a:t>Discount control.  </a:t>
+            </a:r>
+            <a:r>
+              <a:rPr sz="1050" b="0">
+                <a:solidFill>
+                  <a:srgbClr val="0E1620"/>
+                </a:solidFill>
+                <a:latin typeface="Arial"/>
+              </a:rPr>
+              <a:t>The trust buys back shares whenever they trade more than 10% below NAV, measured on a 10-day VWAP — a hard, rules-based discount-management mechanism.</a:t>
+            </a:r>
+          </a:p>
+          <a:p>
+            <a:pPr>
+              <a:spcAft>
+                <a:spcPts val="700"/>
+              </a:spcAft>
+            </a:pPr>
+            <a:r>
+              <a:rPr sz="1050" b="1">
+                <a:solidFill>
+                  <a:srgbClr val="314359"/>
+                </a:solidFill>
+                <a:latin typeface="Arial"/>
+              </a:rPr>
+              <a:t>›  </a:t>
+            </a:r>
+            <a:r>
+              <a:rPr sz="1050" b="1">
+                <a:solidFill>
+                  <a:srgbClr val="314359"/>
+                </a:solidFill>
+                <a:latin typeface="Arial"/>
+              </a:rPr>
+              <a:t>Launch costs.  </a:t>
+            </a:r>
+            <a:r>
+              <a:rPr sz="1050" b="0">
+                <a:solidFill>
+                  <a:srgbClr val="0E1620"/>
+                </a:solidFill>
+                <a:latin typeface="Arial"/>
+              </a:rPr>
+              <a:t>The trust bears IPO and set-up costs, partially offset by AIP's subscription for the initial shares — manager capital at risk from day one.</a:t>
+            </a:r>
+          </a:p>
+        </p:txBody>
+      </p:sp>
+      <p:sp>
+        <p:nvSpPr>
+          <p:cNvPr id="14" name="TextBox 13"/>
+          <p:cNvSpPr txBox="1"/>
+          <p:nvPr/>
+        </p:nvSpPr>
+        <p:spPr>
+          <a:xfrm>
+            <a:off x="5440680" y="2578608"/>
+            <a:ext cx="3886200" cy="3749039"/>
+          </a:xfrm>
+          <a:prstGeom prst="rect">
+            <a:avLst/>
+          </a:prstGeom>
+          <a:noFill/>
+        </p:spPr>
+        <p:txBody>
+          <a:bodyPr wrap="square" lIns="0" rIns="0" tIns="0" bIns="0">
+            <a:spAutoFit/>
+          </a:bodyPr>
+          <a:lstStyle/>
+          <a:p>
+            <a:pPr>
+              <a:spcAft>
+                <a:spcPts val="440"/>
+              </a:spcAft>
+            </a:pPr>
+            <a:r>
+              <a:rPr sz="919" b="1">
+                <a:solidFill>
+                  <a:srgbClr val="556A83"/>
+                </a:solidFill>
+                <a:latin typeface="Arial"/>
+              </a:rPr>
+              <a:t>·  </a:t>
+            </a:r>
+            <a:r>
+              <a:rPr sz="919" b="0">
+                <a:solidFill>
+                  <a:srgbClr val="0E1620"/>
+                </a:solidFill>
+                <a:latin typeface="Arial"/>
+              </a:rPr>
+              <a:t>Structure &amp; domicile — UK investment trust (plc), s.1158 status</a:t>
+            </a:r>
+          </a:p>
+          <a:p>
+            <a:pPr>
+              <a:spcAft>
+                <a:spcPts val="440"/>
+              </a:spcAft>
+            </a:pPr>
+            <a:r>
+              <a:rPr sz="919" b="1">
+                <a:solidFill>
+                  <a:srgbClr val="556A83"/>
+                </a:solidFill>
+                <a:latin typeface="Arial"/>
+              </a:rPr>
+              <a:t>·  </a:t>
+            </a:r>
+            <a:r>
+              <a:rPr sz="919" b="0">
+                <a:solidFill>
+                  <a:srgbClr val="0E1620"/>
+                </a:solidFill>
+                <a:latin typeface="Arial"/>
+              </a:rPr>
+              <a:t>Listing &amp; market — LSE Main Market, premium listing</a:t>
+            </a:r>
+          </a:p>
+          <a:p>
+            <a:pPr>
+              <a:spcAft>
+                <a:spcPts val="440"/>
+              </a:spcAft>
+            </a:pPr>
+            <a:r>
+              <a:rPr sz="919" b="1">
+                <a:solidFill>
+                  <a:srgbClr val="556A83"/>
+                </a:solidFill>
+                <a:latin typeface="Arial"/>
+              </a:rPr>
+              <a:t>·  </a:t>
+            </a:r>
+            <a:r>
+              <a:rPr sz="919" b="0">
+                <a:solidFill>
+                  <a:srgbClr val="0E1620"/>
+                </a:solidFill>
+                <a:latin typeface="Arial"/>
+              </a:rPr>
+              <a:t>Investment objective &amp; policy</a:t>
+            </a:r>
+          </a:p>
+          <a:p>
+            <a:pPr>
+              <a:spcAft>
+                <a:spcPts val="440"/>
+              </a:spcAft>
+            </a:pPr>
+            <a:r>
+              <a:rPr sz="919" b="1">
+                <a:solidFill>
+                  <a:srgbClr val="556A83"/>
+                </a:solidFill>
+                <a:latin typeface="Arial"/>
+              </a:rPr>
+              <a:t>·  </a:t>
+            </a:r>
+            <a:r>
+              <a:rPr sz="919" b="0">
+                <a:solidFill>
+                  <a:srgbClr val="0E1620"/>
+                </a:solidFill>
+                <a:latin typeface="Arial"/>
+              </a:rPr>
+              <a:t>Investment restrictions &amp; limits</a:t>
+            </a:r>
+          </a:p>
+          <a:p>
+            <a:pPr>
+              <a:spcAft>
+                <a:spcPts val="440"/>
+              </a:spcAft>
+            </a:pPr>
+            <a:r>
+              <a:rPr sz="919" b="1">
+                <a:solidFill>
+                  <a:srgbClr val="556A83"/>
+                </a:solidFill>
+                <a:latin typeface="Arial"/>
+              </a:rPr>
+              <a:t>·  </a:t>
+            </a:r>
+            <a:r>
+              <a:rPr sz="919" b="0">
+                <a:solidFill>
+                  <a:srgbClr val="0E1620"/>
+                </a:solidFill>
+                <a:latin typeface="Arial"/>
+              </a:rPr>
+              <a:t>AIFM, investment manager &amp; key persons</a:t>
+            </a:r>
+          </a:p>
+          <a:p>
+            <a:pPr>
+              <a:spcAft>
+                <a:spcPts val="440"/>
+              </a:spcAft>
+            </a:pPr>
+            <a:r>
+              <a:rPr sz="919" b="1">
+                <a:solidFill>
+                  <a:srgbClr val="556A83"/>
+                </a:solidFill>
+                <a:latin typeface="Arial"/>
+              </a:rPr>
+              <a:t>·  </a:t>
+            </a:r>
+            <a:r>
+              <a:rPr sz="919" b="0">
+                <a:solidFill>
+                  <a:srgbClr val="0E1620"/>
+                </a:solidFill>
+                <a:latin typeface="Arial"/>
+              </a:rPr>
+              <a:t>Gearing / borrowing policy</a:t>
+            </a:r>
+          </a:p>
+          <a:p>
+            <a:pPr>
+              <a:spcAft>
+                <a:spcPts val="440"/>
+              </a:spcAft>
+            </a:pPr>
+            <a:r>
+              <a:rPr sz="919" b="1">
+                <a:solidFill>
+                  <a:srgbClr val="556A83"/>
+                </a:solidFill>
+                <a:latin typeface="Arial"/>
+              </a:rPr>
+              <a:t>·  </a:t>
+            </a:r>
+            <a:r>
+              <a:rPr sz="919" b="0">
+                <a:solidFill>
+                  <a:srgbClr val="0E1620"/>
+                </a:solidFill>
+                <a:latin typeface="Arial"/>
+              </a:rPr>
+              <a:t>Dividend &amp; distribution policy</a:t>
+            </a:r>
+          </a:p>
+          <a:p>
+            <a:pPr>
+              <a:spcAft>
+                <a:spcPts val="440"/>
+              </a:spcAft>
+            </a:pPr>
+            <a:r>
+              <a:rPr sz="919" b="1">
+                <a:solidFill>
+                  <a:srgbClr val="556A83"/>
+                </a:solidFill>
+                <a:latin typeface="Arial"/>
+              </a:rPr>
+              <a:t>·  </a:t>
+            </a:r>
+            <a:r>
+              <a:rPr sz="919" b="0">
+                <a:solidFill>
+                  <a:srgbClr val="0E1620"/>
+                </a:solidFill>
+                <a:latin typeface="Arial"/>
+              </a:rPr>
+              <a:t>NAV calculation &amp; valuation policy</a:t>
+            </a:r>
+          </a:p>
+          <a:p>
+            <a:pPr>
+              <a:spcAft>
+                <a:spcPts val="440"/>
+              </a:spcAft>
+            </a:pPr>
+            <a:r>
+              <a:rPr sz="919" b="1">
+                <a:solidFill>
+                  <a:srgbClr val="556A83"/>
+                </a:solidFill>
+                <a:latin typeface="Arial"/>
+              </a:rPr>
+              <a:t>·  </a:t>
+            </a:r>
+            <a:r>
+              <a:rPr sz="919" b="0">
+                <a:solidFill>
+                  <a:srgbClr val="0E1620"/>
+                </a:solidFill>
+                <a:latin typeface="Arial"/>
+              </a:rPr>
+              <a:t>Continuation vote / life of the company</a:t>
+            </a:r>
+          </a:p>
+          <a:p>
+            <a:pPr>
+              <a:spcAft>
+                <a:spcPts val="440"/>
+              </a:spcAft>
+            </a:pPr>
+            <a:r>
+              <a:rPr sz="919" b="1">
+                <a:solidFill>
+                  <a:srgbClr val="556A83"/>
+                </a:solidFill>
+                <a:latin typeface="Arial"/>
+              </a:rPr>
+              <a:t>·  </a:t>
+            </a:r>
+            <a:r>
+              <a:rPr sz="919" b="0">
+                <a:solidFill>
+                  <a:srgbClr val="0E1620"/>
+                </a:solidFill>
+                <a:latin typeface="Arial"/>
+              </a:rPr>
+              <a:t>Board composition &amp; corporate governance</a:t>
+            </a:r>
+          </a:p>
+          <a:p>
+            <a:pPr>
+              <a:spcAft>
+                <a:spcPts val="440"/>
+              </a:spcAft>
+            </a:pPr>
+            <a:r>
+              <a:rPr sz="919" b="1">
+                <a:solidFill>
+                  <a:srgbClr val="556A83"/>
+                </a:solidFill>
+                <a:latin typeface="Arial"/>
+              </a:rPr>
+              <a:t>·  </a:t>
+            </a:r>
+            <a:r>
+              <a:rPr sz="919" b="0">
+                <a:solidFill>
+                  <a:srgbClr val="0E1620"/>
+                </a:solidFill>
+                <a:latin typeface="Arial"/>
+              </a:rPr>
+              <a:t>Conflicts of interest &amp; related-party dealing</a:t>
+            </a:r>
+          </a:p>
+          <a:p>
+            <a:pPr>
+              <a:spcAft>
+                <a:spcPts val="440"/>
+              </a:spcAft>
+            </a:pPr>
+            <a:r>
+              <a:rPr sz="919" b="1">
+                <a:solidFill>
+                  <a:srgbClr val="556A83"/>
+                </a:solidFill>
+                <a:latin typeface="Arial"/>
+              </a:rPr>
+              <a:t>·  </a:t>
+            </a:r>
+            <a:r>
+              <a:rPr sz="919" b="0">
+                <a:solidFill>
+                  <a:srgbClr val="0E1620"/>
+                </a:solidFill>
+                <a:latin typeface="Arial"/>
+              </a:rPr>
+              <a:t>Depositary, administrator &amp; registrar</a:t>
+            </a:r>
+          </a:p>
+          <a:p>
+            <a:pPr>
+              <a:spcAft>
+                <a:spcPts val="440"/>
+              </a:spcAft>
+            </a:pPr>
+            <a:r>
+              <a:rPr sz="919" b="1">
+                <a:solidFill>
+                  <a:srgbClr val="556A83"/>
+                </a:solidFill>
+                <a:latin typeface="Arial"/>
+              </a:rPr>
+              <a:t>·  </a:t>
+            </a:r>
+            <a:r>
+              <a:rPr sz="919" b="0">
+                <a:solidFill>
+                  <a:srgbClr val="0E1620"/>
+                </a:solidFill>
+                <a:latin typeface="Arial"/>
+              </a:rPr>
+              <a:t>Auditor &amp; corporate broker</a:t>
+            </a:r>
+          </a:p>
+          <a:p>
+            <a:pPr>
+              <a:spcAft>
+                <a:spcPts val="440"/>
+              </a:spcAft>
+            </a:pPr>
+            <a:r>
+              <a:rPr sz="919" b="1">
+                <a:solidFill>
+                  <a:srgbClr val="556A83"/>
+                </a:solidFill>
+                <a:latin typeface="Arial"/>
+              </a:rPr>
+              <a:t>·  </a:t>
+            </a:r>
+            <a:r>
+              <a:rPr sz="919" b="0">
+                <a:solidFill>
+                  <a:srgbClr val="0E1620"/>
+                </a:solidFill>
+                <a:latin typeface="Arial"/>
+              </a:rPr>
+              <a:t>Liquidity — tender offers / treasury shares</a:t>
+            </a:r>
+          </a:p>
+          <a:p>
+            <a:pPr>
+              <a:spcAft>
+                <a:spcPts val="440"/>
+              </a:spcAft>
+            </a:pPr>
+            <a:r>
+              <a:rPr sz="919" b="1">
+                <a:solidFill>
+                  <a:srgbClr val="556A83"/>
+                </a:solidFill>
+                <a:latin typeface="Arial"/>
+              </a:rPr>
+              <a:t>·  </a:t>
+            </a:r>
+            <a:r>
+              <a:rPr sz="919" b="0">
+                <a:solidFill>
+                  <a:srgbClr val="0E1620"/>
+                </a:solidFill>
+                <a:latin typeface="Arial"/>
+              </a:rPr>
+              <a:t>Lock-up &amp; orderly-market arrangements</a:t>
+            </a:r>
+          </a:p>
+          <a:p>
+            <a:pPr>
+              <a:spcAft>
+                <a:spcPts val="440"/>
+              </a:spcAft>
+            </a:pPr>
+            <a:r>
+              <a:rPr sz="919" b="1">
+                <a:solidFill>
+                  <a:srgbClr val="556A83"/>
+                </a:solidFill>
+                <a:latin typeface="Arial"/>
+              </a:rPr>
+              <a:t>·  </a:t>
+            </a:r>
+            <a:r>
+              <a:rPr sz="919" b="0">
+                <a:solidFill>
+                  <a:srgbClr val="0E1620"/>
+                </a:solidFill>
+                <a:latin typeface="Arial"/>
+              </a:rPr>
+              <a:t>ISA / SIPP eligibility</a:t>
+            </a:r>
+          </a:p>
+          <a:p>
+            <a:pPr>
+              <a:spcAft>
+                <a:spcPts val="440"/>
+              </a:spcAft>
+            </a:pPr>
+            <a:r>
+              <a:rPr sz="919" b="1">
+                <a:solidFill>
+                  <a:srgbClr val="556A83"/>
+                </a:solidFill>
+                <a:latin typeface="Arial"/>
+              </a:rPr>
+              <a:t>·  </a:t>
+            </a:r>
+            <a:r>
+              <a:rPr sz="919" b="0">
+                <a:solidFill>
+                  <a:srgbClr val="0E1620"/>
+                </a:solidFill>
+                <a:latin typeface="Arial"/>
+              </a:rPr>
+              <a:t>Reporting &amp; financial calendar</a:t>
+            </a:r>
+          </a:p>
+          <a:p>
+            <a:pPr>
+              <a:spcAft>
+                <a:spcPts val="440"/>
+              </a:spcAft>
+            </a:pPr>
+            <a:r>
+              <a:rPr sz="919" b="1">
+                <a:solidFill>
+                  <a:srgbClr val="556A83"/>
+                </a:solidFill>
+                <a:latin typeface="Arial"/>
+              </a:rPr>
+              <a:t>·  </a:t>
+            </a:r>
+            <a:r>
+              <a:rPr sz="919" b="0">
+                <a:solidFill>
+                  <a:srgbClr val="0E1620"/>
+                </a:solidFill>
+                <a:latin typeface="Arial"/>
+              </a:rPr>
+              <a:t>Ticker, ISIN &amp; SEDOL</a:t>
+            </a:r>
+          </a:p>
+        </p:txBody>
+      </p:sp>
+      <p:sp>
+        <p:nvSpPr>
+          <p:cNvPr id="15" name="TextBox 14"/>
+          <p:cNvSpPr txBox="1"/>
+          <p:nvPr/>
+        </p:nvSpPr>
+        <p:spPr>
+          <a:xfrm>
+            <a:off x="512064" y="6419088"/>
+            <a:ext cx="8778240" cy="365760"/>
+          </a:xfrm>
+          <a:prstGeom prst="rect">
+            <a:avLst/>
+          </a:prstGeom>
+          <a:noFill/>
+        </p:spPr>
+        <p:txBody>
+          <a:bodyPr wrap="square" lIns="0" rIns="0" tIns="0" bIns="0">
+            <a:spAutoFit/>
+          </a:bodyPr>
+          <a:lstStyle/>
+          <a:p>
+            <a:r>
+              <a:rPr sz="650" b="0">
+                <a:solidFill>
+                  <a:srgbClr val="8A939F"/>
+                </a:solidFill>
+                <a:latin typeface="Arial"/>
+              </a:rPr>
+              <a:t>Indicative and non-binding, for discussion only — subject to contract, satisfactory due diligence, regulatory approval and final documentation. Not an offer or invitation to invest.</a:t>
             </a:r>
           </a:p>
         </p:txBody>

</xml_diff>

<commit_message>
Flesh out term sheet into a two-page Term/Detail table (p.22-23)
Converted the single headings slide into a proper indicative term sheet:
- p.22 (1/2): structure, listing, size, investment objective (invest in
  AIPII via zero-fee share class), restrictions, manager/key man (Stefan
  Charette; key-man redemption), operating-cost model, 2.5x conversion
  share, discount control, launch costs
- p.23 (2/2): gearing (10% NAV short-term only), dividend (growth/total-
  return; minimum to keep s.1158 status), NAV via MUFG, continuation/
  conversion, board (>=4 INEDs + 1 AIP), conflicts, and TBC service-
  provider rows
- Non-binding/subject-to-contract footnote; TOC updated for both pages

https://claude.ai/code/session_01HRMxSvt6t94q3GFGUqavQe
</commit_message>
<xml_diff>
--- a/UK_Investment_Trust_Proposal.pptx
+++ b/UK_Investment_Trust_Proposal.pptx
@@ -30,6 +30,7 @@
     <p:sldId id="329" r:id="rId24"/>
     <p:sldId id="321" r:id="rId26"/>
     <p:sldId id="344" r:id="rId25"/>
+    <p:sldId id="345" r:id="rId19"/>
   </p:sldIdLst>
   <p:sldSz cx="9753600" cy="7315200"/>
   <p:notesSz cx="6858000" cy="9144000"/>
@@ -22380,6 +22381,34 @@
               <a:t>Indicative term sheet</a:t>
             </a:r>
           </a:p>
+          <a:p>
+            <a:pPr>
+              <a:lnSpc>
+                <a:spcPct val="102000"/>
+              </a:lnSpc>
+              <a:spcAft>
+                <a:spcPts val="300"/>
+              </a:spcAft>
+            </a:pPr>
+            <a:r>
+              <a:rPr sz="800" b="1">
+                <a:solidFill>
+                  <a:srgbClr val="314359"/>
+                </a:solidFill>
+                <a:latin typeface="Arial"/>
+              </a:rPr>
+              <a:t>23   </a:t>
+            </a:r>
+            <a:r>
+              <a:rPr sz="800">
+                <a:solidFill>
+                  <a:srgbClr val="314359"/>
+                </a:solidFill>
+                <a:latin typeface="Arial"/>
+              </a:rPr>
+              <a:t>Indicative term sheet (cont.)</a:t>
+            </a:r>
+          </a:p>
         </p:txBody>
       </p:sp>
     </p:spTree>
@@ -24582,7 +24611,7 @@
                 </a:solidFill>
                 <a:latin typeface="Arial"/>
               </a:rPr>
-              <a:t>Key commercial points for discussion; standard investment-trust terms to be documented.</a:t>
+              <a:t>Indicative and non-binding, for discussion only — subject to contract and final documentation.  (1 of 2)</a:t>
             </a:r>
           </a:p>
         </p:txBody>
@@ -24629,90 +24658,526 @@
           </a:p>
         </p:txBody>
       </p:sp>
-      <p:sp>
-        <p:nvSpPr>
-          <p:cNvPr id="10" name="TextBox 9"/>
-          <p:cNvSpPr txBox="1"/>
-          <p:nvPr/>
-        </p:nvSpPr>
-        <p:spPr>
-          <a:xfrm>
-            <a:off x="512064" y="2212848"/>
-            <a:ext cx="4572000" cy="274320"/>
-          </a:xfrm>
-          <a:prstGeom prst="rect">
-            <a:avLst/>
-          </a:prstGeom>
-          <a:noFill/>
-        </p:spPr>
-        <p:txBody>
-          <a:bodyPr wrap="square" lIns="0" rIns="0" tIns="0" bIns="0">
-            <a:spAutoFit/>
-          </a:bodyPr>
-          <a:lstStyle/>
-          <a:p>
-            <a:r>
-              <a:rPr sz="950" b="1">
-                <a:solidFill>
-                  <a:srgbClr val="556A83"/>
-                </a:solidFill>
-                <a:latin typeface="Arial"/>
-              </a:rPr>
-              <a:t>KEY COMMERCIAL TERMS   ·   TO BE DISCUSSED</a:t>
-            </a:r>
-          </a:p>
-        </p:txBody>
-      </p:sp>
-      <p:sp>
-        <p:nvSpPr>
-          <p:cNvPr id="11" name="TextBox 10"/>
-          <p:cNvSpPr txBox="1"/>
-          <p:nvPr/>
-        </p:nvSpPr>
-        <p:spPr>
-          <a:xfrm>
-            <a:off x="5440680" y="2212848"/>
-            <a:ext cx="3886200" cy="274320"/>
-          </a:xfrm>
-          <a:prstGeom prst="rect">
-            <a:avLst/>
-          </a:prstGeom>
-          <a:noFill/>
-        </p:spPr>
-        <p:txBody>
-          <a:bodyPr wrap="square" lIns="0" rIns="0" tIns="0" bIns="0">
-            <a:spAutoFit/>
-          </a:bodyPr>
-          <a:lstStyle/>
-          <a:p>
-            <a:r>
-              <a:rPr sz="950" b="1">
-                <a:solidFill>
-                  <a:srgbClr val="556A83"/>
-                </a:solidFill>
-                <a:latin typeface="Arial"/>
-              </a:rPr>
-              <a:t>STANDARD TRUST TERMS   ·   TO BE DOCUMENTED</a:t>
-            </a:r>
-          </a:p>
-        </p:txBody>
-      </p:sp>
-      <p:sp>
-        <p:nvSpPr>
-          <p:cNvPr id="12" name="Rectangle 11"/>
+      <p:graphicFrame>
+        <p:nvGraphicFramePr>
+          <p:cNvPr id="10" name="Table 9"/>
+          <p:cNvGraphicFramePr>
+            <a:graphicFrameLocks noGrp="1"/>
+          </p:cNvGraphicFramePr>
+          <p:nvPr/>
+        </p:nvGraphicFramePr>
+        <p:xfrm>
+          <a:off x="512064" y="2139696"/>
+          <a:ext cx="8796527" cy="2377440"/>
+        </p:xfrm>
+        <a:graphic>
+          <a:graphicData uri="http://schemas.openxmlformats.org/drawingml/2006/table">
+            <a:tbl>
+              <a:tblPr>
+                <a:tableStyleId>{2D5ABB26-0587-4C30-8999-92F81FD0307C}</a:tableStyleId>
+              </a:tblPr>
+              <a:tblGrid>
+                <a:gridCol w="2331720"/>
+                <a:gridCol w="6464807"/>
+              </a:tblGrid>
+              <a:tr h="237744">
+                <a:tc>
+                  <a:txBody>
+                    <a:bodyPr wrap="square"/>
+                    <a:lstStyle/>
+                    <a:p>
+                      <a:r>
+                        <a:rPr sz="900" b="1">
+                          <a:solidFill>
+                            <a:srgbClr val="314359"/>
+                          </a:solidFill>
+                          <a:latin typeface="Arial"/>
+                        </a:rPr>
+                        <a:t>Structure &amp; domicile</a:t>
+                      </a:r>
+                    </a:p>
+                  </a:txBody>
+                  <a:tcPr marL="64008" marR="82296" marT="32004" marB="32004" anchor="t">
+                    <a:solidFill>
+                      <a:srgbClr val="FFFFFF"/>
+                    </a:solidFill>
+                  </a:tcPr>
+                </a:tc>
+                <a:tc>
+                  <a:txBody>
+                    <a:bodyPr wrap="square"/>
+                    <a:lstStyle/>
+                    <a:p>
+                      <a:r>
+                        <a:rPr sz="869" b="0">
+                          <a:solidFill>
+                            <a:srgbClr val="0E1620"/>
+                          </a:solidFill>
+                          <a:latin typeface="Arial"/>
+                        </a:rPr>
+                        <a:t>UK investment trust (plc), approved under s.1158 CTA 2010 [domicile TBC].</a:t>
+                      </a:r>
+                    </a:p>
+                  </a:txBody>
+                  <a:tcPr marL="64008" marR="82296" marT="32004" marB="32004" anchor="t">
+                    <a:solidFill>
+                      <a:srgbClr val="FFFFFF"/>
+                    </a:solidFill>
+                  </a:tcPr>
+                </a:tc>
+              </a:tr>
+              <a:tr h="237744">
+                <a:tc>
+                  <a:txBody>
+                    <a:bodyPr wrap="square"/>
+                    <a:lstStyle/>
+                    <a:p>
+                      <a:r>
+                        <a:rPr sz="900" b="1">
+                          <a:solidFill>
+                            <a:srgbClr val="314359"/>
+                          </a:solidFill>
+                          <a:latin typeface="Arial"/>
+                        </a:rPr>
+                        <a:t>Listing &amp; market</a:t>
+                      </a:r>
+                    </a:p>
+                  </a:txBody>
+                  <a:tcPr marL="64008" marR="82296" marT="32004" marB="32004" anchor="t">
+                    <a:solidFill>
+                      <a:srgbClr val="F4F6F8"/>
+                    </a:solidFill>
+                  </a:tcPr>
+                </a:tc>
+                <a:tc>
+                  <a:txBody>
+                    <a:bodyPr wrap="square"/>
+                    <a:lstStyle/>
+                    <a:p>
+                      <a:r>
+                        <a:rPr sz="869" b="0">
+                          <a:solidFill>
+                            <a:srgbClr val="0E1620"/>
+                          </a:solidFill>
+                          <a:latin typeface="Arial"/>
+                        </a:rPr>
+                        <a:t>Premium listing, London Stock Exchange Main Market; sterling.</a:t>
+                      </a:r>
+                    </a:p>
+                  </a:txBody>
+                  <a:tcPr marL="64008" marR="82296" marT="32004" marB="32004" anchor="t">
+                    <a:solidFill>
+                      <a:srgbClr val="F4F6F8"/>
+                    </a:solidFill>
+                  </a:tcPr>
+                </a:tc>
+              </a:tr>
+              <a:tr h="237744">
+                <a:tc>
+                  <a:txBody>
+                    <a:bodyPr wrap="square"/>
+                    <a:lstStyle/>
+                    <a:p>
+                      <a:r>
+                        <a:rPr sz="900" b="1">
+                          <a:solidFill>
+                            <a:srgbClr val="314359"/>
+                          </a:solidFill>
+                          <a:latin typeface="Arial"/>
+                        </a:rPr>
+                        <a:t>Size</a:t>
+                      </a:r>
+                    </a:p>
+                  </a:txBody>
+                  <a:tcPr marL="64008" marR="82296" marT="32004" marB="32004" anchor="t">
+                    <a:solidFill>
+                      <a:srgbClr val="FFFFFF"/>
+                    </a:solidFill>
+                  </a:tcPr>
+                </a:tc>
+                <a:tc>
+                  <a:txBody>
+                    <a:bodyPr wrap="square"/>
+                    <a:lstStyle/>
+                    <a:p>
+                      <a:r>
+                        <a:rPr sz="869" b="0">
+                          <a:solidFill>
+                            <a:srgbClr val="0E1620"/>
+                          </a:solidFill>
+                          <a:latin typeface="Arial"/>
+                        </a:rPr>
+                        <a:t>Minimum £1bn raised at IPO.</a:t>
+                      </a:r>
+                    </a:p>
+                  </a:txBody>
+                  <a:tcPr marL="64008" marR="82296" marT="32004" marB="32004" anchor="t">
+                    <a:solidFill>
+                      <a:srgbClr val="FFFFFF"/>
+                    </a:solidFill>
+                  </a:tcPr>
+                </a:tc>
+              </a:tr>
+              <a:tr h="237744">
+                <a:tc>
+                  <a:txBody>
+                    <a:bodyPr wrap="square"/>
+                    <a:lstStyle/>
+                    <a:p>
+                      <a:r>
+                        <a:rPr sz="900" b="1">
+                          <a:solidFill>
+                            <a:srgbClr val="314359"/>
+                          </a:solidFill>
+                          <a:latin typeface="Arial"/>
+                        </a:rPr>
+                        <a:t>Investment objective &amp; policy</a:t>
+                      </a:r>
+                    </a:p>
+                  </a:txBody>
+                  <a:tcPr marL="64008" marR="82296" marT="32004" marB="32004" anchor="t">
+                    <a:solidFill>
+                      <a:srgbClr val="F4F6F8"/>
+                    </a:solidFill>
+                  </a:tcPr>
+                </a:tc>
+                <a:tc>
+                  <a:txBody>
+                    <a:bodyPr wrap="square"/>
+                    <a:lstStyle/>
+                    <a:p>
+                      <a:r>
+                        <a:rPr sz="869" b="0">
+                          <a:solidFill>
+                            <a:srgbClr val="0E1620"/>
+                          </a:solidFill>
+                          <a:latin typeface="Arial"/>
+                        </a:rPr>
+                        <a:t>Long-term capital growth, investing substantially all assets in Athanase Industrial Partners Fund II (“AIPII”) via a dedicated, tax-efficient zero-fee share class [structure TBC]. AIPII invests globally in mid-sized companies with scope for operational improvement through engaged ownership.</a:t>
+                      </a:r>
+                    </a:p>
+                  </a:txBody>
+                  <a:tcPr marL="64008" marR="82296" marT="32004" marB="32004" anchor="t">
+                    <a:solidFill>
+                      <a:srgbClr val="F4F6F8"/>
+                    </a:solidFill>
+                  </a:tcPr>
+                </a:tc>
+              </a:tr>
+              <a:tr h="237744">
+                <a:tc>
+                  <a:txBody>
+                    <a:bodyPr wrap="square"/>
+                    <a:lstStyle/>
+                    <a:p>
+                      <a:r>
+                        <a:rPr sz="900" b="1">
+                          <a:solidFill>
+                            <a:srgbClr val="314359"/>
+                          </a:solidFill>
+                          <a:latin typeface="Arial"/>
+                        </a:rPr>
+                        <a:t>Investment restrictions &amp; limits</a:t>
+                      </a:r>
+                    </a:p>
+                  </a:txBody>
+                  <a:tcPr marL="64008" marR="82296" marT="32004" marB="32004" anchor="t">
+                    <a:solidFill>
+                      <a:srgbClr val="FFFFFF"/>
+                    </a:solidFill>
+                  </a:tcPr>
+                </a:tc>
+                <a:tc>
+                  <a:txBody>
+                    <a:bodyPr wrap="square"/>
+                    <a:lstStyle/>
+                    <a:p>
+                      <a:r>
+                        <a:rPr sz="869" b="0">
+                          <a:solidFill>
+                            <a:srgbClr val="0E1620"/>
+                          </a:solidFill>
+                          <a:latin typeface="Arial"/>
+                        </a:rPr>
+                        <a:t>The trust invests solely in AIPII.</a:t>
+                      </a:r>
+                    </a:p>
+                  </a:txBody>
+                  <a:tcPr marL="64008" marR="82296" marT="32004" marB="32004" anchor="t">
+                    <a:solidFill>
+                      <a:srgbClr val="FFFFFF"/>
+                    </a:solidFill>
+                  </a:tcPr>
+                </a:tc>
+              </a:tr>
+              <a:tr h="237744">
+                <a:tc>
+                  <a:txBody>
+                    <a:bodyPr wrap="square"/>
+                    <a:lstStyle/>
+                    <a:p>
+                      <a:r>
+                        <a:rPr sz="900" b="1">
+                          <a:solidFill>
+                            <a:srgbClr val="314359"/>
+                          </a:solidFill>
+                          <a:latin typeface="Arial"/>
+                        </a:rPr>
+                        <a:t>AIFM, investment manager &amp; key persons</a:t>
+                      </a:r>
+                    </a:p>
+                  </a:txBody>
+                  <a:tcPr marL="64008" marR="82296" marT="32004" marB="32004" anchor="t">
+                    <a:solidFill>
+                      <a:srgbClr val="F4F6F8"/>
+                    </a:solidFill>
+                  </a:tcPr>
+                </a:tc>
+                <a:tc>
+                  <a:txBody>
+                    <a:bodyPr wrap="square"/>
+                    <a:lstStyle/>
+                    <a:p>
+                      <a:r>
+                        <a:rPr sz="869" b="0">
+                          <a:solidFill>
+                            <a:srgbClr val="0E1620"/>
+                          </a:solidFill>
+                          <a:latin typeface="Arial"/>
+                        </a:rPr>
+                        <a:t>AIPII's manager is Athanase Industrial Partner Ltd (Cayman Islands). Key man: Stefan Charette. On a key-man departure, the trust may redeem its AIPII holding and reinvest the proceeds.</a:t>
+                      </a:r>
+                    </a:p>
+                  </a:txBody>
+                  <a:tcPr marL="64008" marR="82296" marT="32004" marB="32004" anchor="t">
+                    <a:solidFill>
+                      <a:srgbClr val="F4F6F8"/>
+                    </a:solidFill>
+                  </a:tcPr>
+                </a:tc>
+              </a:tr>
+              <a:tr h="237744">
+                <a:tc>
+                  <a:txBody>
+                    <a:bodyPr wrap="square"/>
+                    <a:lstStyle/>
+                    <a:p>
+                      <a:r>
+                        <a:rPr sz="900" b="1">
+                          <a:solidFill>
+                            <a:srgbClr val="314359"/>
+                          </a:solidFill>
+                          <a:latin typeface="Arial"/>
+                        </a:rPr>
+                        <a:t>Operating costs (not a fee on assets)</a:t>
+                      </a:r>
+                    </a:p>
+                  </a:txBody>
+                  <a:tcPr marL="64008" marR="82296" marT="32004" marB="32004" anchor="t">
+                    <a:solidFill>
+                      <a:srgbClr val="FFFFFF"/>
+                    </a:solidFill>
+                  </a:tcPr>
+                </a:tc>
+                <a:tc>
+                  <a:txBody>
+                    <a:bodyPr wrap="square"/>
+                    <a:lstStyle/>
+                    <a:p>
+                      <a:r>
+                        <a:rPr sz="869" b="0">
+                          <a:solidFill>
+                            <a:srgbClr val="0E1620"/>
+                          </a:solidFill>
+                          <a:latin typeface="Arial"/>
+                        </a:rPr>
+                        <a:t>Manager reimbursed a capped operating-cost budget; no ad valorem management fee on AUM. The cost base falls as a share of NAV as the trust grows.</a:t>
+                      </a:r>
+                    </a:p>
+                  </a:txBody>
+                  <a:tcPr marL="64008" marR="82296" marT="32004" marB="32004" anchor="t">
+                    <a:solidFill>
+                      <a:srgbClr val="FFFFFF"/>
+                    </a:solidFill>
+                  </a:tcPr>
+                </a:tc>
+              </a:tr>
+              <a:tr h="237744">
+                <a:tc>
+                  <a:txBody>
+                    <a:bodyPr wrap="square"/>
+                    <a:lstStyle/>
+                    <a:p>
+                      <a:r>
+                        <a:rPr sz="900" b="1">
+                          <a:solidFill>
+                            <a:srgbClr val="314359"/>
+                          </a:solidFill>
+                          <a:latin typeface="Arial"/>
+                        </a:rPr>
+                        <a:t>Manager incentive — conversion share</a:t>
+                      </a:r>
+                    </a:p>
+                  </a:txBody>
+                  <a:tcPr marL="64008" marR="82296" marT="32004" marB="32004" anchor="t">
+                    <a:solidFill>
+                      <a:srgbClr val="F4F6F8"/>
+                    </a:solidFill>
+                  </a:tcPr>
+                </a:tc>
+                <a:tc>
+                  <a:txBody>
+                    <a:bodyPr wrap="square"/>
+                    <a:lstStyle/>
+                    <a:p>
+                      <a:r>
+                        <a:rPr sz="869" b="0">
+                          <a:solidFill>
+                            <a:srgbClr val="0E1620"/>
+                          </a:solidFill>
+                          <a:latin typeface="Arial"/>
+                        </a:rPr>
+                        <a:t>AIP subscribes for a special share with no economic rights that converts into economic rights only once NAV per share reaches 2.5× its initial value.</a:t>
+                      </a:r>
+                    </a:p>
+                  </a:txBody>
+                  <a:tcPr marL="64008" marR="82296" marT="32004" marB="32004" anchor="t">
+                    <a:solidFill>
+                      <a:srgbClr val="F4F6F8"/>
+                    </a:solidFill>
+                  </a:tcPr>
+                </a:tc>
+              </a:tr>
+              <a:tr h="237744">
+                <a:tc>
+                  <a:txBody>
+                    <a:bodyPr wrap="square"/>
+                    <a:lstStyle/>
+                    <a:p>
+                      <a:r>
+                        <a:rPr sz="900" b="1">
+                          <a:solidFill>
+                            <a:srgbClr val="314359"/>
+                          </a:solidFill>
+                          <a:latin typeface="Arial"/>
+                        </a:rPr>
+                        <a:t>Discount control</a:t>
+                      </a:r>
+                    </a:p>
+                  </a:txBody>
+                  <a:tcPr marL="64008" marR="82296" marT="32004" marB="32004" anchor="t">
+                    <a:solidFill>
+                      <a:srgbClr val="FFFFFF"/>
+                    </a:solidFill>
+                  </a:tcPr>
+                </a:tc>
+                <a:tc>
+                  <a:txBody>
+                    <a:bodyPr wrap="square"/>
+                    <a:lstStyle/>
+                    <a:p>
+                      <a:r>
+                        <a:rPr sz="869" b="0">
+                          <a:solidFill>
+                            <a:srgbClr val="0E1620"/>
+                          </a:solidFill>
+                          <a:latin typeface="Arial"/>
+                        </a:rPr>
+                        <a:t>The trust buys back shares when they trade more than 10% below NAV, measured on a 10-day VWAP.</a:t>
+                      </a:r>
+                    </a:p>
+                  </a:txBody>
+                  <a:tcPr marL="64008" marR="82296" marT="32004" marB="32004" anchor="t">
+                    <a:solidFill>
+                      <a:srgbClr val="FFFFFF"/>
+                    </a:solidFill>
+                  </a:tcPr>
+                </a:tc>
+              </a:tr>
+              <a:tr h="237744">
+                <a:tc>
+                  <a:txBody>
+                    <a:bodyPr wrap="square"/>
+                    <a:lstStyle/>
+                    <a:p>
+                      <a:r>
+                        <a:rPr sz="900" b="1">
+                          <a:solidFill>
+                            <a:srgbClr val="314359"/>
+                          </a:solidFill>
+                          <a:latin typeface="Arial"/>
+                        </a:rPr>
+                        <a:t>Launch costs</a:t>
+                      </a:r>
+                    </a:p>
+                  </a:txBody>
+                  <a:tcPr marL="64008" marR="82296" marT="32004" marB="32004" anchor="t">
+                    <a:solidFill>
+                      <a:srgbClr val="F4F6F8"/>
+                    </a:solidFill>
+                  </a:tcPr>
+                </a:tc>
+                <a:tc>
+                  <a:txBody>
+                    <a:bodyPr wrap="square"/>
+                    <a:lstStyle/>
+                    <a:p>
+                      <a:r>
+                        <a:rPr sz="869" b="0">
+                          <a:solidFill>
+                            <a:srgbClr val="0E1620"/>
+                          </a:solidFill>
+                          <a:latin typeface="Arial"/>
+                        </a:rPr>
+                        <a:t>Borne by the trust, partially offset by AIP's subscription for the initial shares.</a:t>
+                      </a:r>
+                    </a:p>
+                  </a:txBody>
+                  <a:tcPr marL="64008" marR="82296" marT="32004" marB="32004" anchor="t">
+                    <a:solidFill>
+                      <a:srgbClr val="F4F6F8"/>
+                    </a:solidFill>
+                  </a:tcPr>
+                </a:tc>
+              </a:tr>
+            </a:tbl>
+          </a:graphicData>
+        </a:graphic>
+      </p:graphicFrame>
+    </p:spTree>
+  </p:cSld>
+  <p:clrMapOvr>
+    <a:masterClrMapping/>
+  </p:clrMapOvr>
+</p:sld>
+</file>
+
+<file path=ppt/slides/slide23.xml><?xml version="1.0" encoding="utf-8"?>
+<p:sld xmlns:a="http://schemas.openxmlformats.org/drawingml/2006/main" xmlns:p="http://schemas.openxmlformats.org/presentationml/2006/main" xmlns:r="http://schemas.openxmlformats.org/officeDocument/2006/relationships">
+  <p:cSld>
+    <p:spTree>
+      <p:nvGrpSpPr>
+        <p:cNvPr id="1" name=""/>
+        <p:cNvGrpSpPr/>
+        <p:nvPr/>
+      </p:nvGrpSpPr>
+      <p:grpSpPr/>
+      <p:sp>
+        <p:nvSpPr>
+          <p:cNvPr id="2" name="Rectangle 1"/>
           <p:cNvSpPr/>
           <p:nvPr/>
         </p:nvSpPr>
         <p:spPr>
           <a:xfrm>
-            <a:off x="5230368" y="2240280"/>
-            <a:ext cx="10972" cy="4069080"/>
+            <a:off x="0" y="0"/>
+            <a:ext cx="9753600" cy="7315200"/>
           </a:xfrm>
           <a:prstGeom prst="rect">
             <a:avLst/>
           </a:prstGeom>
           <a:solidFill>
-            <a:srgbClr val="DDE1E7"/>
+            <a:srgbClr val="FFFFFF"/>
           </a:solidFill>
           <a:ln>
             <a:noFill/>
@@ -24738,19 +25203,835 @@
           <a:lstStyle/>
           <a:p>
             <a:pPr algn="ctr"/>
-          </a:p>
-        </p:txBody>
-      </p:sp>
-      <p:sp>
-        <p:nvSpPr>
-          <p:cNvPr id="13" name="TextBox 12"/>
+            <a:endParaRPr/>
+          </a:p>
+        </p:txBody>
+      </p:sp>
+      <p:pic>
+        <p:nvPicPr>
+          <p:cNvPr id="3" name="Picture 2" descr="mark_dark.png"/>
+          <p:cNvPicPr>
+            <a:picLocks noChangeAspect="1"/>
+          </p:cNvPicPr>
+          <p:nvPr/>
+        </p:nvPicPr>
+        <p:blipFill>
+          <a:blip r:embed="rId2"/>
+          <a:stretch>
+            <a:fillRect/>
+          </a:stretch>
+        </p:blipFill>
+        <p:spPr>
+          <a:xfrm>
+            <a:off x="402346" y="234086"/>
+            <a:ext cx="224012" cy="190199"/>
+          </a:xfrm>
+          <a:prstGeom prst="rect">
+            <a:avLst/>
+          </a:prstGeom>
+        </p:spPr>
+      </p:pic>
+      <p:sp>
+        <p:nvSpPr>
+          <p:cNvPr id="4" name="TextBox 3"/>
           <p:cNvSpPr txBox="1"/>
           <p:nvPr/>
         </p:nvSpPr>
         <p:spPr>
           <a:xfrm>
-            <a:off x="512064" y="2578608"/>
-            <a:ext cx="4590288" cy="3749039"/>
+            <a:off x="716907" y="263347"/>
+            <a:ext cx="5120768" cy="292608"/>
+          </a:xfrm>
+          <a:prstGeom prst="rect">
+            <a:avLst/>
+          </a:prstGeom>
+          <a:noFill/>
+        </p:spPr>
+        <p:txBody>
+          <a:bodyPr wrap="square" lIns="0" tIns="0" rIns="0" bIns="0" anchor="t">
+            <a:spAutoFit/>
+          </a:bodyPr>
+          <a:lstStyle/>
+          <a:p>
+            <a:pPr algn="l">
+              <a:lnSpc>
+                <a:spcPct val="110000"/>
+              </a:lnSpc>
+              <a:spcAft>
+                <a:spcPts val="0"/>
+              </a:spcAft>
+            </a:pPr>
+            <a:r>
+              <a:rPr sz="880" b="0" i="0">
+                <a:solidFill>
+                  <a:srgbClr val="556A83"/>
+                </a:solidFill>
+                <a:latin typeface="Arial"/>
+              </a:rPr>
+              <a:t>Proposed Terms</a:t>
+            </a:r>
+          </a:p>
+        </p:txBody>
+      </p:sp>
+      <p:sp>
+        <p:nvSpPr>
+          <p:cNvPr id="6" name="Rectangle 5"/>
+          <p:cNvSpPr/>
+          <p:nvPr/>
+        </p:nvSpPr>
+        <p:spPr>
+          <a:xfrm>
+            <a:off x="0" y="604723"/>
+            <a:ext cx="9753600" cy="1414272"/>
+          </a:xfrm>
+          <a:prstGeom prst="rect">
+            <a:avLst/>
+          </a:prstGeom>
+          <a:solidFill>
+            <a:srgbClr val="F6F7F9"/>
+          </a:solidFill>
+          <a:ln>
+            <a:noFill/>
+          </a:ln>
+          <a:effectLst/>
+        </p:spPr>
+        <p:style>
+          <a:lnRef idx="1">
+            <a:schemeClr val="accent1"/>
+          </a:lnRef>
+          <a:fillRef idx="3">
+            <a:schemeClr val="accent1"/>
+          </a:fillRef>
+          <a:effectRef idx="2">
+            <a:schemeClr val="accent1"/>
+          </a:effectRef>
+          <a:fontRef idx="minor">
+            <a:schemeClr val="lt1"/>
+          </a:fontRef>
+        </p:style>
+        <p:txBody>
+          <a:bodyPr rtlCol="0" anchor="ctr"/>
+          <a:lstStyle/>
+          <a:p>
+            <a:pPr algn="ctr"/>
+            <a:endParaRPr/>
+          </a:p>
+        </p:txBody>
+      </p:sp>
+      <p:sp>
+        <p:nvSpPr>
+          <p:cNvPr id="7" name="TextBox 6"/>
+          <p:cNvSpPr txBox="1"/>
+          <p:nvPr/>
+        </p:nvSpPr>
+        <p:spPr>
+          <a:xfrm>
+            <a:off x="438922" y="721766"/>
+            <a:ext cx="8851613" cy="829056"/>
+          </a:xfrm>
+          <a:prstGeom prst="rect">
+            <a:avLst/>
+          </a:prstGeom>
+          <a:noFill/>
+        </p:spPr>
+        <p:txBody>
+          <a:bodyPr wrap="square" lIns="0" tIns="0" rIns="0" bIns="0" anchor="t">
+            <a:spAutoFit/>
+          </a:bodyPr>
+          <a:lstStyle/>
+          <a:p>
+            <a:pPr algn="l">
+              <a:lnSpc>
+                <a:spcPct val="110000"/>
+              </a:lnSpc>
+              <a:spcAft>
+                <a:spcPts val="200"/>
+              </a:spcAft>
+            </a:pPr>
+            <a:r>
+              <a:rPr sz="2400" b="0" i="0" spc="-90">
+                <a:solidFill>
+                  <a:srgbClr val="314359"/>
+                </a:solidFill>
+                <a:latin typeface="Times New Roman"/>
+              </a:rPr>
+              <a:t>Indicative term sheet (continued)</a:t>
+            </a:r>
+          </a:p>
+        </p:txBody>
+      </p:sp>
+      <p:sp>
+        <p:nvSpPr>
+          <p:cNvPr id="8" name="TextBox 7"/>
+          <p:cNvSpPr txBox="1"/>
+          <p:nvPr/>
+        </p:nvSpPr>
+        <p:spPr>
+          <a:xfrm>
+            <a:off x="453553" y="1511808"/>
+            <a:ext cx="8705305" cy="487680"/>
+          </a:xfrm>
+          <a:prstGeom prst="rect">
+            <a:avLst/>
+          </a:prstGeom>
+          <a:noFill/>
+        </p:spPr>
+        <p:txBody>
+          <a:bodyPr wrap="square" lIns="0" tIns="0" rIns="0" bIns="0" anchor="t">
+            <a:spAutoFit/>
+          </a:bodyPr>
+          <a:lstStyle/>
+          <a:p>
+            <a:pPr algn="l">
+              <a:lnSpc>
+                <a:spcPct val="110000"/>
+              </a:lnSpc>
+              <a:spcAft>
+                <a:spcPts val="0"/>
+              </a:spcAft>
+            </a:pPr>
+            <a:r>
+              <a:rPr sz="1040" b="0" i="1">
+                <a:solidFill>
+                  <a:srgbClr val="556A83"/>
+                </a:solidFill>
+                <a:latin typeface="Arial"/>
+              </a:rPr>
+              <a:t>Gearing, governance, operations and service providers.  (2 of 2)</a:t>
+            </a:r>
+          </a:p>
+        </p:txBody>
+      </p:sp>
+      <p:sp>
+        <p:nvSpPr>
+          <p:cNvPr id="9" name="TextBox 8"/>
+          <p:cNvSpPr txBox="1"/>
+          <p:nvPr/>
+        </p:nvSpPr>
+        <p:spPr>
+          <a:xfrm>
+            <a:off x="6583844" y="6876288"/>
+            <a:ext cx="2926153" cy="292608"/>
+          </a:xfrm>
+          <a:prstGeom prst="rect">
+            <a:avLst/>
+          </a:prstGeom>
+          <a:noFill/>
+        </p:spPr>
+        <p:txBody>
+          <a:bodyPr wrap="square" lIns="0" tIns="0" rIns="0" bIns="0" anchor="t">
+            <a:spAutoFit/>
+          </a:bodyPr>
+          <a:lstStyle/>
+          <a:p>
+            <a:pPr algn="r">
+              <a:lnSpc>
+                <a:spcPct val="110000"/>
+              </a:lnSpc>
+              <a:spcAft>
+                <a:spcPts val="0"/>
+              </a:spcAft>
+            </a:pPr>
+            <a:r>
+              <a:rPr sz="680" b="0" i="0">
+                <a:solidFill>
+                  <a:srgbClr val="556A83"/>
+                </a:solidFill>
+                <a:latin typeface="Arial"/>
+              </a:rPr>
+              <a:t>Strictly confidential          23</a:t>
+            </a:r>
+          </a:p>
+        </p:txBody>
+      </p:sp>
+      <p:graphicFrame>
+        <p:nvGraphicFramePr>
+          <p:cNvPr id="10" name="Table 9"/>
+          <p:cNvGraphicFramePr>
+            <a:graphicFrameLocks noGrp="1"/>
+          </p:cNvGraphicFramePr>
+          <p:nvPr/>
+        </p:nvGraphicFramePr>
+        <p:xfrm>
+          <a:off x="512064" y="2139696"/>
+          <a:ext cx="8796527" cy="2852928"/>
+        </p:xfrm>
+        <a:graphic>
+          <a:graphicData uri="http://schemas.openxmlformats.org/drawingml/2006/table">
+            <a:tbl>
+              <a:tblPr>
+                <a:tableStyleId>{2D5ABB26-0587-4C30-8999-92F81FD0307C}</a:tableStyleId>
+              </a:tblPr>
+              <a:tblGrid>
+                <a:gridCol w="2331720"/>
+                <a:gridCol w="6464807"/>
+              </a:tblGrid>
+              <a:tr h="237744">
+                <a:tc>
+                  <a:txBody>
+                    <a:bodyPr wrap="square"/>
+                    <a:lstStyle/>
+                    <a:p>
+                      <a:r>
+                        <a:rPr sz="900" b="1">
+                          <a:solidFill>
+                            <a:srgbClr val="314359"/>
+                          </a:solidFill>
+                          <a:latin typeface="Arial"/>
+                        </a:rPr>
+                        <a:t>Gearing / borrowing policy</a:t>
+                      </a:r>
+                    </a:p>
+                  </a:txBody>
+                  <a:tcPr marL="64008" marR="82296" marT="32004" marB="32004" anchor="t">
+                    <a:solidFill>
+                      <a:srgbClr val="FFFFFF"/>
+                    </a:solidFill>
+                  </a:tcPr>
+                </a:tc>
+                <a:tc>
+                  <a:txBody>
+                    <a:bodyPr wrap="square"/>
+                    <a:lstStyle/>
+                    <a:p>
+                      <a:r>
+                        <a:rPr sz="869" b="0">
+                          <a:solidFill>
+                            <a:srgbClr val="0E1620"/>
+                          </a:solidFill>
+                          <a:latin typeface="Arial"/>
+                        </a:rPr>
+                        <a:t>No structural gearing for return. Short-term financing for operating-cost or working-capital shortfalls only, capped at 10% of NAV.</a:t>
+                      </a:r>
+                    </a:p>
+                  </a:txBody>
+                  <a:tcPr marL="64008" marR="82296" marT="32004" marB="32004" anchor="t">
+                    <a:solidFill>
+                      <a:srgbClr val="FFFFFF"/>
+                    </a:solidFill>
+                  </a:tcPr>
+                </a:tc>
+              </a:tr>
+              <a:tr h="237744">
+                <a:tc>
+                  <a:txBody>
+                    <a:bodyPr wrap="square"/>
+                    <a:lstStyle/>
+                    <a:p>
+                      <a:r>
+                        <a:rPr sz="900" b="1">
+                          <a:solidFill>
+                            <a:srgbClr val="314359"/>
+                          </a:solidFill>
+                          <a:latin typeface="Arial"/>
+                        </a:rPr>
+                        <a:t>Dividend &amp; distribution policy</a:t>
+                      </a:r>
+                    </a:p>
+                  </a:txBody>
+                  <a:tcPr marL="64008" marR="82296" marT="32004" marB="32004" anchor="t">
+                    <a:solidFill>
+                      <a:srgbClr val="F4F6F8"/>
+                    </a:solidFill>
+                  </a:tcPr>
+                </a:tc>
+                <a:tc>
+                  <a:txBody>
+                    <a:bodyPr wrap="square"/>
+                    <a:lstStyle/>
+                    <a:p>
+                      <a:r>
+                        <a:rPr sz="869" b="0">
+                          <a:solidFill>
+                            <a:srgbClr val="0E1620"/>
+                          </a:solidFill>
+                          <a:latin typeface="Arial"/>
+                        </a:rPr>
+                        <a:t>Managed for long-term total return; no regular dividend expected. Distributions limited to the minimum required to maintain s.1158 status.  [for confirmation]</a:t>
+                      </a:r>
+                    </a:p>
+                  </a:txBody>
+                  <a:tcPr marL="64008" marR="82296" marT="32004" marB="32004" anchor="t">
+                    <a:solidFill>
+                      <a:srgbClr val="F4F6F8"/>
+                    </a:solidFill>
+                  </a:tcPr>
+                </a:tc>
+              </a:tr>
+              <a:tr h="237744">
+                <a:tc>
+                  <a:txBody>
+                    <a:bodyPr wrap="square"/>
+                    <a:lstStyle/>
+                    <a:p>
+                      <a:r>
+                        <a:rPr sz="900" b="1">
+                          <a:solidFill>
+                            <a:srgbClr val="314359"/>
+                          </a:solidFill>
+                          <a:latin typeface="Arial"/>
+                        </a:rPr>
+                        <a:t>NAV calculation &amp; valuation policy</a:t>
+                      </a:r>
+                    </a:p>
+                  </a:txBody>
+                  <a:tcPr marL="64008" marR="82296" marT="32004" marB="32004" anchor="t">
+                    <a:solidFill>
+                      <a:srgbClr val="FFFFFF"/>
+                    </a:solidFill>
+                  </a:tcPr>
+                </a:tc>
+                <a:tc>
+                  <a:txBody>
+                    <a:bodyPr wrap="square"/>
+                    <a:lstStyle/>
+                    <a:p>
+                      <a:r>
+                        <a:rPr sz="869" b="0">
+                          <a:solidFill>
+                            <a:srgbClr val="0E1620"/>
+                          </a:solidFill>
+                          <a:latin typeface="Arial"/>
+                        </a:rPr>
+                        <a:t>Based on AIPII's NAV as struck by its administrator, MUFG.</a:t>
+                      </a:r>
+                    </a:p>
+                  </a:txBody>
+                  <a:tcPr marL="64008" marR="82296" marT="32004" marB="32004" anchor="t">
+                    <a:solidFill>
+                      <a:srgbClr val="FFFFFF"/>
+                    </a:solidFill>
+                  </a:tcPr>
+                </a:tc>
+              </a:tr>
+              <a:tr h="237744">
+                <a:tc>
+                  <a:txBody>
+                    <a:bodyPr wrap="square"/>
+                    <a:lstStyle/>
+                    <a:p>
+                      <a:r>
+                        <a:rPr sz="900" b="1">
+                          <a:solidFill>
+                            <a:srgbClr val="314359"/>
+                          </a:solidFill>
+                          <a:latin typeface="Arial"/>
+                        </a:rPr>
+                        <a:t>Continuation vote / life of the company</a:t>
+                      </a:r>
+                    </a:p>
+                  </a:txBody>
+                  <a:tcPr marL="64008" marR="82296" marT="32004" marB="32004" anchor="t">
+                    <a:solidFill>
+                      <a:srgbClr val="F4F6F8"/>
+                    </a:solidFill>
+                  </a:tcPr>
+                </a:tc>
+                <a:tc>
+                  <a:txBody>
+                    <a:bodyPr wrap="square"/>
+                    <a:lstStyle/>
+                    <a:p>
+                      <a:r>
+                        <a:rPr sz="869" b="0">
+                          <a:solidFill>
+                            <a:srgbClr val="0E1620"/>
+                          </a:solidFill>
+                          <a:latin typeface="Arial"/>
+                        </a:rPr>
+                        <a:t>Continues until shareholders vote to discontinue; on discontinuation, AIP's special share converts automatically.</a:t>
+                      </a:r>
+                    </a:p>
+                  </a:txBody>
+                  <a:tcPr marL="64008" marR="82296" marT="32004" marB="32004" anchor="t">
+                    <a:solidFill>
+                      <a:srgbClr val="F4F6F8"/>
+                    </a:solidFill>
+                  </a:tcPr>
+                </a:tc>
+              </a:tr>
+              <a:tr h="237744">
+                <a:tc>
+                  <a:txBody>
+                    <a:bodyPr wrap="square"/>
+                    <a:lstStyle/>
+                    <a:p>
+                      <a:r>
+                        <a:rPr sz="900" b="1">
+                          <a:solidFill>
+                            <a:srgbClr val="314359"/>
+                          </a:solidFill>
+                          <a:latin typeface="Arial"/>
+                        </a:rPr>
+                        <a:t>Board composition &amp; corporate governance</a:t>
+                      </a:r>
+                    </a:p>
+                  </a:txBody>
+                  <a:tcPr marL="64008" marR="82296" marT="32004" marB="32004" anchor="t">
+                    <a:solidFill>
+                      <a:srgbClr val="FFFFFF"/>
+                    </a:solidFill>
+                  </a:tcPr>
+                </a:tc>
+                <a:tc>
+                  <a:txBody>
+                    <a:bodyPr wrap="square"/>
+                    <a:lstStyle/>
+                    <a:p>
+                      <a:r>
+                        <a:rPr sz="869" b="0">
+                          <a:solidFill>
+                            <a:srgbClr val="0E1620"/>
+                          </a:solidFill>
+                          <a:latin typeface="Arial"/>
+                        </a:rPr>
+                        <a:t>At least four independent non-executive directors plus one AIP management representative; UK Corporate Governance / AIC Code.</a:t>
+                      </a:r>
+                    </a:p>
+                  </a:txBody>
+                  <a:tcPr marL="64008" marR="82296" marT="32004" marB="32004" anchor="t">
+                    <a:solidFill>
+                      <a:srgbClr val="FFFFFF"/>
+                    </a:solidFill>
+                  </a:tcPr>
+                </a:tc>
+              </a:tr>
+              <a:tr h="237744">
+                <a:tc>
+                  <a:txBody>
+                    <a:bodyPr wrap="square"/>
+                    <a:lstStyle/>
+                    <a:p>
+                      <a:r>
+                        <a:rPr sz="900" b="1">
+                          <a:solidFill>
+                            <a:srgbClr val="314359"/>
+                          </a:solidFill>
+                          <a:latin typeface="Arial"/>
+                        </a:rPr>
+                        <a:t>Conflicts of interest &amp; related-party dealing</a:t>
+                      </a:r>
+                    </a:p>
+                  </a:txBody>
+                  <a:tcPr marL="64008" marR="82296" marT="32004" marB="32004" anchor="t">
+                    <a:solidFill>
+                      <a:srgbClr val="F4F6F8"/>
+                    </a:solidFill>
+                  </a:tcPr>
+                </a:tc>
+                <a:tc>
+                  <a:txBody>
+                    <a:bodyPr wrap="square"/>
+                    <a:lstStyle/>
+                    <a:p>
+                      <a:r>
+                        <a:rPr sz="869" b="0">
+                          <a:solidFill>
+                            <a:srgbClr val="0E1620"/>
+                          </a:solidFill>
+                          <a:latin typeface="Arial"/>
+                        </a:rPr>
+                        <a:t>All exposure is held through AIPII to minimise conflicts; residual matters governed by a formal conflicts-of-interest framework.</a:t>
+                      </a:r>
+                    </a:p>
+                  </a:txBody>
+                  <a:tcPr marL="64008" marR="82296" marT="32004" marB="32004" anchor="t">
+                    <a:solidFill>
+                      <a:srgbClr val="F4F6F8"/>
+                    </a:solidFill>
+                  </a:tcPr>
+                </a:tc>
+              </a:tr>
+              <a:tr h="237744">
+                <a:tc>
+                  <a:txBody>
+                    <a:bodyPr wrap="square"/>
+                    <a:lstStyle/>
+                    <a:p>
+                      <a:r>
+                        <a:rPr sz="900" b="1">
+                          <a:solidFill>
+                            <a:srgbClr val="314359"/>
+                          </a:solidFill>
+                          <a:latin typeface="Arial"/>
+                        </a:rPr>
+                        <a:t>Depositary, administrator &amp; registrar</a:t>
+                      </a:r>
+                    </a:p>
+                  </a:txBody>
+                  <a:tcPr marL="64008" marR="82296" marT="32004" marB="32004" anchor="t">
+                    <a:solidFill>
+                      <a:srgbClr val="FFFFFF"/>
+                    </a:solidFill>
+                  </a:tcPr>
+                </a:tc>
+                <a:tc>
+                  <a:txBody>
+                    <a:bodyPr wrap="square"/>
+                    <a:lstStyle/>
+                    <a:p>
+                      <a:r>
+                        <a:rPr sz="869" b="0">
+                          <a:solidFill>
+                            <a:srgbClr val="0E1620"/>
+                          </a:solidFill>
+                          <a:latin typeface="Arial"/>
+                        </a:rPr>
+                        <a:t>To be confirmed.</a:t>
+                      </a:r>
+                    </a:p>
+                  </a:txBody>
+                  <a:tcPr marL="64008" marR="82296" marT="32004" marB="32004" anchor="t">
+                    <a:solidFill>
+                      <a:srgbClr val="FFFFFF"/>
+                    </a:solidFill>
+                  </a:tcPr>
+                </a:tc>
+              </a:tr>
+              <a:tr h="237744">
+                <a:tc>
+                  <a:txBody>
+                    <a:bodyPr wrap="square"/>
+                    <a:lstStyle/>
+                    <a:p>
+                      <a:r>
+                        <a:rPr sz="900" b="1">
+                          <a:solidFill>
+                            <a:srgbClr val="314359"/>
+                          </a:solidFill>
+                          <a:latin typeface="Arial"/>
+                        </a:rPr>
+                        <a:t>Auditor &amp; corporate broker</a:t>
+                      </a:r>
+                    </a:p>
+                  </a:txBody>
+                  <a:tcPr marL="64008" marR="82296" marT="32004" marB="32004" anchor="t">
+                    <a:solidFill>
+                      <a:srgbClr val="F4F6F8"/>
+                    </a:solidFill>
+                  </a:tcPr>
+                </a:tc>
+                <a:tc>
+                  <a:txBody>
+                    <a:bodyPr wrap="square"/>
+                    <a:lstStyle/>
+                    <a:p>
+                      <a:r>
+                        <a:rPr sz="869" b="0">
+                          <a:solidFill>
+                            <a:srgbClr val="0E1620"/>
+                          </a:solidFill>
+                          <a:latin typeface="Arial"/>
+                        </a:rPr>
+                        <a:t>To be confirmed.</a:t>
+                      </a:r>
+                    </a:p>
+                  </a:txBody>
+                  <a:tcPr marL="64008" marR="82296" marT="32004" marB="32004" anchor="t">
+                    <a:solidFill>
+                      <a:srgbClr val="F4F6F8"/>
+                    </a:solidFill>
+                  </a:tcPr>
+                </a:tc>
+              </a:tr>
+              <a:tr h="237744">
+                <a:tc>
+                  <a:txBody>
+                    <a:bodyPr wrap="square"/>
+                    <a:lstStyle/>
+                    <a:p>
+                      <a:r>
+                        <a:rPr sz="900" b="1">
+                          <a:solidFill>
+                            <a:srgbClr val="314359"/>
+                          </a:solidFill>
+                          <a:latin typeface="Arial"/>
+                        </a:rPr>
+                        <a:t>Lock-up &amp; orderly-market arrangements</a:t>
+                      </a:r>
+                    </a:p>
+                  </a:txBody>
+                  <a:tcPr marL="64008" marR="82296" marT="32004" marB="32004" anchor="t">
+                    <a:solidFill>
+                      <a:srgbClr val="FFFFFF"/>
+                    </a:solidFill>
+                  </a:tcPr>
+                </a:tc>
+                <a:tc>
+                  <a:txBody>
+                    <a:bodyPr wrap="square"/>
+                    <a:lstStyle/>
+                    <a:p>
+                      <a:r>
+                        <a:rPr sz="869" b="0">
+                          <a:solidFill>
+                            <a:srgbClr val="0E1620"/>
+                          </a:solidFill>
+                          <a:latin typeface="Arial"/>
+                        </a:rPr>
+                        <a:t>To be confirmed.</a:t>
+                      </a:r>
+                    </a:p>
+                  </a:txBody>
+                  <a:tcPr marL="64008" marR="82296" marT="32004" marB="32004" anchor="t">
+                    <a:solidFill>
+                      <a:srgbClr val="FFFFFF"/>
+                    </a:solidFill>
+                  </a:tcPr>
+                </a:tc>
+              </a:tr>
+              <a:tr h="237744">
+                <a:tc>
+                  <a:txBody>
+                    <a:bodyPr wrap="square"/>
+                    <a:lstStyle/>
+                    <a:p>
+                      <a:r>
+                        <a:rPr sz="900" b="1">
+                          <a:solidFill>
+                            <a:srgbClr val="314359"/>
+                          </a:solidFill>
+                          <a:latin typeface="Arial"/>
+                        </a:rPr>
+                        <a:t>ISA / SIPP eligibility</a:t>
+                      </a:r>
+                    </a:p>
+                  </a:txBody>
+                  <a:tcPr marL="64008" marR="82296" marT="32004" marB="32004" anchor="t">
+                    <a:solidFill>
+                      <a:srgbClr val="F4F6F8"/>
+                    </a:solidFill>
+                  </a:tcPr>
+                </a:tc>
+                <a:tc>
+                  <a:txBody>
+                    <a:bodyPr wrap="square"/>
+                    <a:lstStyle/>
+                    <a:p>
+                      <a:r>
+                        <a:rPr sz="869" b="0">
+                          <a:solidFill>
+                            <a:srgbClr val="0E1620"/>
+                          </a:solidFill>
+                          <a:latin typeface="Arial"/>
+                        </a:rPr>
+                        <a:t>To be confirmed (expected eligible).</a:t>
+                      </a:r>
+                    </a:p>
+                  </a:txBody>
+                  <a:tcPr marL="64008" marR="82296" marT="32004" marB="32004" anchor="t">
+                    <a:solidFill>
+                      <a:srgbClr val="F4F6F8"/>
+                    </a:solidFill>
+                  </a:tcPr>
+                </a:tc>
+              </a:tr>
+              <a:tr h="237744">
+                <a:tc>
+                  <a:txBody>
+                    <a:bodyPr wrap="square"/>
+                    <a:lstStyle/>
+                    <a:p>
+                      <a:r>
+                        <a:rPr sz="900" b="1">
+                          <a:solidFill>
+                            <a:srgbClr val="314359"/>
+                          </a:solidFill>
+                          <a:latin typeface="Arial"/>
+                        </a:rPr>
+                        <a:t>Reporting &amp; financial calendar</a:t>
+                      </a:r>
+                    </a:p>
+                  </a:txBody>
+                  <a:tcPr marL="64008" marR="82296" marT="32004" marB="32004" anchor="t">
+                    <a:solidFill>
+                      <a:srgbClr val="FFFFFF"/>
+                    </a:solidFill>
+                  </a:tcPr>
+                </a:tc>
+                <a:tc>
+                  <a:txBody>
+                    <a:bodyPr wrap="square"/>
+                    <a:lstStyle/>
+                    <a:p>
+                      <a:r>
+                        <a:rPr sz="869" b="0">
+                          <a:solidFill>
+                            <a:srgbClr val="0E1620"/>
+                          </a:solidFill>
+                          <a:latin typeface="Arial"/>
+                        </a:rPr>
+                        <a:t>To be confirmed.</a:t>
+                      </a:r>
+                    </a:p>
+                  </a:txBody>
+                  <a:tcPr marL="64008" marR="82296" marT="32004" marB="32004" anchor="t">
+                    <a:solidFill>
+                      <a:srgbClr val="FFFFFF"/>
+                    </a:solidFill>
+                  </a:tcPr>
+                </a:tc>
+              </a:tr>
+              <a:tr h="237744">
+                <a:tc>
+                  <a:txBody>
+                    <a:bodyPr wrap="square"/>
+                    <a:lstStyle/>
+                    <a:p>
+                      <a:r>
+                        <a:rPr sz="900" b="1">
+                          <a:solidFill>
+                            <a:srgbClr val="314359"/>
+                          </a:solidFill>
+                          <a:latin typeface="Arial"/>
+                        </a:rPr>
+                        <a:t>Ticker, ISIN &amp; SEDOL</a:t>
+                      </a:r>
+                    </a:p>
+                  </a:txBody>
+                  <a:tcPr marL="64008" marR="82296" marT="32004" marB="32004" anchor="t">
+                    <a:solidFill>
+                      <a:srgbClr val="F4F6F8"/>
+                    </a:solidFill>
+                  </a:tcPr>
+                </a:tc>
+                <a:tc>
+                  <a:txBody>
+                    <a:bodyPr wrap="square"/>
+                    <a:lstStyle/>
+                    <a:p>
+                      <a:r>
+                        <a:rPr sz="869" b="0">
+                          <a:solidFill>
+                            <a:srgbClr val="0E1620"/>
+                          </a:solidFill>
+                          <a:latin typeface="Arial"/>
+                        </a:rPr>
+                        <a:t>To be confirmed.</a:t>
+                      </a:r>
+                    </a:p>
+                  </a:txBody>
+                  <a:tcPr marL="64008" marR="82296" marT="32004" marB="32004" anchor="t">
+                    <a:solidFill>
+                      <a:srgbClr val="F4F6F8"/>
+                    </a:solidFill>
+                  </a:tcPr>
+                </a:tc>
+              </a:tr>
+            </a:tbl>
+          </a:graphicData>
+        </a:graphic>
+      </p:graphicFrame>
+      <p:sp>
+        <p:nvSpPr>
+          <p:cNvPr id="11" name="TextBox 10"/>
+          <p:cNvSpPr txBox="1"/>
+          <p:nvPr/>
+        </p:nvSpPr>
+        <p:spPr>
+          <a:xfrm>
+            <a:off x="512064" y="6455664"/>
+            <a:ext cx="8778240" cy="365760"/>
           </a:xfrm>
           <a:prstGeom prst="rect">
             <a:avLst/>
@@ -24763,680 +26044,14 @@
           </a:bodyPr>
           <a:lstStyle/>
           <a:p>
-            <a:pPr>
-              <a:spcAft>
-                <a:spcPts val="700"/>
-              </a:spcAft>
-            </a:pPr>
-            <a:r>
-              <a:rPr sz="1050" b="1">
-                <a:solidFill>
-                  <a:srgbClr val="314359"/>
-                </a:solidFill>
-                <a:latin typeface="Arial"/>
-              </a:rPr>
-              <a:t>›  </a:t>
-            </a:r>
-            <a:r>
-              <a:rPr sz="1050" b="1">
-                <a:solidFill>
-                  <a:srgbClr val="314359"/>
-                </a:solidFill>
-                <a:latin typeface="Arial"/>
-              </a:rPr>
-              <a:t>Size.  </a:t>
-            </a:r>
-            <a:r>
-              <a:rPr sz="1050" b="0">
-                <a:solidFill>
-                  <a:srgbClr val="0E1620"/>
-                </a:solidFill>
-                <a:latin typeface="Arial"/>
-              </a:rPr>
-              <a:t>Minimum £1bn raised at IPO — the scale needed to run the operating-cost model and take meaningful, board-level stakes across the mid-market.</a:t>
-            </a:r>
-          </a:p>
-          <a:p>
-            <a:pPr>
-              <a:spcAft>
-                <a:spcPts val="700"/>
-              </a:spcAft>
-            </a:pPr>
-            <a:r>
-              <a:rPr sz="1050" b="1">
-                <a:solidFill>
-                  <a:srgbClr val="314359"/>
-                </a:solidFill>
-                <a:latin typeface="Arial"/>
-              </a:rPr>
-              <a:t>›  </a:t>
-            </a:r>
-            <a:r>
-              <a:rPr sz="1050" b="1">
-                <a:solidFill>
-                  <a:srgbClr val="314359"/>
-                </a:solidFill>
-                <a:latin typeface="Arial"/>
-              </a:rPr>
-              <a:t>Operating costs, not a fee on assets.  </a:t>
-            </a:r>
-            <a:r>
-              <a:rPr sz="1050" b="0">
-                <a:solidFill>
-                  <a:srgbClr val="0E1620"/>
-                </a:solidFill>
-                <a:latin typeface="Arial"/>
-              </a:rPr>
-              <a:t>The manager is reimbursed a capped operating-cost budget rather than an ad valorem management fee on AUM; the cost base falls as a share of NAV as the trust grows.</a:t>
-            </a:r>
-          </a:p>
-          <a:p>
-            <a:pPr>
-              <a:spcAft>
-                <a:spcPts val="700"/>
-              </a:spcAft>
-            </a:pPr>
-            <a:r>
-              <a:rPr sz="1050" b="1">
-                <a:solidFill>
-                  <a:srgbClr val="314359"/>
-                </a:solidFill>
-                <a:latin typeface="Arial"/>
-              </a:rPr>
-              <a:t>›  </a:t>
-            </a:r>
-            <a:r>
-              <a:rPr sz="1050" b="1">
-                <a:solidFill>
-                  <a:srgbClr val="314359"/>
-                </a:solidFill>
-                <a:latin typeface="Arial"/>
-              </a:rPr>
-              <a:t>Manager incentive — conversion share.  </a:t>
-            </a:r>
-            <a:r>
-              <a:rPr sz="1050" b="0">
-                <a:solidFill>
-                  <a:srgbClr val="0E1620"/>
-                </a:solidFill>
-                <a:latin typeface="Arial"/>
-              </a:rPr>
-              <a:t>AIP subscribes for a special share carrying no economic rights that converts into economic rights only once NAV per share reaches 2.5× its initial value — aligning the manager to absolute, compounding growth, not assets gathered.</a:t>
-            </a:r>
-          </a:p>
-          <a:p>
-            <a:pPr>
-              <a:spcAft>
-                <a:spcPts val="700"/>
-              </a:spcAft>
-            </a:pPr>
-            <a:r>
-              <a:rPr sz="1050" b="1">
-                <a:solidFill>
-                  <a:srgbClr val="314359"/>
-                </a:solidFill>
-                <a:latin typeface="Arial"/>
-              </a:rPr>
-              <a:t>›  </a:t>
-            </a:r>
-            <a:r>
-              <a:rPr sz="1050" b="1">
-                <a:solidFill>
-                  <a:srgbClr val="314359"/>
-                </a:solidFill>
-                <a:latin typeface="Arial"/>
-              </a:rPr>
-              <a:t>Discount control.  </a:t>
-            </a:r>
-            <a:r>
-              <a:rPr sz="1050" b="0">
-                <a:solidFill>
-                  <a:srgbClr val="0E1620"/>
-                </a:solidFill>
-                <a:latin typeface="Arial"/>
-              </a:rPr>
-              <a:t>The trust buys back shares whenever they trade more than 10% below NAV, measured on a 10-day VWAP — a hard, rules-based discount-management mechanism.</a:t>
-            </a:r>
-          </a:p>
-          <a:p>
-            <a:pPr>
-              <a:spcAft>
-                <a:spcPts val="700"/>
-              </a:spcAft>
-            </a:pPr>
-            <a:r>
-              <a:rPr sz="1050" b="1">
-                <a:solidFill>
-                  <a:srgbClr val="314359"/>
-                </a:solidFill>
-                <a:latin typeface="Arial"/>
-              </a:rPr>
-              <a:t>›  </a:t>
-            </a:r>
-            <a:r>
-              <a:rPr sz="1050" b="1">
-                <a:solidFill>
-                  <a:srgbClr val="314359"/>
-                </a:solidFill>
-                <a:latin typeface="Arial"/>
-              </a:rPr>
-              <a:t>Launch costs.  </a:t>
-            </a:r>
-            <a:r>
-              <a:rPr sz="1050" b="0">
-                <a:solidFill>
-                  <a:srgbClr val="0E1620"/>
-                </a:solidFill>
-                <a:latin typeface="Arial"/>
-              </a:rPr>
-              <a:t>The trust bears IPO and set-up costs, partially offset by AIP's subscription for the initial shares — manager capital at risk from day one.</a:t>
-            </a:r>
-          </a:p>
-        </p:txBody>
-      </p:sp>
-      <p:sp>
-        <p:nvSpPr>
-          <p:cNvPr id="14" name="TextBox 13"/>
-          <p:cNvSpPr txBox="1"/>
-          <p:nvPr/>
-        </p:nvSpPr>
-        <p:spPr>
-          <a:xfrm>
-            <a:off x="5440680" y="2578608"/>
-            <a:ext cx="3886200" cy="3749039"/>
-          </a:xfrm>
-          <a:prstGeom prst="rect">
-            <a:avLst/>
-          </a:prstGeom>
-          <a:noFill/>
-        </p:spPr>
-        <p:txBody>
-          <a:bodyPr wrap="square" lIns="0" rIns="0" tIns="0" bIns="0">
-            <a:spAutoFit/>
-          </a:bodyPr>
-          <a:lstStyle/>
-          <a:p>
-            <a:pPr>
-              <a:spcAft>
-                <a:spcPts val="440"/>
-              </a:spcAft>
-            </a:pPr>
-            <a:r>
-              <a:rPr sz="919" b="1">
-                <a:solidFill>
-                  <a:srgbClr val="556A83"/>
-                </a:solidFill>
-                <a:latin typeface="Arial"/>
-              </a:rPr>
-              <a:t>·  </a:t>
-            </a:r>
-            <a:r>
-              <a:rPr sz="919" b="0">
-                <a:solidFill>
-                  <a:srgbClr val="0E1620"/>
-                </a:solidFill>
-                <a:latin typeface="Arial"/>
-              </a:rPr>
-              <a:t>Structure &amp; domicile — UK investment trust (plc), s.1158 status</a:t>
-            </a:r>
-          </a:p>
-          <a:p>
-            <a:pPr>
-              <a:spcAft>
-                <a:spcPts val="440"/>
-              </a:spcAft>
-            </a:pPr>
-            <a:r>
-              <a:rPr sz="919" b="1">
-                <a:solidFill>
-                  <a:srgbClr val="556A83"/>
-                </a:solidFill>
-                <a:latin typeface="Arial"/>
-              </a:rPr>
-              <a:t>·  </a:t>
-            </a:r>
-            <a:r>
-              <a:rPr sz="919" b="0">
-                <a:solidFill>
-                  <a:srgbClr val="0E1620"/>
-                </a:solidFill>
-                <a:latin typeface="Arial"/>
-              </a:rPr>
-              <a:t>Listing &amp; market — LSE Main Market, premium listing</a:t>
-            </a:r>
-          </a:p>
-          <a:p>
-            <a:pPr>
-              <a:spcAft>
-                <a:spcPts val="440"/>
-              </a:spcAft>
-            </a:pPr>
-            <a:r>
-              <a:rPr sz="919" b="1">
-                <a:solidFill>
-                  <a:srgbClr val="556A83"/>
-                </a:solidFill>
-                <a:latin typeface="Arial"/>
-              </a:rPr>
-              <a:t>·  </a:t>
-            </a:r>
-            <a:r>
-              <a:rPr sz="919" b="0">
-                <a:solidFill>
-                  <a:srgbClr val="0E1620"/>
-                </a:solidFill>
-                <a:latin typeface="Arial"/>
-              </a:rPr>
-              <a:t>Investment objective &amp; policy</a:t>
-            </a:r>
-          </a:p>
-          <a:p>
-            <a:pPr>
-              <a:spcAft>
-                <a:spcPts val="440"/>
-              </a:spcAft>
-            </a:pPr>
-            <a:r>
-              <a:rPr sz="919" b="1">
-                <a:solidFill>
-                  <a:srgbClr val="556A83"/>
-                </a:solidFill>
-                <a:latin typeface="Arial"/>
-              </a:rPr>
-              <a:t>·  </a:t>
-            </a:r>
-            <a:r>
-              <a:rPr sz="919" b="0">
-                <a:solidFill>
-                  <a:srgbClr val="0E1620"/>
-                </a:solidFill>
-                <a:latin typeface="Arial"/>
-              </a:rPr>
-              <a:t>Investment restrictions &amp; limits</a:t>
-            </a:r>
-          </a:p>
-          <a:p>
-            <a:pPr>
-              <a:spcAft>
-                <a:spcPts val="440"/>
-              </a:spcAft>
-            </a:pPr>
-            <a:r>
-              <a:rPr sz="919" b="1">
-                <a:solidFill>
-                  <a:srgbClr val="556A83"/>
-                </a:solidFill>
-                <a:latin typeface="Arial"/>
-              </a:rPr>
-              <a:t>·  </a:t>
-            </a:r>
-            <a:r>
-              <a:rPr sz="919" b="0">
-                <a:solidFill>
-                  <a:srgbClr val="0E1620"/>
-                </a:solidFill>
-                <a:latin typeface="Arial"/>
-              </a:rPr>
-              <a:t>AIFM, investment manager &amp; key persons</a:t>
-            </a:r>
-          </a:p>
-          <a:p>
-            <a:pPr>
-              <a:spcAft>
-                <a:spcPts val="440"/>
-              </a:spcAft>
-            </a:pPr>
-            <a:r>
-              <a:rPr sz="919" b="1">
-                <a:solidFill>
-                  <a:srgbClr val="556A83"/>
-                </a:solidFill>
-                <a:latin typeface="Arial"/>
-              </a:rPr>
-              <a:t>·  </a:t>
-            </a:r>
-            <a:r>
-              <a:rPr sz="919" b="0">
-                <a:solidFill>
-                  <a:srgbClr val="0E1620"/>
-                </a:solidFill>
-                <a:latin typeface="Arial"/>
-              </a:rPr>
-              <a:t>Gearing / borrowing policy</a:t>
-            </a:r>
-          </a:p>
-          <a:p>
-            <a:pPr>
-              <a:spcAft>
-                <a:spcPts val="440"/>
-              </a:spcAft>
-            </a:pPr>
-            <a:r>
-              <a:rPr sz="919" b="1">
-                <a:solidFill>
-                  <a:srgbClr val="556A83"/>
-                </a:solidFill>
-                <a:latin typeface="Arial"/>
-              </a:rPr>
-              <a:t>·  </a:t>
-            </a:r>
-            <a:r>
-              <a:rPr sz="919" b="0">
-                <a:solidFill>
-                  <a:srgbClr val="0E1620"/>
-                </a:solidFill>
-                <a:latin typeface="Arial"/>
-              </a:rPr>
-              <a:t>Dividend &amp; distribution policy</a:t>
-            </a:r>
-          </a:p>
-          <a:p>
-            <a:pPr>
-              <a:spcAft>
-                <a:spcPts val="440"/>
-              </a:spcAft>
-            </a:pPr>
-            <a:r>
-              <a:rPr sz="919" b="1">
-                <a:solidFill>
-                  <a:srgbClr val="556A83"/>
-                </a:solidFill>
-                <a:latin typeface="Arial"/>
-              </a:rPr>
-              <a:t>·  </a:t>
-            </a:r>
-            <a:r>
-              <a:rPr sz="919" b="0">
-                <a:solidFill>
-                  <a:srgbClr val="0E1620"/>
-                </a:solidFill>
-                <a:latin typeface="Arial"/>
-              </a:rPr>
-              <a:t>NAV calculation &amp; valuation policy</a:t>
-            </a:r>
-          </a:p>
-          <a:p>
-            <a:pPr>
-              <a:spcAft>
-                <a:spcPts val="440"/>
-              </a:spcAft>
-            </a:pPr>
-            <a:r>
-              <a:rPr sz="919" b="1">
-                <a:solidFill>
-                  <a:srgbClr val="556A83"/>
-                </a:solidFill>
-                <a:latin typeface="Arial"/>
-              </a:rPr>
-              <a:t>·  </a:t>
-            </a:r>
-            <a:r>
-              <a:rPr sz="919" b="0">
-                <a:solidFill>
-                  <a:srgbClr val="0E1620"/>
-                </a:solidFill>
-                <a:latin typeface="Arial"/>
-              </a:rPr>
-              <a:t>Continuation vote / life of the company</a:t>
-            </a:r>
-          </a:p>
-          <a:p>
-            <a:pPr>
-              <a:spcAft>
-                <a:spcPts val="440"/>
-              </a:spcAft>
-            </a:pPr>
-            <a:r>
-              <a:rPr sz="919" b="1">
-                <a:solidFill>
-                  <a:srgbClr val="556A83"/>
-                </a:solidFill>
-                <a:latin typeface="Arial"/>
-              </a:rPr>
-              <a:t>·  </a:t>
-            </a:r>
-            <a:r>
-              <a:rPr sz="919" b="0">
-                <a:solidFill>
-                  <a:srgbClr val="0E1620"/>
-                </a:solidFill>
-                <a:latin typeface="Arial"/>
-              </a:rPr>
-              <a:t>Board composition &amp; corporate governance</a:t>
-            </a:r>
-          </a:p>
-          <a:p>
-            <a:pPr>
-              <a:spcAft>
-                <a:spcPts val="440"/>
-              </a:spcAft>
-            </a:pPr>
-            <a:r>
-              <a:rPr sz="919" b="1">
-                <a:solidFill>
-                  <a:srgbClr val="556A83"/>
-                </a:solidFill>
-                <a:latin typeface="Arial"/>
-              </a:rPr>
-              <a:t>·  </a:t>
-            </a:r>
-            <a:r>
-              <a:rPr sz="919" b="0">
-                <a:solidFill>
-                  <a:srgbClr val="0E1620"/>
-                </a:solidFill>
-                <a:latin typeface="Arial"/>
-              </a:rPr>
-              <a:t>Conflicts of interest &amp; related-party dealing</a:t>
-            </a:r>
-          </a:p>
-          <a:p>
-            <a:pPr>
-              <a:spcAft>
-                <a:spcPts val="440"/>
-              </a:spcAft>
-            </a:pPr>
-            <a:r>
-              <a:rPr sz="919" b="1">
-                <a:solidFill>
-                  <a:srgbClr val="556A83"/>
-                </a:solidFill>
-                <a:latin typeface="Arial"/>
-              </a:rPr>
-              <a:t>·  </a:t>
-            </a:r>
-            <a:r>
-              <a:rPr sz="919" b="0">
-                <a:solidFill>
-                  <a:srgbClr val="0E1620"/>
-                </a:solidFill>
-                <a:latin typeface="Arial"/>
-              </a:rPr>
-              <a:t>Depositary, administrator &amp; registrar</a:t>
-            </a:r>
-          </a:p>
-          <a:p>
-            <a:pPr>
-              <a:spcAft>
-                <a:spcPts val="440"/>
-              </a:spcAft>
-            </a:pPr>
-            <a:r>
-              <a:rPr sz="919" b="1">
-                <a:solidFill>
-                  <a:srgbClr val="556A83"/>
-                </a:solidFill>
-                <a:latin typeface="Arial"/>
-              </a:rPr>
-              <a:t>·  </a:t>
-            </a:r>
-            <a:r>
-              <a:rPr sz="919" b="0">
-                <a:solidFill>
-                  <a:srgbClr val="0E1620"/>
-                </a:solidFill>
-                <a:latin typeface="Arial"/>
-              </a:rPr>
-              <a:t>Auditor &amp; corporate broker</a:t>
-            </a:r>
-          </a:p>
-          <a:p>
-            <a:pPr>
-              <a:spcAft>
-                <a:spcPts val="440"/>
-              </a:spcAft>
-            </a:pPr>
-            <a:r>
-              <a:rPr sz="919" b="1">
-                <a:solidFill>
-                  <a:srgbClr val="556A83"/>
-                </a:solidFill>
-                <a:latin typeface="Arial"/>
-              </a:rPr>
-              <a:t>·  </a:t>
-            </a:r>
-            <a:r>
-              <a:rPr sz="919" b="0">
-                <a:solidFill>
-                  <a:srgbClr val="0E1620"/>
-                </a:solidFill>
-                <a:latin typeface="Arial"/>
-              </a:rPr>
-              <a:t>Liquidity — tender offers / treasury shares</a:t>
-            </a:r>
-          </a:p>
-          <a:p>
-            <a:pPr>
-              <a:spcAft>
-                <a:spcPts val="440"/>
-              </a:spcAft>
-            </a:pPr>
-            <a:r>
-              <a:rPr sz="919" b="1">
-                <a:solidFill>
-                  <a:srgbClr val="556A83"/>
-                </a:solidFill>
-                <a:latin typeface="Arial"/>
-              </a:rPr>
-              <a:t>·  </a:t>
-            </a:r>
-            <a:r>
-              <a:rPr sz="919" b="0">
-                <a:solidFill>
-                  <a:srgbClr val="0E1620"/>
-                </a:solidFill>
-                <a:latin typeface="Arial"/>
-              </a:rPr>
-              <a:t>Lock-up &amp; orderly-market arrangements</a:t>
-            </a:r>
-          </a:p>
-          <a:p>
-            <a:pPr>
-              <a:spcAft>
-                <a:spcPts val="440"/>
-              </a:spcAft>
-            </a:pPr>
-            <a:r>
-              <a:rPr sz="919" b="1">
-                <a:solidFill>
-                  <a:srgbClr val="556A83"/>
-                </a:solidFill>
-                <a:latin typeface="Arial"/>
-              </a:rPr>
-              <a:t>·  </a:t>
-            </a:r>
-            <a:r>
-              <a:rPr sz="919" b="0">
-                <a:solidFill>
-                  <a:srgbClr val="0E1620"/>
-                </a:solidFill>
-                <a:latin typeface="Arial"/>
-              </a:rPr>
-              <a:t>ISA / SIPP eligibility</a:t>
-            </a:r>
-          </a:p>
-          <a:p>
-            <a:pPr>
-              <a:spcAft>
-                <a:spcPts val="440"/>
-              </a:spcAft>
-            </a:pPr>
-            <a:r>
-              <a:rPr sz="919" b="1">
-                <a:solidFill>
-                  <a:srgbClr val="556A83"/>
-                </a:solidFill>
-                <a:latin typeface="Arial"/>
-              </a:rPr>
-              <a:t>·  </a:t>
-            </a:r>
-            <a:r>
-              <a:rPr sz="919" b="0">
-                <a:solidFill>
-                  <a:srgbClr val="0E1620"/>
-                </a:solidFill>
-                <a:latin typeface="Arial"/>
-              </a:rPr>
-              <a:t>Reporting &amp; financial calendar</a:t>
-            </a:r>
-          </a:p>
-          <a:p>
-            <a:pPr>
-              <a:spcAft>
-                <a:spcPts val="440"/>
-              </a:spcAft>
-            </a:pPr>
-            <a:r>
-              <a:rPr sz="919" b="1">
-                <a:solidFill>
-                  <a:srgbClr val="556A83"/>
-                </a:solidFill>
-                <a:latin typeface="Arial"/>
-              </a:rPr>
-              <a:t>·  </a:t>
-            </a:r>
-            <a:r>
-              <a:rPr sz="919" b="0">
-                <a:solidFill>
-                  <a:srgbClr val="0E1620"/>
-                </a:solidFill>
-                <a:latin typeface="Arial"/>
-              </a:rPr>
-              <a:t>Ticker, ISIN &amp; SEDOL</a:t>
-            </a:r>
-          </a:p>
-        </p:txBody>
-      </p:sp>
-      <p:sp>
-        <p:nvSpPr>
-          <p:cNvPr id="15" name="TextBox 14"/>
-          <p:cNvSpPr txBox="1"/>
-          <p:nvPr/>
-        </p:nvSpPr>
-        <p:spPr>
-          <a:xfrm>
-            <a:off x="512064" y="6419088"/>
-            <a:ext cx="8778240" cy="365760"/>
-          </a:xfrm>
-          <a:prstGeom prst="rect">
-            <a:avLst/>
-          </a:prstGeom>
-          <a:noFill/>
-        </p:spPr>
-        <p:txBody>
-          <a:bodyPr wrap="square" lIns="0" rIns="0" tIns="0" bIns="0">
-            <a:spAutoFit/>
-          </a:bodyPr>
-          <a:lstStyle/>
-          <a:p>
-            <a:r>
-              <a:rPr sz="650" b="0">
+            <a:r>
+              <a:rPr sz="650">
                 <a:solidFill>
                   <a:srgbClr val="8A939F"/>
                 </a:solidFill>
                 <a:latin typeface="Arial"/>
               </a:rPr>
-              <a:t>Indicative and non-binding, for discussion only — subject to contract, satisfactory due diligence, regulatory approval and final documentation. Not an offer or invitation to invest.</a:t>
+              <a:t>Indicative and non-binding, for discussion only — subject to contract, satisfactory due diligence, regulatory approval and final documentation. Not an offer or invitation to invest. [TBC = to be confirmed.]</a:t>
             </a:r>
           </a:p>
         </p:txBody>

</xml_diff>

<commit_message>
Term sheet: incorporate structure clarifications
- Self-managed trust (board is the AIFM); no trust-level manager
- AIPII's assets managed by Athanase Industrial Partner Ltd (fund level)
- Costs: no AUM/fund fee; AIP holds special A shares + a flat operating
  fee (inflation-capped); trust's AIPII holding bears custodian/admin
  (<20bp); total charges capped ~50bp at listing, falling with NAV
- Added 'Underlying fund liquidity' row: AIPII quarterly redemptions,
  90 days' notice (funds buybacks and key-man exit)

https://claude.ai/code/session_01HRMxSvt6t94q3GFGUqavQe
</commit_message>
<xml_diff>
--- a/UK_Investment_Trust_Proposal.pptx
+++ b/UK_Investment_Trust_Proposal.pptx
@@ -24853,7 +24853,7 @@
                           </a:solidFill>
                           <a:latin typeface="Arial"/>
                         </a:rPr>
-                        <a:t>Long-term capital growth, investing substantially all assets in Athanase Industrial Partners Fund II (“AIPII”) via a dedicated, tax-efficient zero-fee share class [structure TBC]. AIPII invests globally in mid-sized companies with scope for operational improvement through engaged ownership.</a:t>
+                        <a:t>Long-term capital growth, investing substantially all assets in Athanase Industrial Partners Fund II (“AIPII”) through a zero-fee share class. AIPII invests globally in mid-sized companies with scope for operational improvement through engaged ownership.</a:t>
                       </a:r>
                     </a:p>
                   </a:txBody>
@@ -24923,7 +24923,7 @@
                           </a:solidFill>
                           <a:latin typeface="Arial"/>
                         </a:rPr>
-                        <a:t>AIFM, investment manager &amp; key persons</a:t>
+                        <a:t>AIFM, management &amp; key persons</a:t>
                       </a:r>
                     </a:p>
                   </a:txBody>
@@ -24945,7 +24945,7 @@
                           </a:solidFill>
                           <a:latin typeface="Arial"/>
                         </a:rPr>
-                        <a:t>AIPII's manager is Athanase Industrial Partner Ltd (Cayman Islands). Key man: Stefan Charette. On a key-man departure, the trust may redeem its AIPII holding and reinvest the proceeds.</a:t>
+                        <a:t>Self-managed: the board is the AIFM and makes the single allocation decision (hold AIPII); there is no trust-level investment manager. AIPII's assets are managed by Athanase Industrial Partner Ltd (Cayman Islands). Key man: Stefan Charette — on his departure the trust may redeem its AIPII units and reinvest the proceeds.</a:t>
                       </a:r>
                     </a:p>
                   </a:txBody>
@@ -24969,7 +24969,7 @@
                           </a:solidFill>
                           <a:latin typeface="Arial"/>
                         </a:rPr>
-                        <a:t>Operating costs (not a fee on assets)</a:t>
+                        <a:t>Costs — operating fee, not an AUM fee</a:t>
                       </a:r>
                     </a:p>
                   </a:txBody>
@@ -24991,7 +24991,7 @@
                           </a:solidFill>
                           <a:latin typeface="Arial"/>
                         </a:rPr>
-                        <a:t>Manager reimbursed a capped operating-cost budget; no ad valorem management fee on AUM. The cost base falls as a share of NAV as the trust grows.</a:t>
+                        <a:t>No management fee on AUM and no fee at the AIPII level. AIP (holder of the special A shares) receives a flat operating fee agreed at listing, rising by no more than inflation each year. The trust's AIPII holding bears custodian and administrator costs (typically under 20bp). Total ongoing charges are capped at ~50bp at listing and fall materially as NAV grows.</a:t>
                       </a:r>
                     </a:p>
                   </a:txBody>
@@ -25015,7 +25015,7 @@
                           </a:solidFill>
                           <a:latin typeface="Arial"/>
                         </a:rPr>
-                        <a:t>Manager incentive — conversion share</a:t>
+                        <a:t>Manager incentive — conversion A share</a:t>
                       </a:r>
                     </a:p>
                   </a:txBody>
@@ -25037,7 +25037,7 @@
                           </a:solidFill>
                           <a:latin typeface="Arial"/>
                         </a:rPr>
-                        <a:t>AIP subscribes for a special share with no economic rights that converts into economic rights only once NAV per share reaches 2.5× its initial value.</a:t>
+                        <a:t>AIP holds a special A share carrying no economic rights that converts into economic rights only once NAV per share reaches 2.5× its initial value — aligning reward to absolute, compounding growth, not assets gathered.</a:t>
                       </a:r>
                     </a:p>
                   </a:txBody>
@@ -25617,7 +25617,7 @@
                           </a:solidFill>
                           <a:latin typeface="Arial"/>
                         </a:rPr>
-                        <a:t>Continuation vote / life of the company</a:t>
+                        <a:t>Underlying fund liquidity</a:t>
                       </a:r>
                     </a:p>
                   </a:txBody>
@@ -25639,7 +25639,7 @@
                           </a:solidFill>
                           <a:latin typeface="Arial"/>
                         </a:rPr>
-                        <a:t>Continues until shareholders vote to discontinue; on discontinuation, AIP's special share converts automatically.</a:t>
+                        <a:t>AIPII offers quarterly redemptions on 90 days' notice — the source the trust draws on to fund buybacks and to exit on a key-man event. The trust itself remains closed-ended and listed.</a:t>
                       </a:r>
                     </a:p>
                   </a:txBody>
@@ -25663,7 +25663,7 @@
                           </a:solidFill>
                           <a:latin typeface="Arial"/>
                         </a:rPr>
-                        <a:t>Board composition &amp; corporate governance</a:t>
+                        <a:t>Continuation vote / life of the company</a:t>
                       </a:r>
                     </a:p>
                   </a:txBody>
@@ -25685,7 +25685,7 @@
                           </a:solidFill>
                           <a:latin typeface="Arial"/>
                         </a:rPr>
-                        <a:t>At least four independent non-executive directors plus one AIP management representative; UK Corporate Governance / AIC Code.</a:t>
+                        <a:t>Continues until shareholders vote to discontinue; on discontinuation, AIP's special share converts automatically.</a:t>
                       </a:r>
                     </a:p>
                   </a:txBody>
@@ -25709,7 +25709,7 @@
                           </a:solidFill>
                           <a:latin typeface="Arial"/>
                         </a:rPr>
-                        <a:t>Conflicts of interest &amp; related-party dealing</a:t>
+                        <a:t>Board composition &amp; corporate governance</a:t>
                       </a:r>
                     </a:p>
                   </a:txBody>
@@ -25731,7 +25731,7 @@
                           </a:solidFill>
                           <a:latin typeface="Arial"/>
                         </a:rPr>
-                        <a:t>All exposure is held through AIPII to minimise conflicts; residual matters governed by a formal conflicts-of-interest framework.</a:t>
+                        <a:t>At least four independent non-executive directors plus one AIP management representative; UK Corporate Governance / AIC Code.</a:t>
                       </a:r>
                     </a:p>
                   </a:txBody>
@@ -25755,7 +25755,99 @@
                           </a:solidFill>
                           <a:latin typeface="Arial"/>
                         </a:rPr>
+                        <a:t>Conflicts of interest &amp; related-party dealing</a:t>
+                      </a:r>
+                    </a:p>
+                  </a:txBody>
+                  <a:tcPr marL="64008" marR="82296" marT="32004" marB="32004" anchor="t">
+                    <a:solidFill>
+                      <a:srgbClr val="FFFFFF"/>
+                    </a:solidFill>
+                  </a:tcPr>
+                </a:tc>
+                <a:tc>
+                  <a:txBody>
+                    <a:bodyPr wrap="square"/>
+                    <a:lstStyle/>
+                    <a:p>
+                      <a:r>
+                        <a:rPr sz="869" b="0">
+                          <a:solidFill>
+                            <a:srgbClr val="0E1620"/>
+                          </a:solidFill>
+                          <a:latin typeface="Arial"/>
+                        </a:rPr>
+                        <a:t>All exposure is held through AIPII to minimise conflicts; residual matters governed by a formal conflicts-of-interest framework.</a:t>
+                      </a:r>
+                    </a:p>
+                  </a:txBody>
+                  <a:tcPr marL="64008" marR="82296" marT="32004" marB="32004" anchor="t">
+                    <a:solidFill>
+                      <a:srgbClr val="FFFFFF"/>
+                    </a:solidFill>
+                  </a:tcPr>
+                </a:tc>
+              </a:tr>
+              <a:tr h="237744">
+                <a:tc>
+                  <a:txBody>
+                    <a:bodyPr wrap="square"/>
+                    <a:lstStyle/>
+                    <a:p>
+                      <a:r>
+                        <a:rPr sz="900" b="1">
+                          <a:solidFill>
+                            <a:srgbClr val="314359"/>
+                          </a:solidFill>
+                          <a:latin typeface="Arial"/>
+                        </a:rPr>
                         <a:t>Depositary, administrator &amp; registrar</a:t>
+                      </a:r>
+                    </a:p>
+                  </a:txBody>
+                  <a:tcPr marL="64008" marR="82296" marT="32004" marB="32004" anchor="t">
+                    <a:solidFill>
+                      <a:srgbClr val="F4F6F8"/>
+                    </a:solidFill>
+                  </a:tcPr>
+                </a:tc>
+                <a:tc>
+                  <a:txBody>
+                    <a:bodyPr wrap="square"/>
+                    <a:lstStyle/>
+                    <a:p>
+                      <a:r>
+                        <a:rPr sz="869" b="0">
+                          <a:solidFill>
+                            <a:srgbClr val="0E1620"/>
+                          </a:solidFill>
+                          <a:latin typeface="Arial"/>
+                        </a:rPr>
+                        <a:t>To be confirmed.</a:t>
+                      </a:r>
+                    </a:p>
+                  </a:txBody>
+                  <a:tcPr marL="64008" marR="82296" marT="32004" marB="32004" anchor="t">
+                    <a:solidFill>
+                      <a:srgbClr val="F4F6F8"/>
+                    </a:solidFill>
+                  </a:tcPr>
+                </a:tc>
+              </a:tr>
+              <a:tr h="237744">
+                <a:tc>
+                  <a:txBody>
+                    <a:bodyPr wrap="square"/>
+                    <a:lstStyle/>
+                    <a:p>
+                      <a:r>
+                        <a:rPr sz="900" b="1">
+                          <a:solidFill>
+                            <a:srgbClr val="314359"/>
+                          </a:solidFill>
+                          <a:latin typeface="Arial"/>
+                        </a:rPr>
+                        <a:t>Auditor &amp; corporate broker</a:t>
                       </a:r>
                     </a:p>
                   </a:txBody>
@@ -25801,7 +25893,7 @@
                           </a:solidFill>
                           <a:latin typeface="Arial"/>
                         </a:rPr>
-                        <a:t>Auditor &amp; corporate broker</a:t>
+                        <a:t>Lock-up &amp; orderly-market arrangements</a:t>
                       </a:r>
                     </a:p>
                   </a:txBody>
@@ -25847,7 +25939,99 @@
                           </a:solidFill>
                           <a:latin typeface="Arial"/>
                         </a:rPr>
-                        <a:t>Lock-up &amp; orderly-market arrangements</a:t>
+                        <a:t>ISA / SIPP eligibility</a:t>
+                      </a:r>
+                    </a:p>
+                  </a:txBody>
+                  <a:tcPr marL="64008" marR="82296" marT="32004" marB="32004" anchor="t">
+                    <a:solidFill>
+                      <a:srgbClr val="FFFFFF"/>
+                    </a:solidFill>
+                  </a:tcPr>
+                </a:tc>
+                <a:tc>
+                  <a:txBody>
+                    <a:bodyPr wrap="square"/>
+                    <a:lstStyle/>
+                    <a:p>
+                      <a:r>
+                        <a:rPr sz="869" b="0">
+                          <a:solidFill>
+                            <a:srgbClr val="0E1620"/>
+                          </a:solidFill>
+                          <a:latin typeface="Arial"/>
+                        </a:rPr>
+                        <a:t>To be confirmed (expected eligible).</a:t>
+                      </a:r>
+                    </a:p>
+                  </a:txBody>
+                  <a:tcPr marL="64008" marR="82296" marT="32004" marB="32004" anchor="t">
+                    <a:solidFill>
+                      <a:srgbClr val="FFFFFF"/>
+                    </a:solidFill>
+                  </a:tcPr>
+                </a:tc>
+              </a:tr>
+              <a:tr h="237744">
+                <a:tc>
+                  <a:txBody>
+                    <a:bodyPr wrap="square"/>
+                    <a:lstStyle/>
+                    <a:p>
+                      <a:r>
+                        <a:rPr sz="900" b="1">
+                          <a:solidFill>
+                            <a:srgbClr val="314359"/>
+                          </a:solidFill>
+                          <a:latin typeface="Arial"/>
+                        </a:rPr>
+                        <a:t>Reporting &amp; financial calendar</a:t>
+                      </a:r>
+                    </a:p>
+                  </a:txBody>
+                  <a:tcPr marL="64008" marR="82296" marT="32004" marB="32004" anchor="t">
+                    <a:solidFill>
+                      <a:srgbClr val="F4F6F8"/>
+                    </a:solidFill>
+                  </a:tcPr>
+                </a:tc>
+                <a:tc>
+                  <a:txBody>
+                    <a:bodyPr wrap="square"/>
+                    <a:lstStyle/>
+                    <a:p>
+                      <a:r>
+                        <a:rPr sz="869" b="0">
+                          <a:solidFill>
+                            <a:srgbClr val="0E1620"/>
+                          </a:solidFill>
+                          <a:latin typeface="Arial"/>
+                        </a:rPr>
+                        <a:t>To be confirmed.</a:t>
+                      </a:r>
+                    </a:p>
+                  </a:txBody>
+                  <a:tcPr marL="64008" marR="82296" marT="32004" marB="32004" anchor="t">
+                    <a:solidFill>
+                      <a:srgbClr val="F4F6F8"/>
+                    </a:solidFill>
+                  </a:tcPr>
+                </a:tc>
+              </a:tr>
+              <a:tr h="237744">
+                <a:tc>
+                  <a:txBody>
+                    <a:bodyPr wrap="square"/>
+                    <a:lstStyle/>
+                    <a:p>
+                      <a:r>
+                        <a:rPr sz="900" b="1">
+                          <a:solidFill>
+                            <a:srgbClr val="314359"/>
+                          </a:solidFill>
+                          <a:latin typeface="Arial"/>
+                        </a:rPr>
+                        <a:t>Ticker, ISIN &amp; SEDOL</a:t>
                       </a:r>
                     </a:p>
                   </a:txBody>
@@ -25876,144 +26060,6 @@
                   <a:tcPr marL="64008" marR="82296" marT="32004" marB="32004" anchor="t">
                     <a:solidFill>
                       <a:srgbClr val="FFFFFF"/>
-                    </a:solidFill>
-                  </a:tcPr>
-                </a:tc>
-              </a:tr>
-              <a:tr h="237744">
-                <a:tc>
-                  <a:txBody>
-                    <a:bodyPr wrap="square"/>
-                    <a:lstStyle/>
-                    <a:p>
-                      <a:r>
-                        <a:rPr sz="900" b="1">
-                          <a:solidFill>
-                            <a:srgbClr val="314359"/>
-                          </a:solidFill>
-                          <a:latin typeface="Arial"/>
-                        </a:rPr>
-                        <a:t>ISA / SIPP eligibility</a:t>
-                      </a:r>
-                    </a:p>
-                  </a:txBody>
-                  <a:tcPr marL="64008" marR="82296" marT="32004" marB="32004" anchor="t">
-                    <a:solidFill>
-                      <a:srgbClr val="F4F6F8"/>
-                    </a:solidFill>
-                  </a:tcPr>
-                </a:tc>
-                <a:tc>
-                  <a:txBody>
-                    <a:bodyPr wrap="square"/>
-                    <a:lstStyle/>
-                    <a:p>
-                      <a:r>
-                        <a:rPr sz="869" b="0">
-                          <a:solidFill>
-                            <a:srgbClr val="0E1620"/>
-                          </a:solidFill>
-                          <a:latin typeface="Arial"/>
-                        </a:rPr>
-                        <a:t>To be confirmed (expected eligible).</a:t>
-                      </a:r>
-                    </a:p>
-                  </a:txBody>
-                  <a:tcPr marL="64008" marR="82296" marT="32004" marB="32004" anchor="t">
-                    <a:solidFill>
-                      <a:srgbClr val="F4F6F8"/>
-                    </a:solidFill>
-                  </a:tcPr>
-                </a:tc>
-              </a:tr>
-              <a:tr h="237744">
-                <a:tc>
-                  <a:txBody>
-                    <a:bodyPr wrap="square"/>
-                    <a:lstStyle/>
-                    <a:p>
-                      <a:r>
-                        <a:rPr sz="900" b="1">
-                          <a:solidFill>
-                            <a:srgbClr val="314359"/>
-                          </a:solidFill>
-                          <a:latin typeface="Arial"/>
-                        </a:rPr>
-                        <a:t>Reporting &amp; financial calendar</a:t>
-                      </a:r>
-                    </a:p>
-                  </a:txBody>
-                  <a:tcPr marL="64008" marR="82296" marT="32004" marB="32004" anchor="t">
-                    <a:solidFill>
-                      <a:srgbClr val="FFFFFF"/>
-                    </a:solidFill>
-                  </a:tcPr>
-                </a:tc>
-                <a:tc>
-                  <a:txBody>
-                    <a:bodyPr wrap="square"/>
-                    <a:lstStyle/>
-                    <a:p>
-                      <a:r>
-                        <a:rPr sz="869" b="0">
-                          <a:solidFill>
-                            <a:srgbClr val="0E1620"/>
-                          </a:solidFill>
-                          <a:latin typeface="Arial"/>
-                        </a:rPr>
-                        <a:t>To be confirmed.</a:t>
-                      </a:r>
-                    </a:p>
-                  </a:txBody>
-                  <a:tcPr marL="64008" marR="82296" marT="32004" marB="32004" anchor="t">
-                    <a:solidFill>
-                      <a:srgbClr val="FFFFFF"/>
-                    </a:solidFill>
-                  </a:tcPr>
-                </a:tc>
-              </a:tr>
-              <a:tr h="237744">
-                <a:tc>
-                  <a:txBody>
-                    <a:bodyPr wrap="square"/>
-                    <a:lstStyle/>
-                    <a:p>
-                      <a:r>
-                        <a:rPr sz="900" b="1">
-                          <a:solidFill>
-                            <a:srgbClr val="314359"/>
-                          </a:solidFill>
-                          <a:latin typeface="Arial"/>
-                        </a:rPr>
-                        <a:t>Ticker, ISIN &amp; SEDOL</a:t>
-                      </a:r>
-                    </a:p>
-                  </a:txBody>
-                  <a:tcPr marL="64008" marR="82296" marT="32004" marB="32004" anchor="t">
-                    <a:solidFill>
-                      <a:srgbClr val="F4F6F8"/>
-                    </a:solidFill>
-                  </a:tcPr>
-                </a:tc>
-                <a:tc>
-                  <a:txBody>
-                    <a:bodyPr wrap="square"/>
-                    <a:lstStyle/>
-                    <a:p>
-                      <a:r>
-                        <a:rPr sz="869" b="0">
-                          <a:solidFill>
-                            <a:srgbClr val="0E1620"/>
-                          </a:solidFill>
-                          <a:latin typeface="Arial"/>
-                        </a:rPr>
-                        <a:t>To be confirmed.</a:t>
-                      </a:r>
-                    </a:p>
-                  </a:txBody>
-                  <a:tcPr marL="64008" marR="82296" marT="32004" marB="32004" anchor="t">
-                    <a:solidFill>
-                      <a:srgbClr val="F4F6F8"/>
                     </a:solidFill>
                   </a:tcPr>
                 </a:tc>

</xml_diff>

<commit_message>
Add buyback-mechanics appendix slide (p.24)
UK MAR safe-harbour framework (14.99% authority, price/25% ADTV limits,
same-day RNS, non-discretionary mandate, treasury vs cancellation) plus
our proposed discount-control policy: 10-day VWAP >10% trigger, on-market
non-discretionary execution, cash+bridge funding from AIPII quarterly
redemptions, ~10% tranches refreshed by GM cancellation, daily 10-day-VWAP
measurement pausing inside ~5%, quarterly review. Added to TOC.

https://claude.ai/code/session_01HRMxSvt6t94q3GFGUqavQe
</commit_message>
<xml_diff>
--- a/UK_Investment_Trust_Proposal.pptx
+++ b/UK_Investment_Trust_Proposal.pptx
@@ -31,6 +31,7 @@
     <p:sldId id="321" r:id="rId26"/>
     <p:sldId id="344" r:id="rId25"/>
     <p:sldId id="345" r:id="rId19"/>
+    <p:sldId id="346" r:id="rId35"/>
   </p:sldIdLst>
   <p:sldSz cx="9753600" cy="7315200"/>
   <p:notesSz cx="6858000" cy="9144000"/>
@@ -22407,6 +22408,34 @@
                 <a:latin typeface="Arial"/>
               </a:rPr>
               <a:t>Indicative term sheet (cont.)</a:t>
+            </a:r>
+          </a:p>
+          <a:p>
+            <a:pPr>
+              <a:lnSpc>
+                <a:spcPct val="102000"/>
+              </a:lnSpc>
+              <a:spcAft>
+                <a:spcPts val="300"/>
+              </a:spcAft>
+            </a:pPr>
+            <a:r>
+              <a:rPr sz="800" b="1">
+                <a:solidFill>
+                  <a:srgbClr val="314359"/>
+                </a:solidFill>
+                <a:latin typeface="Arial"/>
+              </a:rPr>
+              <a:t>24   </a:t>
+            </a:r>
+            <a:r>
+              <a:rPr sz="800">
+                <a:solidFill>
+                  <a:srgbClr val="314359"/>
+                </a:solidFill>
+                <a:latin typeface="Arial"/>
+              </a:rPr>
+              <a:t>How the share buyback works</a:t>
             </a:r>
           </a:p>
         </p:txBody>
@@ -26098,6 +26127,838 @@
                 <a:latin typeface="Arial"/>
               </a:rPr>
               <a:t>Indicative and non-binding, for discussion only — subject to contract, satisfactory due diligence, regulatory approval and final documentation. Not an offer or invitation to invest. [TBC = to be confirmed.]</a:t>
+            </a:r>
+          </a:p>
+        </p:txBody>
+      </p:sp>
+    </p:spTree>
+  </p:cSld>
+  <p:clrMapOvr>
+    <a:masterClrMapping/>
+  </p:clrMapOvr>
+</p:sld>
+</file>
+
+<file path=ppt/slides/slide24.xml><?xml version="1.0" encoding="utf-8"?>
+<p:sld xmlns:a="http://schemas.openxmlformats.org/drawingml/2006/main" xmlns:p="http://schemas.openxmlformats.org/presentationml/2006/main" xmlns:r="http://schemas.openxmlformats.org/officeDocument/2006/relationships">
+  <p:cSld>
+    <p:spTree>
+      <p:nvGrpSpPr>
+        <p:cNvPr id="1" name=""/>
+        <p:cNvGrpSpPr/>
+        <p:nvPr/>
+      </p:nvGrpSpPr>
+      <p:grpSpPr/>
+      <p:sp>
+        <p:nvSpPr>
+          <p:cNvPr id="2" name="Rectangle 1"/>
+          <p:cNvSpPr/>
+          <p:nvPr/>
+        </p:nvSpPr>
+        <p:spPr>
+          <a:xfrm>
+            <a:off x="0" y="0"/>
+            <a:ext cx="9753600" cy="7315200"/>
+          </a:xfrm>
+          <a:prstGeom prst="rect">
+            <a:avLst/>
+          </a:prstGeom>
+          <a:solidFill>
+            <a:srgbClr val="FFFFFF"/>
+          </a:solidFill>
+          <a:ln>
+            <a:noFill/>
+          </a:ln>
+          <a:effectLst/>
+        </p:spPr>
+        <p:style>
+          <a:lnRef idx="1">
+            <a:schemeClr val="accent1"/>
+          </a:lnRef>
+          <a:fillRef idx="3">
+            <a:schemeClr val="accent1"/>
+          </a:fillRef>
+          <a:effectRef idx="2">
+            <a:schemeClr val="accent1"/>
+          </a:effectRef>
+          <a:fontRef idx="minor">
+            <a:schemeClr val="lt1"/>
+          </a:fontRef>
+        </p:style>
+        <p:txBody>
+          <a:bodyPr rtlCol="0" anchor="ctr"/>
+          <a:lstStyle/>
+          <a:p>
+            <a:pPr algn="ctr"/>
+            <a:endParaRPr/>
+          </a:p>
+        </p:txBody>
+      </p:sp>
+      <p:pic>
+        <p:nvPicPr>
+          <p:cNvPr id="3" name="Picture 2" descr="mark_dark.png"/>
+          <p:cNvPicPr>
+            <a:picLocks noChangeAspect="1"/>
+          </p:cNvPicPr>
+          <p:nvPr/>
+        </p:nvPicPr>
+        <p:blipFill>
+          <a:blip r:embed="rId2"/>
+          <a:stretch>
+            <a:fillRect/>
+          </a:stretch>
+        </p:blipFill>
+        <p:spPr>
+          <a:xfrm>
+            <a:off x="402346" y="234086"/>
+            <a:ext cx="224012" cy="190199"/>
+          </a:xfrm>
+          <a:prstGeom prst="rect">
+            <a:avLst/>
+          </a:prstGeom>
+        </p:spPr>
+      </p:pic>
+      <p:sp>
+        <p:nvSpPr>
+          <p:cNvPr id="4" name="TextBox 3"/>
+          <p:cNvSpPr txBox="1"/>
+          <p:nvPr/>
+        </p:nvSpPr>
+        <p:spPr>
+          <a:xfrm>
+            <a:off x="716907" y="263347"/>
+            <a:ext cx="5120768" cy="292608"/>
+          </a:xfrm>
+          <a:prstGeom prst="rect">
+            <a:avLst/>
+          </a:prstGeom>
+          <a:noFill/>
+        </p:spPr>
+        <p:txBody>
+          <a:bodyPr wrap="square" lIns="0" tIns="0" rIns="0" bIns="0" anchor="t">
+            <a:spAutoFit/>
+          </a:bodyPr>
+          <a:lstStyle/>
+          <a:p>
+            <a:pPr algn="l">
+              <a:lnSpc>
+                <a:spcPct val="110000"/>
+              </a:lnSpc>
+              <a:spcAft>
+                <a:spcPts val="0"/>
+              </a:spcAft>
+            </a:pPr>
+            <a:r>
+              <a:rPr sz="880" b="0" i="0">
+                <a:solidFill>
+                  <a:srgbClr val="556A83"/>
+                </a:solidFill>
+                <a:latin typeface="Arial"/>
+              </a:rPr>
+              <a:t>Appendix</a:t>
+            </a:r>
+          </a:p>
+        </p:txBody>
+      </p:sp>
+      <p:sp>
+        <p:nvSpPr>
+          <p:cNvPr id="6" name="Rectangle 5"/>
+          <p:cNvSpPr/>
+          <p:nvPr/>
+        </p:nvSpPr>
+        <p:spPr>
+          <a:xfrm>
+            <a:off x="0" y="604723"/>
+            <a:ext cx="9753600" cy="1414272"/>
+          </a:xfrm>
+          <a:prstGeom prst="rect">
+            <a:avLst/>
+          </a:prstGeom>
+          <a:solidFill>
+            <a:srgbClr val="F6F7F9"/>
+          </a:solidFill>
+          <a:ln>
+            <a:noFill/>
+          </a:ln>
+          <a:effectLst/>
+        </p:spPr>
+        <p:style>
+          <a:lnRef idx="1">
+            <a:schemeClr val="accent1"/>
+          </a:lnRef>
+          <a:fillRef idx="3">
+            <a:schemeClr val="accent1"/>
+          </a:fillRef>
+          <a:effectRef idx="2">
+            <a:schemeClr val="accent1"/>
+          </a:effectRef>
+          <a:fontRef idx="minor">
+            <a:schemeClr val="lt1"/>
+          </a:fontRef>
+        </p:style>
+        <p:txBody>
+          <a:bodyPr rtlCol="0" anchor="ctr"/>
+          <a:lstStyle/>
+          <a:p>
+            <a:pPr algn="ctr"/>
+            <a:endParaRPr/>
+          </a:p>
+        </p:txBody>
+      </p:sp>
+      <p:sp>
+        <p:nvSpPr>
+          <p:cNvPr id="7" name="TextBox 6"/>
+          <p:cNvSpPr txBox="1"/>
+          <p:nvPr/>
+        </p:nvSpPr>
+        <p:spPr>
+          <a:xfrm>
+            <a:off x="438922" y="721766"/>
+            <a:ext cx="8851613" cy="829056"/>
+          </a:xfrm>
+          <a:prstGeom prst="rect">
+            <a:avLst/>
+          </a:prstGeom>
+          <a:noFill/>
+        </p:spPr>
+        <p:txBody>
+          <a:bodyPr wrap="square" lIns="0" tIns="0" rIns="0" bIns="0" anchor="t">
+            <a:spAutoFit/>
+          </a:bodyPr>
+          <a:lstStyle/>
+          <a:p>
+            <a:pPr algn="l">
+              <a:lnSpc>
+                <a:spcPct val="110000"/>
+              </a:lnSpc>
+              <a:spcAft>
+                <a:spcPts val="200"/>
+              </a:spcAft>
+            </a:pPr>
+            <a:r>
+              <a:rPr sz="2400" b="0" i="0" spc="-90">
+                <a:solidFill>
+                  <a:srgbClr val="314359"/>
+                </a:solidFill>
+                <a:latin typeface="Times New Roman"/>
+              </a:rPr>
+              <a:t>How the share buyback works</a:t>
+            </a:r>
+          </a:p>
+        </p:txBody>
+      </p:sp>
+      <p:sp>
+        <p:nvSpPr>
+          <p:cNvPr id="8" name="TextBox 7"/>
+          <p:cNvSpPr txBox="1"/>
+          <p:nvPr/>
+        </p:nvSpPr>
+        <p:spPr>
+          <a:xfrm>
+            <a:off x="453553" y="1511808"/>
+            <a:ext cx="8705305" cy="487680"/>
+          </a:xfrm>
+          <a:prstGeom prst="rect">
+            <a:avLst/>
+          </a:prstGeom>
+          <a:noFill/>
+        </p:spPr>
+        <p:txBody>
+          <a:bodyPr wrap="square" lIns="0" tIns="0" rIns="0" bIns="0" anchor="t">
+            <a:spAutoFit/>
+          </a:bodyPr>
+          <a:lstStyle/>
+          <a:p>
+            <a:pPr algn="l">
+              <a:lnSpc>
+                <a:spcPct val="110000"/>
+              </a:lnSpc>
+              <a:spcAft>
+                <a:spcPts val="0"/>
+              </a:spcAft>
+            </a:pPr>
+            <a:r>
+              <a:rPr sz="1040" b="0" i="1">
+                <a:solidFill>
+                  <a:srgbClr val="556A83"/>
+                </a:solidFill>
+                <a:latin typeface="Arial"/>
+              </a:rPr>
+              <a:t>UK MAR safe-harbour mechanics, and our proposed discount-control policy.</a:t>
+            </a:r>
+          </a:p>
+        </p:txBody>
+      </p:sp>
+      <p:sp>
+        <p:nvSpPr>
+          <p:cNvPr id="9" name="TextBox 8"/>
+          <p:cNvSpPr txBox="1"/>
+          <p:nvPr/>
+        </p:nvSpPr>
+        <p:spPr>
+          <a:xfrm>
+            <a:off x="6583844" y="6876288"/>
+            <a:ext cx="2926153" cy="292608"/>
+          </a:xfrm>
+          <a:prstGeom prst="rect">
+            <a:avLst/>
+          </a:prstGeom>
+          <a:noFill/>
+        </p:spPr>
+        <p:txBody>
+          <a:bodyPr wrap="square" lIns="0" tIns="0" rIns="0" bIns="0" anchor="t">
+            <a:spAutoFit/>
+          </a:bodyPr>
+          <a:lstStyle/>
+          <a:p>
+            <a:pPr algn="r">
+              <a:lnSpc>
+                <a:spcPct val="110000"/>
+              </a:lnSpc>
+              <a:spcAft>
+                <a:spcPts val="0"/>
+              </a:spcAft>
+            </a:pPr>
+            <a:r>
+              <a:rPr sz="680" b="0" i="0">
+                <a:solidFill>
+                  <a:srgbClr val="556A83"/>
+                </a:solidFill>
+                <a:latin typeface="Arial"/>
+              </a:rPr>
+              <a:t>Strictly confidential          24</a:t>
+            </a:r>
+          </a:p>
+        </p:txBody>
+      </p:sp>
+      <p:sp>
+        <p:nvSpPr>
+          <p:cNvPr id="10" name="Rectangle 9"/>
+          <p:cNvSpPr/>
+          <p:nvPr/>
+        </p:nvSpPr>
+        <p:spPr>
+          <a:xfrm>
+            <a:off x="5230368" y="2240280"/>
+            <a:ext cx="10972" cy="4069080"/>
+          </a:xfrm>
+          <a:prstGeom prst="rect">
+            <a:avLst/>
+          </a:prstGeom>
+          <a:solidFill>
+            <a:srgbClr val="DDE1E7"/>
+          </a:solidFill>
+          <a:ln>
+            <a:noFill/>
+          </a:ln>
+          <a:effectLst/>
+        </p:spPr>
+        <p:style>
+          <a:lnRef idx="1">
+            <a:schemeClr val="accent1"/>
+          </a:lnRef>
+          <a:fillRef idx="3">
+            <a:schemeClr val="accent1"/>
+          </a:fillRef>
+          <a:effectRef idx="2">
+            <a:schemeClr val="accent1"/>
+          </a:effectRef>
+          <a:fontRef idx="minor">
+            <a:schemeClr val="lt1"/>
+          </a:fontRef>
+        </p:style>
+        <p:txBody>
+          <a:bodyPr rtlCol="0" anchor="ctr"/>
+          <a:lstStyle/>
+          <a:p>
+            <a:pPr algn="ctr"/>
+          </a:p>
+        </p:txBody>
+      </p:sp>
+      <p:sp>
+        <p:nvSpPr>
+          <p:cNvPr id="11" name="TextBox 10"/>
+          <p:cNvSpPr txBox="1"/>
+          <p:nvPr/>
+        </p:nvSpPr>
+        <p:spPr>
+          <a:xfrm>
+            <a:off x="512064" y="2212848"/>
+            <a:ext cx="4572000" cy="274320"/>
+          </a:xfrm>
+          <a:prstGeom prst="rect">
+            <a:avLst/>
+          </a:prstGeom>
+          <a:noFill/>
+        </p:spPr>
+        <p:txBody>
+          <a:bodyPr wrap="square" lIns="0" rIns="0" tIns="0" bIns="0">
+            <a:spAutoFit/>
+          </a:bodyPr>
+          <a:lstStyle/>
+          <a:p>
+            <a:r>
+              <a:rPr sz="950" b="1">
+                <a:solidFill>
+                  <a:srgbClr val="556A83"/>
+                </a:solidFill>
+                <a:latin typeface="Arial"/>
+              </a:rPr>
+              <a:t>THE UK FRAMEWORK   ·   MAR SAFE HARBOUR</a:t>
+            </a:r>
+          </a:p>
+        </p:txBody>
+      </p:sp>
+      <p:sp>
+        <p:nvSpPr>
+          <p:cNvPr id="12" name="TextBox 11"/>
+          <p:cNvSpPr txBox="1"/>
+          <p:nvPr/>
+        </p:nvSpPr>
+        <p:spPr>
+          <a:xfrm>
+            <a:off x="512064" y="2560320"/>
+            <a:ext cx="4590288" cy="3840480"/>
+          </a:xfrm>
+          <a:prstGeom prst="rect">
+            <a:avLst/>
+          </a:prstGeom>
+          <a:noFill/>
+        </p:spPr>
+        <p:txBody>
+          <a:bodyPr wrap="square" lIns="0" rIns="0" tIns="0" bIns="0">
+            <a:spAutoFit/>
+          </a:bodyPr>
+          <a:lstStyle/>
+          <a:p>
+            <a:pPr>
+              <a:spcAft>
+                <a:spcPts val="600"/>
+              </a:spcAft>
+            </a:pPr>
+            <a:r>
+              <a:rPr sz="960" b="1">
+                <a:solidFill>
+                  <a:srgbClr val="314359"/>
+                </a:solidFill>
+                <a:latin typeface="Arial"/>
+              </a:rPr>
+              <a:t>›  </a:t>
+            </a:r>
+            <a:r>
+              <a:rPr sz="960" b="1">
+                <a:solidFill>
+                  <a:srgbClr val="314359"/>
+                </a:solidFill>
+                <a:latin typeface="Arial"/>
+              </a:rPr>
+              <a:t>Shareholder authority.  </a:t>
+            </a:r>
+            <a:r>
+              <a:rPr sz="960" b="0">
+                <a:solidFill>
+                  <a:srgbClr val="0E1620"/>
+                </a:solidFill>
+                <a:latin typeface="Arial"/>
+              </a:rPr>
+              <a:t>AGM approval to repurchase up to 14.99% of issued shares; going further needs a general meeting and a fresh circular.</a:t>
+            </a:r>
+          </a:p>
+          <a:p>
+            <a:pPr>
+              <a:spcAft>
+                <a:spcPts val="600"/>
+              </a:spcAft>
+            </a:pPr>
+            <a:r>
+              <a:rPr sz="960" b="1">
+                <a:solidFill>
+                  <a:srgbClr val="314359"/>
+                </a:solidFill>
+                <a:latin typeface="Arial"/>
+              </a:rPr>
+              <a:t>›  </a:t>
+            </a:r>
+            <a:r>
+              <a:rPr sz="960" b="1">
+                <a:solidFill>
+                  <a:srgbClr val="314359"/>
+                </a:solidFill>
+                <a:latin typeface="Arial"/>
+              </a:rPr>
+              <a:t>Price &amp; volume limits.  </a:t>
+            </a:r>
+            <a:r>
+              <a:rPr sz="960" b="0">
+                <a:solidFill>
+                  <a:srgbClr val="0E1620"/>
+                </a:solidFill>
+                <a:latin typeface="Arial"/>
+              </a:rPr>
+              <a:t>No higher than the higher of the last independent trade or the highest current bid; volume capped at 25% of average daily volume (ADTV).</a:t>
+            </a:r>
+          </a:p>
+          <a:p>
+            <a:pPr>
+              <a:spcAft>
+                <a:spcPts val="600"/>
+              </a:spcAft>
+            </a:pPr>
+            <a:r>
+              <a:rPr sz="960" b="1">
+                <a:solidFill>
+                  <a:srgbClr val="314359"/>
+                </a:solidFill>
+                <a:latin typeface="Arial"/>
+              </a:rPr>
+              <a:t>›  </a:t>
+            </a:r>
+            <a:r>
+              <a:rPr sz="960" b="1">
+                <a:solidFill>
+                  <a:srgbClr val="314359"/>
+                </a:solidFill>
+                <a:latin typeface="Arial"/>
+              </a:rPr>
+              <a:t>Disclosure.  </a:t>
+            </a:r>
+            <a:r>
+              <a:rPr sz="960" b="0">
+                <a:solidFill>
+                  <a:srgbClr val="0E1620"/>
+                </a:solidFill>
+                <a:latin typeface="Arial"/>
+              </a:rPr>
+              <a:t>Each day's dealings are announced by RNS — market practice is same-day, shortly after the 16:30 close (volume, high/low and VWAP).</a:t>
+            </a:r>
+          </a:p>
+          <a:p>
+            <a:pPr>
+              <a:spcAft>
+                <a:spcPts val="600"/>
+              </a:spcAft>
+            </a:pPr>
+            <a:r>
+              <a:rPr sz="960" b="1">
+                <a:solidFill>
+                  <a:srgbClr val="314359"/>
+                </a:solidFill>
+                <a:latin typeface="Arial"/>
+              </a:rPr>
+              <a:t>›  </a:t>
+            </a:r>
+            <a:r>
+              <a:rPr sz="960" b="1">
+                <a:solidFill>
+                  <a:srgbClr val="314359"/>
+                </a:solidFill>
+                <a:latin typeface="Arial"/>
+              </a:rPr>
+              <a:t>Execution.  </a:t>
+            </a:r>
+            <a:r>
+              <a:rPr sz="960" b="0">
+                <a:solidFill>
+                  <a:srgbClr val="0E1620"/>
+                </a:solidFill>
+                <a:latin typeface="Arial"/>
+              </a:rPr>
+              <a:t>A broker runs the programme; a non-discretionary mandate — board sets the parameters, broker executes — lets buybacks continue through closed periods.</a:t>
+            </a:r>
+          </a:p>
+          <a:p>
+            <a:pPr>
+              <a:spcAft>
+                <a:spcPts val="600"/>
+              </a:spcAft>
+            </a:pPr>
+            <a:r>
+              <a:rPr sz="960" b="1">
+                <a:solidFill>
+                  <a:srgbClr val="314359"/>
+                </a:solidFill>
+                <a:latin typeface="Arial"/>
+              </a:rPr>
+              <a:t>›  </a:t>
+            </a:r>
+            <a:r>
+              <a:rPr sz="960" b="1">
+                <a:solidFill>
+                  <a:srgbClr val="314359"/>
+                </a:solidFill>
+                <a:latin typeface="Arial"/>
+              </a:rPr>
+              <a:t>Treatment.  </a:t>
+            </a:r>
+            <a:r>
+              <a:rPr sz="960" b="0">
+                <a:solidFill>
+                  <a:srgbClr val="0E1620"/>
+                </a:solidFill>
+                <a:latin typeface="Arial"/>
+              </a:rPr>
+              <a:t>Cancel (permanently shrinks the count and, as shares are bought below NAV, lifts NAV per share) or hold in treasury for quick re-issue at a premium.</a:t>
+            </a:r>
+          </a:p>
+        </p:txBody>
+      </p:sp>
+      <p:sp>
+        <p:nvSpPr>
+          <p:cNvPr id="13" name="TextBox 12"/>
+          <p:cNvSpPr txBox="1"/>
+          <p:nvPr/>
+        </p:nvSpPr>
+        <p:spPr>
+          <a:xfrm>
+            <a:off x="5440680" y="2212848"/>
+            <a:ext cx="3886200" cy="274320"/>
+          </a:xfrm>
+          <a:prstGeom prst="rect">
+            <a:avLst/>
+          </a:prstGeom>
+          <a:noFill/>
+        </p:spPr>
+        <p:txBody>
+          <a:bodyPr wrap="square" lIns="0" rIns="0" tIns="0" bIns="0">
+            <a:spAutoFit/>
+          </a:bodyPr>
+          <a:lstStyle/>
+          <a:p>
+            <a:r>
+              <a:rPr sz="950" b="1">
+                <a:solidFill>
+                  <a:srgbClr val="556A83"/>
+                </a:solidFill>
+                <a:latin typeface="Arial"/>
+              </a:rPr>
+              <a:t>OUR PROPOSED DISCOUNT-CONTROL POLICY</a:t>
+            </a:r>
+          </a:p>
+        </p:txBody>
+      </p:sp>
+      <p:sp>
+        <p:nvSpPr>
+          <p:cNvPr id="14" name="TextBox 13"/>
+          <p:cNvSpPr txBox="1"/>
+          <p:nvPr/>
+        </p:nvSpPr>
+        <p:spPr>
+          <a:xfrm>
+            <a:off x="5440680" y="2560320"/>
+            <a:ext cx="3886200" cy="3840480"/>
+          </a:xfrm>
+          <a:prstGeom prst="rect">
+            <a:avLst/>
+          </a:prstGeom>
+          <a:noFill/>
+        </p:spPr>
+        <p:txBody>
+          <a:bodyPr wrap="square" lIns="0" rIns="0" tIns="0" bIns="0">
+            <a:spAutoFit/>
+          </a:bodyPr>
+          <a:lstStyle/>
+          <a:p>
+            <a:pPr>
+              <a:spcAft>
+                <a:spcPts val="600"/>
+              </a:spcAft>
+            </a:pPr>
+            <a:r>
+              <a:rPr sz="960" b="1">
+                <a:solidFill>
+                  <a:srgbClr val="314359"/>
+                </a:solidFill>
+                <a:latin typeface="Arial"/>
+              </a:rPr>
+              <a:t>›  </a:t>
+            </a:r>
+            <a:r>
+              <a:rPr sz="960" b="1">
+                <a:solidFill>
+                  <a:srgbClr val="314359"/>
+                </a:solidFill>
+                <a:latin typeface="Arial"/>
+              </a:rPr>
+              <a:t>Trigger.  </a:t>
+            </a:r>
+            <a:r>
+              <a:rPr sz="960" b="0">
+                <a:solidFill>
+                  <a:srgbClr val="0E1620"/>
+                </a:solidFill>
+                <a:latin typeface="Arial"/>
+              </a:rPr>
+              <a:t>Activate when the rolling 10-day VWAP trades at a discount wider than 10% to the latest published NAV.</a:t>
+            </a:r>
+          </a:p>
+          <a:p>
+            <a:pPr>
+              <a:spcAft>
+                <a:spcPts val="600"/>
+              </a:spcAft>
+            </a:pPr>
+            <a:r>
+              <a:rPr sz="960" b="1">
+                <a:solidFill>
+                  <a:srgbClr val="314359"/>
+                </a:solidFill>
+                <a:latin typeface="Arial"/>
+              </a:rPr>
+              <a:t>›  </a:t>
+            </a:r>
+            <a:r>
+              <a:rPr sz="960" b="1">
+                <a:solidFill>
+                  <a:srgbClr val="314359"/>
+                </a:solidFill>
+                <a:latin typeface="Arial"/>
+              </a:rPr>
+              <a:t>Execution.  </a:t>
+            </a:r>
+            <a:r>
+              <a:rPr sz="960" b="0">
+                <a:solidFill>
+                  <a:srgbClr val="0E1620"/>
+                </a:solidFill>
+                <a:latin typeface="Arial"/>
+              </a:rPr>
+              <a:t>On-market purchases within the MAR safe harbour, via a non-discretionary mandate so the programme runs through closed periods.</a:t>
+            </a:r>
+          </a:p>
+          <a:p>
+            <a:pPr>
+              <a:spcAft>
+                <a:spcPts val="600"/>
+              </a:spcAft>
+            </a:pPr>
+            <a:r>
+              <a:rPr sz="960" b="1">
+                <a:solidFill>
+                  <a:srgbClr val="314359"/>
+                </a:solidFill>
+                <a:latin typeface="Arial"/>
+              </a:rPr>
+              <a:t>›  </a:t>
+            </a:r>
+            <a:r>
+              <a:rPr sz="960" b="1">
+                <a:solidFill>
+                  <a:srgbClr val="314359"/>
+                </a:solidFill>
+                <a:latin typeface="Arial"/>
+              </a:rPr>
+              <a:t>Funding.  </a:t>
+            </a:r>
+            <a:r>
+              <a:rPr sz="960" b="0">
+                <a:solidFill>
+                  <a:srgbClr val="0E1620"/>
+                </a:solidFill>
+                <a:latin typeface="Arial"/>
+              </a:rPr>
+              <a:t>A cash buffer plus short-term borrowing, repaid from AIPII's quarterly redemptions (90 days' notice); within the 10%-of-NAV borrowing cap.</a:t>
+            </a:r>
+          </a:p>
+          <a:p>
+            <a:pPr>
+              <a:spcAft>
+                <a:spcPts val="600"/>
+              </a:spcAft>
+            </a:pPr>
+            <a:r>
+              <a:rPr sz="960" b="1">
+                <a:solidFill>
+                  <a:srgbClr val="314359"/>
+                </a:solidFill>
+                <a:latin typeface="Arial"/>
+              </a:rPr>
+              <a:t>›  </a:t>
+            </a:r>
+            <a:r>
+              <a:rPr sz="960" b="1">
+                <a:solidFill>
+                  <a:srgbClr val="314359"/>
+                </a:solidFill>
+                <a:latin typeface="Arial"/>
+              </a:rPr>
+              <a:t>Capacity &amp; refresh.  </a:t>
+            </a:r>
+            <a:r>
+              <a:rPr sz="960" b="0">
+                <a:solidFill>
+                  <a:srgbClr val="0E1620"/>
+                </a:solidFill>
+                <a:latin typeface="Arial"/>
+              </a:rPr>
+              <a:t>Repurchase in tranches of up to ~10% of shares, then a general meeting to cancel the shares and renew authority — repeating while the discount persists.</a:t>
+            </a:r>
+          </a:p>
+          <a:p>
+            <a:pPr>
+              <a:spcAft>
+                <a:spcPts val="600"/>
+              </a:spcAft>
+            </a:pPr>
+            <a:r>
+              <a:rPr sz="960" b="1">
+                <a:solidFill>
+                  <a:srgbClr val="314359"/>
+                </a:solidFill>
+                <a:latin typeface="Arial"/>
+              </a:rPr>
+              <a:t>›  </a:t>
+            </a:r>
+            <a:r>
+              <a:rPr sz="960" b="1">
+                <a:solidFill>
+                  <a:srgbClr val="314359"/>
+                </a:solidFill>
+                <a:latin typeface="Arial"/>
+              </a:rPr>
+              <a:t>Measurement.  </a:t>
+            </a:r>
+            <a:r>
+              <a:rPr sz="960" b="0">
+                <a:solidFill>
+                  <a:srgbClr val="0E1620"/>
+                </a:solidFill>
+                <a:latin typeface="Arial"/>
+              </a:rPr>
+              <a:t>Discount tracked daily on the rolling 10-day VWAP vs latest NAV; the programme pauses once it narrows back inside ~5%, and is reviewed each quarter alongside the redemption that funds it.</a:t>
+            </a:r>
+          </a:p>
+        </p:txBody>
+      </p:sp>
+      <p:sp>
+        <p:nvSpPr>
+          <p:cNvPr id="15" name="TextBox 14"/>
+          <p:cNvSpPr txBox="1"/>
+          <p:nvPr/>
+        </p:nvSpPr>
+        <p:spPr>
+          <a:xfrm>
+            <a:off x="512064" y="6437376"/>
+            <a:ext cx="8778240" cy="365760"/>
+          </a:xfrm>
+          <a:prstGeom prst="rect">
+            <a:avLst/>
+          </a:prstGeom>
+          <a:noFill/>
+        </p:spPr>
+        <p:txBody>
+          <a:bodyPr wrap="square" lIns="0" rIns="0" tIns="0" bIns="0">
+            <a:spAutoFit/>
+          </a:bodyPr>
+          <a:lstStyle/>
+          <a:p>
+            <a:r>
+              <a:rPr sz="650" b="0">
+                <a:solidFill>
+                  <a:srgbClr val="8A939F"/>
+                </a:solidFill>
+                <a:latin typeface="Arial"/>
+              </a:rPr>
+              <a:t>Indicative and for discussion only; final policy subject to board approval, shareholder authority and MAR compliance. ADTV = average daily trading volume; VWAP = volume-weighted average price.</a:t>
             </a:r>
           </a:p>
         </p:txBody>

</xml_diff>

<commit_message>
Add overvaluation evidence slide + sources page (p.25-26)
p.25 maps 50 years of peer-reviewed bubble/IPO research onto the 2026
AI/IPO demand (research-vs-today table): Miller 1977, Scheinkman-Xiong
2003, Diether et al 2002 (~9.5%/yr), Ritter 1991 (34.5% vs 61.9%),
Ofek-Richardson 2003, Pastor-Veronesi 2009, Greenwood-Shleifer-You 2019
(~53%/~80% crash odds) -> SpaceX/OpenAI/Anthropic, Mag-7 ~35%, CAPE ~40.
Conclusion ties to the diversification thesis (Abreu-Brunnermeier 2003).
p.26 is a full references page (16 peer-reviewed articles + book + dated
market-data/press sources), flagging peer-reviewed vs reported figures.
Added both to the TOC.

https://claude.ai/code/session_01HRMxSvt6t94q3GFGUqavQe
</commit_message>
<xml_diff>
--- a/UK_Investment_Trust_Proposal.pptx
+++ b/UK_Investment_Trust_Proposal.pptx
@@ -32,6 +32,8 @@
     <p:sldId id="344" r:id="rId25"/>
     <p:sldId id="345" r:id="rId19"/>
     <p:sldId id="346" r:id="rId35"/>
+    <p:sldId id="347" r:id="rId36"/>
+    <p:sldId id="348" r:id="rId37"/>
   </p:sldIdLst>
   <p:sldSz cx="9753600" cy="7315200"/>
   <p:notesSz cx="6858000" cy="9144000"/>
@@ -22436,6 +22438,62 @@
                 <a:latin typeface="Arial"/>
               </a:rPr>
               <a:t>How the share buyback works</a:t>
+            </a:r>
+          </a:p>
+          <a:p>
+            <a:pPr>
+              <a:lnSpc>
+                <a:spcPct val="102000"/>
+              </a:lnSpc>
+              <a:spcAft>
+                <a:spcPts val="300"/>
+              </a:spcAft>
+            </a:pPr>
+            <a:r>
+              <a:rPr sz="800" b="1">
+                <a:solidFill>
+                  <a:srgbClr val="314359"/>
+                </a:solidFill>
+                <a:latin typeface="Arial"/>
+              </a:rPr>
+              <a:t>25   </a:t>
+            </a:r>
+            <a:r>
+              <a:rPr sz="800">
+                <a:solidFill>
+                  <a:srgbClr val="314359"/>
+                </a:solidFill>
+                <a:latin typeface="Arial"/>
+              </a:rPr>
+              <a:t>Why parts of the market may be overvalued</a:t>
+            </a:r>
+          </a:p>
+          <a:p>
+            <a:pPr>
+              <a:lnSpc>
+                <a:spcPct val="102000"/>
+              </a:lnSpc>
+              <a:spcAft>
+                <a:spcPts val="300"/>
+              </a:spcAft>
+            </a:pPr>
+            <a:r>
+              <a:rPr sz="800" b="1">
+                <a:solidFill>
+                  <a:srgbClr val="314359"/>
+                </a:solidFill>
+                <a:latin typeface="Arial"/>
+              </a:rPr>
+              <a:t>26   </a:t>
+            </a:r>
+            <a:r>
+              <a:rPr sz="800">
+                <a:solidFill>
+                  <a:srgbClr val="314359"/>
+                </a:solidFill>
+                <a:latin typeface="Arial"/>
+              </a:rPr>
+              <a:t>Sources &amp; references</a:t>
             </a:r>
           </a:p>
         </p:txBody>
@@ -26959,6 +27017,2119 @@
                 <a:latin typeface="Arial"/>
               </a:rPr>
               <a:t>Indicative and for discussion only; final policy subject to board approval, shareholder authority and MAR compliance. ADTV = average daily trading volume; VWAP = volume-weighted average price.</a:t>
+            </a:r>
+          </a:p>
+        </p:txBody>
+      </p:sp>
+    </p:spTree>
+  </p:cSld>
+  <p:clrMapOvr>
+    <a:masterClrMapping/>
+  </p:clrMapOvr>
+</p:sld>
+</file>
+
+<file path=ppt/slides/slide25.xml><?xml version="1.0" encoding="utf-8"?>
+<p:sld xmlns:a="http://schemas.openxmlformats.org/drawingml/2006/main" xmlns:p="http://schemas.openxmlformats.org/presentationml/2006/main" xmlns:r="http://schemas.openxmlformats.org/officeDocument/2006/relationships">
+  <p:cSld>
+    <p:spTree>
+      <p:nvGrpSpPr>
+        <p:cNvPr id="1" name=""/>
+        <p:cNvGrpSpPr/>
+        <p:nvPr/>
+      </p:nvGrpSpPr>
+      <p:grpSpPr/>
+      <p:sp>
+        <p:nvSpPr>
+          <p:cNvPr id="2" name="Rectangle 1"/>
+          <p:cNvSpPr/>
+          <p:nvPr/>
+        </p:nvSpPr>
+        <p:spPr>
+          <a:xfrm>
+            <a:off x="0" y="0"/>
+            <a:ext cx="9753600" cy="7315200"/>
+          </a:xfrm>
+          <a:prstGeom prst="rect">
+            <a:avLst/>
+          </a:prstGeom>
+          <a:solidFill>
+            <a:srgbClr val="FFFFFF"/>
+          </a:solidFill>
+          <a:ln>
+            <a:noFill/>
+          </a:ln>
+          <a:effectLst/>
+        </p:spPr>
+        <p:style>
+          <a:lnRef idx="1">
+            <a:schemeClr val="accent1"/>
+          </a:lnRef>
+          <a:fillRef idx="3">
+            <a:schemeClr val="accent1"/>
+          </a:fillRef>
+          <a:effectRef idx="2">
+            <a:schemeClr val="accent1"/>
+          </a:effectRef>
+          <a:fontRef idx="minor">
+            <a:schemeClr val="lt1"/>
+          </a:fontRef>
+        </p:style>
+        <p:txBody>
+          <a:bodyPr rtlCol="0" anchor="ctr"/>
+          <a:lstStyle/>
+          <a:p>
+            <a:pPr algn="ctr"/>
+            <a:endParaRPr/>
+          </a:p>
+        </p:txBody>
+      </p:sp>
+      <p:pic>
+        <p:nvPicPr>
+          <p:cNvPr id="3" name="Picture 2" descr="mark_dark.png"/>
+          <p:cNvPicPr>
+            <a:picLocks noChangeAspect="1"/>
+          </p:cNvPicPr>
+          <p:nvPr/>
+        </p:nvPicPr>
+        <p:blipFill>
+          <a:blip r:embed="rId2"/>
+          <a:stretch>
+            <a:fillRect/>
+          </a:stretch>
+        </p:blipFill>
+        <p:spPr>
+          <a:xfrm>
+            <a:off x="402346" y="234086"/>
+            <a:ext cx="224012" cy="190199"/>
+          </a:xfrm>
+          <a:prstGeom prst="rect">
+            <a:avLst/>
+          </a:prstGeom>
+        </p:spPr>
+      </p:pic>
+      <p:sp>
+        <p:nvSpPr>
+          <p:cNvPr id="4" name="TextBox 3"/>
+          <p:cNvSpPr txBox="1"/>
+          <p:nvPr/>
+        </p:nvSpPr>
+        <p:spPr>
+          <a:xfrm>
+            <a:off x="716907" y="263347"/>
+            <a:ext cx="5120768" cy="292608"/>
+          </a:xfrm>
+          <a:prstGeom prst="rect">
+            <a:avLst/>
+          </a:prstGeom>
+          <a:noFill/>
+        </p:spPr>
+        <p:txBody>
+          <a:bodyPr wrap="square" lIns="0" tIns="0" rIns="0" bIns="0" anchor="t">
+            <a:spAutoFit/>
+          </a:bodyPr>
+          <a:lstStyle/>
+          <a:p>
+            <a:pPr algn="l">
+              <a:lnSpc>
+                <a:spcPct val="110000"/>
+              </a:lnSpc>
+              <a:spcAft>
+                <a:spcPts val="0"/>
+              </a:spcAft>
+            </a:pPr>
+            <a:r>
+              <a:rPr sz="880" b="0" i="0">
+                <a:solidFill>
+                  <a:srgbClr val="556A83"/>
+                </a:solidFill>
+                <a:latin typeface="Arial"/>
+              </a:rPr>
+              <a:t>Market Context</a:t>
+            </a:r>
+          </a:p>
+        </p:txBody>
+      </p:sp>
+      <p:sp>
+        <p:nvSpPr>
+          <p:cNvPr id="6" name="Rectangle 5"/>
+          <p:cNvSpPr/>
+          <p:nvPr/>
+        </p:nvSpPr>
+        <p:spPr>
+          <a:xfrm>
+            <a:off x="0" y="604723"/>
+            <a:ext cx="9753600" cy="1414272"/>
+          </a:xfrm>
+          <a:prstGeom prst="rect">
+            <a:avLst/>
+          </a:prstGeom>
+          <a:solidFill>
+            <a:srgbClr val="F6F7F9"/>
+          </a:solidFill>
+          <a:ln>
+            <a:noFill/>
+          </a:ln>
+          <a:effectLst/>
+        </p:spPr>
+        <p:style>
+          <a:lnRef idx="1">
+            <a:schemeClr val="accent1"/>
+          </a:lnRef>
+          <a:fillRef idx="3">
+            <a:schemeClr val="accent1"/>
+          </a:fillRef>
+          <a:effectRef idx="2">
+            <a:schemeClr val="accent1"/>
+          </a:effectRef>
+          <a:fontRef idx="minor">
+            <a:schemeClr val="lt1"/>
+          </a:fontRef>
+        </p:style>
+        <p:txBody>
+          <a:bodyPr rtlCol="0" anchor="ctr"/>
+          <a:lstStyle/>
+          <a:p>
+            <a:pPr algn="ctr"/>
+            <a:endParaRPr/>
+          </a:p>
+        </p:txBody>
+      </p:sp>
+      <p:sp>
+        <p:nvSpPr>
+          <p:cNvPr id="7" name="TextBox 6"/>
+          <p:cNvSpPr txBox="1"/>
+          <p:nvPr/>
+        </p:nvSpPr>
+        <p:spPr>
+          <a:xfrm>
+            <a:off x="438922" y="721766"/>
+            <a:ext cx="8851613" cy="829056"/>
+          </a:xfrm>
+          <a:prstGeom prst="rect">
+            <a:avLst/>
+          </a:prstGeom>
+          <a:noFill/>
+        </p:spPr>
+        <p:txBody>
+          <a:bodyPr wrap="square" lIns="0" tIns="0" rIns="0" bIns="0" anchor="t">
+            <a:spAutoFit/>
+          </a:bodyPr>
+          <a:lstStyle/>
+          <a:p>
+            <a:pPr algn="l">
+              <a:lnSpc>
+                <a:spcPct val="110000"/>
+              </a:lnSpc>
+              <a:spcAft>
+                <a:spcPts val="200"/>
+              </a:spcAft>
+            </a:pPr>
+            <a:r>
+              <a:rPr sz="2400" b="0" i="0" spc="-90">
+                <a:solidFill>
+                  <a:srgbClr val="314359"/>
+                </a:solidFill>
+                <a:latin typeface="Times New Roman"/>
+              </a:rPr>
+              <a:t>Why parts of the market may be overvalued</a:t>
+            </a:r>
+          </a:p>
+        </p:txBody>
+      </p:sp>
+      <p:sp>
+        <p:nvSpPr>
+          <p:cNvPr id="8" name="TextBox 7"/>
+          <p:cNvSpPr txBox="1"/>
+          <p:nvPr/>
+        </p:nvSpPr>
+        <p:spPr>
+          <a:xfrm>
+            <a:off x="453553" y="1511808"/>
+            <a:ext cx="8705305" cy="487680"/>
+          </a:xfrm>
+          <a:prstGeom prst="rect">
+            <a:avLst/>
+          </a:prstGeom>
+          <a:noFill/>
+        </p:spPr>
+        <p:txBody>
+          <a:bodyPr wrap="square" lIns="0" tIns="0" rIns="0" bIns="0" anchor="t">
+            <a:spAutoFit/>
+          </a:bodyPr>
+          <a:lstStyle/>
+          <a:p>
+            <a:pPr algn="l">
+              <a:lnSpc>
+                <a:spcPct val="110000"/>
+              </a:lnSpc>
+              <a:spcAft>
+                <a:spcPts val="0"/>
+              </a:spcAft>
+            </a:pPr>
+            <a:r>
+              <a:rPr sz="1040" b="0" i="1">
+                <a:solidFill>
+                  <a:srgbClr val="556A83"/>
+                </a:solidFill>
+                <a:latin typeface="Arial"/>
+              </a:rPr>
+              <a:t>Fifty years of peer-reviewed research, mapped onto today's race for the hardest-to-value assets.</a:t>
+            </a:r>
+          </a:p>
+        </p:txBody>
+      </p:sp>
+      <p:sp>
+        <p:nvSpPr>
+          <p:cNvPr id="9" name="TextBox 8"/>
+          <p:cNvSpPr txBox="1"/>
+          <p:nvPr/>
+        </p:nvSpPr>
+        <p:spPr>
+          <a:xfrm>
+            <a:off x="6583844" y="6876288"/>
+            <a:ext cx="2926153" cy="292608"/>
+          </a:xfrm>
+          <a:prstGeom prst="rect">
+            <a:avLst/>
+          </a:prstGeom>
+          <a:noFill/>
+        </p:spPr>
+        <p:txBody>
+          <a:bodyPr wrap="square" lIns="0" tIns="0" rIns="0" bIns="0" anchor="t">
+            <a:spAutoFit/>
+          </a:bodyPr>
+          <a:lstStyle/>
+          <a:p>
+            <a:pPr algn="r">
+              <a:lnSpc>
+                <a:spcPct val="110000"/>
+              </a:lnSpc>
+              <a:spcAft>
+                <a:spcPts val="0"/>
+              </a:spcAft>
+            </a:pPr>
+            <a:r>
+              <a:rPr sz="680" b="0" i="0">
+                <a:solidFill>
+                  <a:srgbClr val="556A83"/>
+                </a:solidFill>
+                <a:latin typeface="Arial"/>
+              </a:rPr>
+              <a:t>Strictly confidential          25</a:t>
+            </a:r>
+          </a:p>
+        </p:txBody>
+      </p:sp>
+      <p:graphicFrame>
+        <p:nvGraphicFramePr>
+          <p:cNvPr id="10" name="Table 9"/>
+          <p:cNvGraphicFramePr>
+            <a:graphicFrameLocks noGrp="1"/>
+          </p:cNvGraphicFramePr>
+          <p:nvPr/>
+        </p:nvGraphicFramePr>
+        <p:xfrm>
+          <a:off x="512064" y="2249424"/>
+          <a:ext cx="8796528" cy="1645920"/>
+        </p:xfrm>
+        <a:graphic>
+          <a:graphicData uri="http://schemas.openxmlformats.org/drawingml/2006/table">
+            <a:tbl>
+              <a:tblPr>
+                <a:tableStyleId>{2D5ABB26-0587-4C30-8999-92F81FD0307C}</a:tableStyleId>
+              </a:tblPr>
+              <a:tblGrid>
+                <a:gridCol w="4828032"/>
+                <a:gridCol w="3968496"/>
+              </a:tblGrid>
+              <a:tr h="274320">
+                <a:tc>
+                  <a:txBody>
+                    <a:bodyPr wrap="square"/>
+                    <a:lstStyle/>
+                    <a:p>
+                      <a:r>
+                        <a:rPr sz="800" b="1">
+                          <a:solidFill>
+                            <a:srgbClr val="556A83"/>
+                          </a:solidFill>
+                          <a:latin typeface="Arial"/>
+                        </a:rPr>
+                        <a:t>WHAT THE RESEARCH SHOWS</a:t>
+                      </a:r>
+                    </a:p>
+                  </a:txBody>
+                  <a:tcPr marL="82296" marR="91440" marT="36576" marB="36576" anchor="t">
+                    <a:solidFill>
+                      <a:srgbClr val="FFFFFF"/>
+                    </a:solidFill>
+                  </a:tcPr>
+                </a:tc>
+                <a:tc>
+                  <a:txBody>
+                    <a:bodyPr wrap="square"/>
+                    <a:lstStyle/>
+                    <a:p>
+                      <a:r>
+                        <a:rPr sz="800" b="1">
+                          <a:solidFill>
+                            <a:srgbClr val="556A83"/>
+                          </a:solidFill>
+                          <a:latin typeface="Arial"/>
+                        </a:rPr>
+                        <a:t>WHAT WE SEE TODAY · 2026</a:t>
+                      </a:r>
+                    </a:p>
+                  </a:txBody>
+                  <a:tcPr marL="82296" marR="91440" marT="36576" marB="36576" anchor="t">
+                    <a:solidFill>
+                      <a:srgbClr val="FFFFFF"/>
+                    </a:solidFill>
+                  </a:tcPr>
+                </a:tc>
+              </a:tr>
+              <a:tr h="274320">
+                <a:tc>
+                  <a:txBody>
+                    <a:bodyPr wrap="square"/>
+                    <a:lstStyle/>
+                    <a:p>
+                      <a:r>
+                        <a:rPr sz="830" b="1">
+                          <a:solidFill>
+                            <a:srgbClr val="314359"/>
+                          </a:solidFill>
+                          <a:latin typeface="Arial"/>
+                        </a:rPr>
+                        <a:t>Uncertainty inflates price.</a:t>
+                      </a:r>
+                      <a:r>
+                        <a:rPr sz="830" b="0">
+                          <a:solidFill>
+                            <a:srgbClr val="0E1620"/>
+                          </a:solidFill>
+                          <a:latin typeface="Arial"/>
+                        </a:rPr>
+                        <a:t> Unknowable prospects, and pessimists who can't short, leave the optimists to set the price — equity turns option-like, so more uncertainty lifts the valuation. (Miller 1977; Pástor–Veronesi 2009; Scheinkman–Xiong 2003)</a:t>
+                      </a:r>
+                    </a:p>
+                  </a:txBody>
+                  <a:tcPr marL="82296" marR="91440" marT="36576" marB="36576" anchor="t">
+                    <a:solidFill>
+                      <a:srgbClr val="FFFFFF"/>
+                    </a:solidFill>
+                  </a:tcPr>
+                </a:tc>
+                <a:tc>
+                  <a:txBody>
+                    <a:bodyPr wrap="square"/>
+                    <a:lstStyle/>
+                    <a:p>
+                      <a:r>
+                        <a:rPr sz="830" b="0">
+                          <a:solidFill>
+                            <a:srgbClr val="0E1620"/>
+                          </a:solidFill>
+                          <a:latin typeface="Arial"/>
+                        </a:rPr>
+                        <a:t>The most-wanted assets are the least-knowable: SpaceX listed at a reported </a:t>
+                      </a:r>
+                      <a:r>
+                        <a:rPr sz="830" b="1">
+                          <a:solidFill>
+                            <a:srgbClr val="314359"/>
+                          </a:solidFill>
+                          <a:latin typeface="Arial"/>
+                        </a:rPr>
+                        <a:t>~$1.8tn</a:t>
+                      </a:r>
+                      <a:r>
+                        <a:rPr sz="830" b="0">
+                          <a:solidFill>
+                            <a:srgbClr val="0E1620"/>
+                          </a:solidFill>
+                          <a:latin typeface="Arial"/>
+                        </a:rPr>
+                        <a:t>; </a:t>
+                      </a:r>
+                      <a:r>
+                        <a:rPr sz="830" b="1">
+                          <a:solidFill>
+                            <a:srgbClr val="314359"/>
+                          </a:solidFill>
+                          <a:latin typeface="Arial"/>
+                        </a:rPr>
+                        <a:t>Anthropic ~$965bn</a:t>
+                      </a:r>
+                      <a:r>
+                        <a:rPr sz="830" b="0">
+                          <a:solidFill>
+                            <a:srgbClr val="0E1620"/>
+                          </a:solidFill>
+                          <a:latin typeface="Arial"/>
+                        </a:rPr>
+                        <a:t> and </a:t>
+                      </a:r>
+                      <a:r>
+                        <a:rPr sz="830" b="1">
+                          <a:solidFill>
+                            <a:srgbClr val="314359"/>
+                          </a:solidFill>
+                          <a:latin typeface="Arial"/>
+                        </a:rPr>
+                        <a:t>OpenAI ~$830bn</a:t>
+                      </a:r>
+                      <a:r>
+                        <a:rPr sz="830" b="0">
+                          <a:solidFill>
+                            <a:srgbClr val="0E1620"/>
+                          </a:solidFill>
+                          <a:latin typeface="Arial"/>
+                        </a:rPr>
+                        <a:t> in private rounds — still deeply loss-making.</a:t>
+                      </a:r>
+                    </a:p>
+                  </a:txBody>
+                  <a:tcPr marL="82296" marR="91440" marT="36576" marB="36576" anchor="t">
+                    <a:solidFill>
+                      <a:srgbClr val="FFFFFF"/>
+                    </a:solidFill>
+                  </a:tcPr>
+                </a:tc>
+              </a:tr>
+              <a:tr h="274320">
+                <a:tc>
+                  <a:txBody>
+                    <a:bodyPr wrap="square"/>
+                    <a:lstStyle/>
+                    <a:p>
+                      <a:r>
+                        <a:rPr sz="830" b="1">
+                          <a:solidFill>
+                            <a:srgbClr val="314359"/>
+                          </a:solidFill>
+                          <a:latin typeface="Arial"/>
+                        </a:rPr>
+                        <a:t>Disagreement reverts.</a:t>
+                      </a:r>
+                      <a:r>
+                        <a:rPr sz="830" b="0">
+                          <a:solidFill>
+                            <a:srgbClr val="0E1620"/>
+                          </a:solidFill>
+                          <a:latin typeface="Arial"/>
+                        </a:rPr>
+                        <a:t> The most-disputed stocks are systematically overpriced; the highest forecast-dispersion names underperform by </a:t>
+                      </a:r>
+                      <a:r>
+                        <a:rPr sz="830" b="1">
+                          <a:solidFill>
+                            <a:srgbClr val="314359"/>
+                          </a:solidFill>
+                          <a:latin typeface="Arial"/>
+                        </a:rPr>
+                        <a:t>~9.5% a year</a:t>
+                      </a:r>
+                      <a:r>
+                        <a:rPr sz="830" b="0">
+                          <a:solidFill>
+                            <a:srgbClr val="0E1620"/>
+                          </a:solidFill>
+                          <a:latin typeface="Arial"/>
+                        </a:rPr>
+                        <a:t>. (Diether–Malloy–Scherbina 2002; Hong–Stein 2007)</a:t>
+                      </a:r>
+                    </a:p>
+                  </a:txBody>
+                  <a:tcPr marL="82296" marR="91440" marT="36576" marB="36576" anchor="t">
+                    <a:solidFill>
+                      <a:srgbClr val="F4F6F8"/>
+                    </a:solidFill>
+                  </a:tcPr>
+                </a:tc>
+                <a:tc>
+                  <a:txBody>
+                    <a:bodyPr wrap="square"/>
+                    <a:lstStyle/>
+                    <a:p>
+                      <a:r>
+                        <a:rPr sz="830" b="0">
+                          <a:solidFill>
+                            <a:srgbClr val="0E1620"/>
+                          </a:solidFill>
+                          <a:latin typeface="Arial"/>
+                        </a:rPr>
+                        <a:t>Nothing divides opinion like AI's terminal value — and newly- or not-yet-listed names are among the </a:t>
+                      </a:r>
+                      <a:r>
+                        <a:rPr sz="830" b="1">
+                          <a:solidFill>
+                            <a:srgbClr val="314359"/>
+                          </a:solidFill>
+                          <a:latin typeface="Arial"/>
+                        </a:rPr>
+                        <a:t>hardest to short</a:t>
+                      </a:r>
+                      <a:r>
+                        <a:rPr sz="830" b="0">
+                          <a:solidFill>
+                            <a:srgbClr val="0E1620"/>
+                          </a:solidFill>
+                          <a:latin typeface="Arial"/>
+                        </a:rPr>
+                        <a:t>.</a:t>
+                      </a:r>
+                    </a:p>
+                  </a:txBody>
+                  <a:tcPr marL="82296" marR="91440" marT="36576" marB="36576" anchor="t">
+                    <a:solidFill>
+                      <a:srgbClr val="F4F6F8"/>
+                    </a:solidFill>
+                  </a:tcPr>
+                </a:tc>
+              </a:tr>
+              <a:tr h="274320">
+                <a:tc>
+                  <a:txBody>
+                    <a:bodyPr wrap="square"/>
+                    <a:lstStyle/>
+                    <a:p>
+                      <a:r>
+                        <a:rPr sz="830" b="1">
+                          <a:solidFill>
+                            <a:srgbClr val="314359"/>
+                          </a:solidFill>
+                          <a:latin typeface="Arial"/>
+                        </a:rPr>
+                        <a:t>IPO waves underperform.</a:t>
+                      </a:r>
+                      <a:r>
+                        <a:rPr sz="830" b="0">
+                          <a:solidFill>
+                            <a:srgbClr val="0E1620"/>
+                          </a:solidFill>
+                          <a:latin typeface="Arial"/>
+                        </a:rPr>
+                        <a:t> New issues returned </a:t>
+                      </a:r>
+                      <a:r>
+                        <a:rPr sz="830" b="1">
+                          <a:solidFill>
+                            <a:srgbClr val="314359"/>
+                          </a:solidFill>
+                          <a:latin typeface="Arial"/>
+                        </a:rPr>
+                        <a:t>34.5% vs 61.9%</a:t>
+                      </a:r>
+                      <a:r>
+                        <a:rPr sz="830" b="0">
+                          <a:solidFill>
+                            <a:srgbClr val="0E1620"/>
+                          </a:solidFill>
+                          <a:latin typeface="Arial"/>
+                        </a:rPr>
+                        <a:t> for matched firms over three years — worst in hot years and for unprofitable issuers. (Ritter 1991; Loughran–Ritter 1995; Ibbotson–Jaffe 1975)</a:t>
+                      </a:r>
+                    </a:p>
+                  </a:txBody>
+                  <a:tcPr marL="82296" marR="91440" marT="36576" marB="36576" anchor="t">
+                    <a:solidFill>
+                      <a:srgbClr val="FFFFFF"/>
+                    </a:solidFill>
+                  </a:tcPr>
+                </a:tc>
+                <a:tc>
+                  <a:txBody>
+                    <a:bodyPr wrap="square"/>
+                    <a:lstStyle/>
+                    <a:p>
+                      <a:r>
+                        <a:rPr sz="830" b="0">
+                          <a:solidFill>
+                            <a:srgbClr val="0E1620"/>
+                          </a:solidFill>
+                          <a:latin typeface="Arial"/>
+                        </a:rPr>
+                        <a:t>2025–26 is the </a:t>
+                      </a:r>
+                      <a:r>
+                        <a:rPr sz="830" b="1">
+                          <a:solidFill>
+                            <a:srgbClr val="314359"/>
+                          </a:solidFill>
+                          <a:latin typeface="Arial"/>
+                        </a:rPr>
+                        <a:t>most AI-concentrated IPO market on record</a:t>
+                      </a:r>
+                      <a:r>
+                        <a:rPr sz="830" b="0">
+                          <a:solidFill>
+                            <a:srgbClr val="0E1620"/>
+                          </a:solidFill>
+                          <a:latin typeface="Arial"/>
+                        </a:rPr>
+                        <a:t>; SpaceX was the </a:t>
+                      </a:r>
+                      <a:r>
+                        <a:rPr sz="830" b="1">
+                          <a:solidFill>
+                            <a:srgbClr val="314359"/>
+                          </a:solidFill>
+                          <a:latin typeface="Arial"/>
+                        </a:rPr>
+                        <a:t>largest IPO in history</a:t>
+                      </a:r>
+                      <a:r>
+                        <a:rPr sz="830" b="0">
+                          <a:solidFill>
+                            <a:srgbClr val="0E1620"/>
+                          </a:solidFill>
+                          <a:latin typeface="Arial"/>
+                        </a:rPr>
+                        <a:t>, with OpenAI and Anthropic reportedly next.</a:t>
+                      </a:r>
+                    </a:p>
+                  </a:txBody>
+                  <a:tcPr marL="82296" marR="91440" marT="36576" marB="36576" anchor="t">
+                    <a:solidFill>
+                      <a:srgbClr val="FFFFFF"/>
+                    </a:solidFill>
+                  </a:tcPr>
+                </a:tc>
+              </a:tr>
+              <a:tr h="274320">
+                <a:tc>
+                  <a:txBody>
+                    <a:bodyPr wrap="square"/>
+                    <a:lstStyle/>
+                    <a:p>
+                      <a:r>
+                        <a:rPr sz="830" b="1">
+                          <a:solidFill>
+                            <a:srgbClr val="314359"/>
+                          </a:solidFill>
+                          <a:latin typeface="Arial"/>
+                        </a:rPr>
+                        <a:t>The dot-com template.</a:t>
+                      </a:r>
+                      <a:r>
+                        <a:rPr sz="830" b="0">
+                          <a:solidFill>
+                            <a:srgbClr val="0E1620"/>
+                          </a:solidFill>
+                          <a:latin typeface="Arial"/>
+                        </a:rPr>
+                        <a:t> Internet stocks hit </a:t>
+                      </a:r>
+                      <a:r>
+                        <a:rPr sz="830" b="1">
+                          <a:solidFill>
+                            <a:srgbClr val="314359"/>
+                          </a:solidFill>
+                          <a:latin typeface="Arial"/>
+                        </a:rPr>
+                        <a:t>~6% of US market value</a:t>
+                      </a:r>
+                      <a:r>
+                        <a:rPr sz="830" b="0">
+                          <a:solidFill>
+                            <a:srgbClr val="0E1620"/>
+                          </a:solidFill>
+                          <a:latin typeface="Arial"/>
+                        </a:rPr>
+                        <a:t> on a sliver of the fundamentals, then crashed; arbitrage failed and the smart money rode it. (Ofek–Richardson 2003; Lamont–Thaler 2003; Brunnermeier–Nagel 2004)</a:t>
+                      </a:r>
+                    </a:p>
+                  </a:txBody>
+                  <a:tcPr marL="82296" marR="91440" marT="36576" marB="36576" anchor="t">
+                    <a:solidFill>
+                      <a:srgbClr val="F4F6F8"/>
+                    </a:solidFill>
+                  </a:tcPr>
+                </a:tc>
+                <a:tc>
+                  <a:txBody>
+                    <a:bodyPr wrap="square"/>
+                    <a:lstStyle/>
+                    <a:p>
+                      <a:r>
+                        <a:rPr sz="830" b="0">
+                          <a:solidFill>
+                            <a:srgbClr val="0E1620"/>
+                          </a:solidFill>
+                          <a:latin typeface="Arial"/>
+                        </a:rPr>
+                        <a:t>The </a:t>
+                      </a:r>
+                      <a:r>
+                        <a:rPr sz="830" b="1">
+                          <a:solidFill>
+                            <a:srgbClr val="314359"/>
+                          </a:solidFill>
+                          <a:latin typeface="Arial"/>
+                        </a:rPr>
+                        <a:t>“Magnificent Seven” are ~35%</a:t>
+                      </a:r>
+                      <a:r>
+                        <a:rPr sz="830" b="0">
+                          <a:solidFill>
+                            <a:srgbClr val="0E1620"/>
+                          </a:solidFill>
+                          <a:latin typeface="Arial"/>
+                        </a:rPr>
+                        <a:t> of the S&amp;P 500 (12% in 2015); the </a:t>
+                      </a:r>
+                      <a:r>
+                        <a:rPr sz="830" b="1">
+                          <a:solidFill>
+                            <a:srgbClr val="314359"/>
+                          </a:solidFill>
+                          <a:latin typeface="Arial"/>
+                        </a:rPr>
+                        <a:t>Shiller CAPE is ~40</a:t>
+                      </a:r>
+                      <a:r>
+                        <a:rPr sz="830" b="0">
+                          <a:solidFill>
+                            <a:srgbClr val="0E1620"/>
+                          </a:solidFill>
+                          <a:latin typeface="Arial"/>
+                        </a:rPr>
+                        <a:t> — near its 2000 record.</a:t>
+                      </a:r>
+                    </a:p>
+                  </a:txBody>
+                  <a:tcPr marL="82296" marR="91440" marT="36576" marB="36576" anchor="t">
+                    <a:solidFill>
+                      <a:srgbClr val="F4F6F8"/>
+                    </a:solidFill>
+                  </a:tcPr>
+                </a:tc>
+              </a:tr>
+              <a:tr h="274320">
+                <a:tc>
+                  <a:txBody>
+                    <a:bodyPr wrap="square"/>
+                    <a:lstStyle/>
+                    <a:p>
+                      <a:r>
+                        <a:rPr sz="830" b="1">
+                          <a:solidFill>
+                            <a:srgbClr val="314359"/>
+                          </a:solidFill>
+                          <a:latin typeface="Arial"/>
+                        </a:rPr>
+                        <a:t>Run-ups carry crash odds.</a:t>
+                      </a:r>
+                      <a:r>
+                        <a:rPr sz="830" b="0">
+                          <a:solidFill>
+                            <a:srgbClr val="0E1620"/>
+                          </a:solidFill>
+                          <a:latin typeface="Arial"/>
+                        </a:rPr>
+                        <a:t> After an industry doubles in two years, a 40% crash follows </a:t>
+                      </a:r>
+                      <a:r>
+                        <a:rPr sz="830" b="1">
+                          <a:solidFill>
+                            <a:srgbClr val="314359"/>
+                          </a:solidFill>
+                          <a:latin typeface="Arial"/>
+                        </a:rPr>
+                        <a:t>~53%</a:t>
+                      </a:r>
+                      <a:r>
+                        <a:rPr sz="830" b="0">
+                          <a:solidFill>
+                            <a:srgbClr val="0E1620"/>
+                          </a:solidFill>
+                          <a:latin typeface="Arial"/>
+                        </a:rPr>
+                        <a:t> of the time (</a:t>
+                      </a:r>
+                      <a:r>
+                        <a:rPr sz="830" b="1">
+                          <a:solidFill>
+                            <a:srgbClr val="314359"/>
+                          </a:solidFill>
+                          <a:latin typeface="Arial"/>
+                        </a:rPr>
+                        <a:t>~80%</a:t>
+                      </a:r>
+                      <a:r>
+                        <a:rPr sz="830" b="0">
+                          <a:solidFill>
+                            <a:srgbClr val="0E1620"/>
+                          </a:solidFill>
+                          <a:latin typeface="Arial"/>
+                        </a:rPr>
+                        <a:t> after +150%); a high CAPE foreshadows weak long-run returns. (Greenwood–Shleifer–You 2019; Campbell–Shiller 1988)</a:t>
+                      </a:r>
+                    </a:p>
+                  </a:txBody>
+                  <a:tcPr marL="82296" marR="91440" marT="36576" marB="36576" anchor="t">
+                    <a:solidFill>
+                      <a:srgbClr val="FFFFFF"/>
+                    </a:solidFill>
+                  </a:tcPr>
+                </a:tc>
+                <a:tc>
+                  <a:txBody>
+                    <a:bodyPr wrap="square"/>
+                    <a:lstStyle/>
+                    <a:p>
+                      <a:r>
+                        <a:rPr sz="830" b="0">
+                          <a:solidFill>
+                            <a:srgbClr val="0E1620"/>
+                          </a:solidFill>
+                          <a:latin typeface="Arial"/>
+                        </a:rPr>
+                        <a:t>Leading AI names have </a:t>
+                      </a:r>
+                      <a:r>
+                        <a:rPr sz="830" b="1">
+                          <a:solidFill>
+                            <a:srgbClr val="314359"/>
+                          </a:solidFill>
+                          <a:latin typeface="Arial"/>
+                        </a:rPr>
+                        <a:t>more than doubled in two years</a:t>
+                      </a:r>
+                      <a:r>
+                        <a:rPr sz="830" b="0">
+                          <a:solidFill>
+                            <a:srgbClr val="0E1620"/>
+                          </a:solidFill>
+                          <a:latin typeface="Arial"/>
+                        </a:rPr>
+                        <a:t> — squarely in the range where crash probability passes one-in-two.</a:t>
+                      </a:r>
+                    </a:p>
+                  </a:txBody>
+                  <a:tcPr marL="82296" marR="91440" marT="36576" marB="36576" anchor="t">
+                    <a:solidFill>
+                      <a:srgbClr val="FFFFFF"/>
+                    </a:solidFill>
+                  </a:tcPr>
+                </a:tc>
+              </a:tr>
+            </a:tbl>
+          </a:graphicData>
+        </a:graphic>
+      </p:graphicFrame>
+      <p:sp>
+        <p:nvSpPr>
+          <p:cNvPr id="11" name="Rectangle 10"/>
+          <p:cNvSpPr/>
+          <p:nvPr/>
+        </p:nvSpPr>
+        <p:spPr>
+          <a:xfrm>
+            <a:off x="438912" y="6035040"/>
+            <a:ext cx="8878824" cy="566928"/>
+          </a:xfrm>
+          <a:prstGeom prst="rect">
+            <a:avLst/>
+          </a:prstGeom>
+          <a:solidFill>
+            <a:srgbClr val="152130"/>
+          </a:solidFill>
+          <a:ln>
+            <a:noFill/>
+          </a:ln>
+          <a:effectLst/>
+        </p:spPr>
+        <p:style>
+          <a:lnRef idx="1">
+            <a:schemeClr val="accent1"/>
+          </a:lnRef>
+          <a:fillRef idx="3">
+            <a:schemeClr val="accent1"/>
+          </a:fillRef>
+          <a:effectRef idx="2">
+            <a:schemeClr val="accent1"/>
+          </a:effectRef>
+          <a:fontRef idx="minor">
+            <a:schemeClr val="lt1"/>
+          </a:fontRef>
+        </p:style>
+        <p:txBody>
+          <a:bodyPr rtlCol="0" anchor="ctr" wrap="square" lIns="128016" rIns="128016" tIns="36576" bIns="36576"/>
+          <a:lstStyle/>
+          <a:p>
+            <a:pPr algn="ctr"/>
+            <a:r>
+              <a:rPr sz="900" b="0">
+                <a:solidFill>
+                  <a:srgbClr val="FFFFFF"/>
+                </a:solidFill>
+                <a:latin typeface="Arial"/>
+              </a:rPr>
+              <a:t>None of this dates the top — bubbles persist precisely because rational investors ride them rather than fight them (Abreu–Brunnermeier 2003). It is the case for diversifying an index that has become a concentrated bet on the market's hardest-to-value assets into a strategy priced on </a:t>
+            </a:r>
+            <a:r>
+              <a:rPr sz="900" b="1">
+                <a:solidFill>
+                  <a:srgbClr val="FFFFFF"/>
+                </a:solidFill>
+                <a:latin typeface="Arial"/>
+              </a:rPr>
+              <a:t>realised cash flows</a:t>
+            </a:r>
+            <a:r>
+              <a:rPr sz="900" b="0">
+                <a:solidFill>
+                  <a:srgbClr val="FFFFFF"/>
+                </a:solidFill>
+                <a:latin typeface="Arial"/>
+              </a:rPr>
+              <a:t>.</a:t>
+            </a:r>
+          </a:p>
+        </p:txBody>
+      </p:sp>
+      <p:sp>
+        <p:nvSpPr>
+          <p:cNvPr id="12" name="TextBox 11"/>
+          <p:cNvSpPr txBox="1"/>
+          <p:nvPr/>
+        </p:nvSpPr>
+        <p:spPr>
+          <a:xfrm>
+            <a:off x="512064" y="6656832"/>
+            <a:ext cx="8778240" cy="274320"/>
+          </a:xfrm>
+          <a:prstGeom prst="rect">
+            <a:avLst/>
+          </a:prstGeom>
+          <a:noFill/>
+        </p:spPr>
+        <p:txBody>
+          <a:bodyPr wrap="square" lIns="0" rIns="0" tIns="0" bIns="0">
+            <a:spAutoFit/>
+          </a:bodyPr>
+          <a:lstStyle/>
+          <a:p>
+            <a:r>
+              <a:rPr sz="650" b="0">
+                <a:solidFill>
+                  <a:srgbClr val="8A939F"/>
+                </a:solidFill>
+                <a:latin typeface="Arial"/>
+              </a:rPr>
+              <a:t>Peer-reviewed citations on the following page. Company valuations are reported 2026 figures, including private rounds; some IPO details are press-reported and may be revised.</a:t>
+            </a:r>
+          </a:p>
+        </p:txBody>
+      </p:sp>
+    </p:spTree>
+  </p:cSld>
+  <p:clrMapOvr>
+    <a:masterClrMapping/>
+  </p:clrMapOvr>
+</p:sld>
+</file>
+
+<file path=ppt/slides/slide26.xml><?xml version="1.0" encoding="utf-8"?>
+<p:sld xmlns:a="http://schemas.openxmlformats.org/drawingml/2006/main" xmlns:p="http://schemas.openxmlformats.org/presentationml/2006/main" xmlns:r="http://schemas.openxmlformats.org/officeDocument/2006/relationships">
+  <p:cSld>
+    <p:spTree>
+      <p:nvGrpSpPr>
+        <p:cNvPr id="1" name=""/>
+        <p:cNvGrpSpPr/>
+        <p:nvPr/>
+      </p:nvGrpSpPr>
+      <p:grpSpPr/>
+      <p:sp>
+        <p:nvSpPr>
+          <p:cNvPr id="2" name="Rectangle 1"/>
+          <p:cNvSpPr/>
+          <p:nvPr/>
+        </p:nvSpPr>
+        <p:spPr>
+          <a:xfrm>
+            <a:off x="0" y="0"/>
+            <a:ext cx="9753600" cy="7315200"/>
+          </a:xfrm>
+          <a:prstGeom prst="rect">
+            <a:avLst/>
+          </a:prstGeom>
+          <a:solidFill>
+            <a:srgbClr val="FFFFFF"/>
+          </a:solidFill>
+          <a:ln>
+            <a:noFill/>
+          </a:ln>
+          <a:effectLst/>
+        </p:spPr>
+        <p:style>
+          <a:lnRef idx="1">
+            <a:schemeClr val="accent1"/>
+          </a:lnRef>
+          <a:fillRef idx="3">
+            <a:schemeClr val="accent1"/>
+          </a:fillRef>
+          <a:effectRef idx="2">
+            <a:schemeClr val="accent1"/>
+          </a:effectRef>
+          <a:fontRef idx="minor">
+            <a:schemeClr val="lt1"/>
+          </a:fontRef>
+        </p:style>
+        <p:txBody>
+          <a:bodyPr rtlCol="0" anchor="ctr"/>
+          <a:lstStyle/>
+          <a:p>
+            <a:pPr algn="ctr"/>
+            <a:endParaRPr/>
+          </a:p>
+        </p:txBody>
+      </p:sp>
+      <p:pic>
+        <p:nvPicPr>
+          <p:cNvPr id="3" name="Picture 2" descr="mark_dark.png"/>
+          <p:cNvPicPr>
+            <a:picLocks noChangeAspect="1"/>
+          </p:cNvPicPr>
+          <p:nvPr/>
+        </p:nvPicPr>
+        <p:blipFill>
+          <a:blip r:embed="rId2"/>
+          <a:stretch>
+            <a:fillRect/>
+          </a:stretch>
+        </p:blipFill>
+        <p:spPr>
+          <a:xfrm>
+            <a:off x="402346" y="234086"/>
+            <a:ext cx="224012" cy="190199"/>
+          </a:xfrm>
+          <a:prstGeom prst="rect">
+            <a:avLst/>
+          </a:prstGeom>
+        </p:spPr>
+      </p:pic>
+      <p:sp>
+        <p:nvSpPr>
+          <p:cNvPr id="4" name="TextBox 3"/>
+          <p:cNvSpPr txBox="1"/>
+          <p:nvPr/>
+        </p:nvSpPr>
+        <p:spPr>
+          <a:xfrm>
+            <a:off x="716907" y="263347"/>
+            <a:ext cx="5120768" cy="292608"/>
+          </a:xfrm>
+          <a:prstGeom prst="rect">
+            <a:avLst/>
+          </a:prstGeom>
+          <a:noFill/>
+        </p:spPr>
+        <p:txBody>
+          <a:bodyPr wrap="square" lIns="0" tIns="0" rIns="0" bIns="0" anchor="t">
+            <a:spAutoFit/>
+          </a:bodyPr>
+          <a:lstStyle/>
+          <a:p>
+            <a:pPr algn="l">
+              <a:lnSpc>
+                <a:spcPct val="110000"/>
+              </a:lnSpc>
+              <a:spcAft>
+                <a:spcPts val="0"/>
+              </a:spcAft>
+            </a:pPr>
+            <a:r>
+              <a:rPr sz="880" b="0" i="0">
+                <a:solidFill>
+                  <a:srgbClr val="556A83"/>
+                </a:solidFill>
+                <a:latin typeface="Arial"/>
+              </a:rPr>
+              <a:t>Appendix</a:t>
+            </a:r>
+          </a:p>
+        </p:txBody>
+      </p:sp>
+      <p:sp>
+        <p:nvSpPr>
+          <p:cNvPr id="6" name="Rectangle 5"/>
+          <p:cNvSpPr/>
+          <p:nvPr/>
+        </p:nvSpPr>
+        <p:spPr>
+          <a:xfrm>
+            <a:off x="0" y="604723"/>
+            <a:ext cx="9753600" cy="1414272"/>
+          </a:xfrm>
+          <a:prstGeom prst="rect">
+            <a:avLst/>
+          </a:prstGeom>
+          <a:solidFill>
+            <a:srgbClr val="F6F7F9"/>
+          </a:solidFill>
+          <a:ln>
+            <a:noFill/>
+          </a:ln>
+          <a:effectLst/>
+        </p:spPr>
+        <p:style>
+          <a:lnRef idx="1">
+            <a:schemeClr val="accent1"/>
+          </a:lnRef>
+          <a:fillRef idx="3">
+            <a:schemeClr val="accent1"/>
+          </a:fillRef>
+          <a:effectRef idx="2">
+            <a:schemeClr val="accent1"/>
+          </a:effectRef>
+          <a:fontRef idx="minor">
+            <a:schemeClr val="lt1"/>
+          </a:fontRef>
+        </p:style>
+        <p:txBody>
+          <a:bodyPr rtlCol="0" anchor="ctr"/>
+          <a:lstStyle/>
+          <a:p>
+            <a:pPr algn="ctr"/>
+            <a:endParaRPr/>
+          </a:p>
+        </p:txBody>
+      </p:sp>
+      <p:sp>
+        <p:nvSpPr>
+          <p:cNvPr id="7" name="TextBox 6"/>
+          <p:cNvSpPr txBox="1"/>
+          <p:nvPr/>
+        </p:nvSpPr>
+        <p:spPr>
+          <a:xfrm>
+            <a:off x="438922" y="721766"/>
+            <a:ext cx="8851613" cy="829056"/>
+          </a:xfrm>
+          <a:prstGeom prst="rect">
+            <a:avLst/>
+          </a:prstGeom>
+          <a:noFill/>
+        </p:spPr>
+        <p:txBody>
+          <a:bodyPr wrap="square" lIns="0" tIns="0" rIns="0" bIns="0" anchor="t">
+            <a:spAutoFit/>
+          </a:bodyPr>
+          <a:lstStyle/>
+          <a:p>
+            <a:pPr algn="l">
+              <a:lnSpc>
+                <a:spcPct val="110000"/>
+              </a:lnSpc>
+              <a:spcAft>
+                <a:spcPts val="200"/>
+              </a:spcAft>
+            </a:pPr>
+            <a:r>
+              <a:rPr sz="2400" b="0" i="0" spc="-90">
+                <a:solidFill>
+                  <a:srgbClr val="314359"/>
+                </a:solidFill>
+                <a:latin typeface="Times New Roman"/>
+              </a:rPr>
+              <a:t>Sources &amp; references</a:t>
+            </a:r>
+          </a:p>
+        </p:txBody>
+      </p:sp>
+      <p:sp>
+        <p:nvSpPr>
+          <p:cNvPr id="8" name="TextBox 7"/>
+          <p:cNvSpPr txBox="1"/>
+          <p:nvPr/>
+        </p:nvSpPr>
+        <p:spPr>
+          <a:xfrm>
+            <a:off x="453553" y="1511808"/>
+            <a:ext cx="8705305" cy="487680"/>
+          </a:xfrm>
+          <a:prstGeom prst="rect">
+            <a:avLst/>
+          </a:prstGeom>
+          <a:noFill/>
+        </p:spPr>
+        <p:txBody>
+          <a:bodyPr wrap="square" lIns="0" tIns="0" rIns="0" bIns="0" anchor="t">
+            <a:spAutoFit/>
+          </a:bodyPr>
+          <a:lstStyle/>
+          <a:p>
+            <a:pPr algn="l">
+              <a:lnSpc>
+                <a:spcPct val="110000"/>
+              </a:lnSpc>
+              <a:spcAft>
+                <a:spcPts val="0"/>
+              </a:spcAft>
+            </a:pPr>
+            <a:r>
+              <a:rPr sz="1040" b="0" i="1">
+                <a:solidFill>
+                  <a:srgbClr val="556A83"/>
+                </a:solidFill>
+                <a:latin typeface="Arial"/>
+              </a:rPr>
+              <a:t>Peer-reviewed studies underpinning the preceding analysis; market data and contemporary reporting.</a:t>
+            </a:r>
+          </a:p>
+        </p:txBody>
+      </p:sp>
+      <p:sp>
+        <p:nvSpPr>
+          <p:cNvPr id="9" name="TextBox 8"/>
+          <p:cNvSpPr txBox="1"/>
+          <p:nvPr/>
+        </p:nvSpPr>
+        <p:spPr>
+          <a:xfrm>
+            <a:off x="6583844" y="6876288"/>
+            <a:ext cx="2926153" cy="292608"/>
+          </a:xfrm>
+          <a:prstGeom prst="rect">
+            <a:avLst/>
+          </a:prstGeom>
+          <a:noFill/>
+        </p:spPr>
+        <p:txBody>
+          <a:bodyPr wrap="square" lIns="0" tIns="0" rIns="0" bIns="0" anchor="t">
+            <a:spAutoFit/>
+          </a:bodyPr>
+          <a:lstStyle/>
+          <a:p>
+            <a:pPr algn="r">
+              <a:lnSpc>
+                <a:spcPct val="110000"/>
+              </a:lnSpc>
+              <a:spcAft>
+                <a:spcPts val="0"/>
+              </a:spcAft>
+            </a:pPr>
+            <a:r>
+              <a:rPr sz="680" b="0" i="0">
+                <a:solidFill>
+                  <a:srgbClr val="556A83"/>
+                </a:solidFill>
+                <a:latin typeface="Arial"/>
+              </a:rPr>
+              <a:t>Strictly confidential          26</a:t>
+            </a:r>
+          </a:p>
+        </p:txBody>
+      </p:sp>
+      <p:sp>
+        <p:nvSpPr>
+          <p:cNvPr id="10" name="Rectangle 9"/>
+          <p:cNvSpPr/>
+          <p:nvPr/>
+        </p:nvSpPr>
+        <p:spPr>
+          <a:xfrm>
+            <a:off x="5230368" y="2240280"/>
+            <a:ext cx="10972" cy="4069080"/>
+          </a:xfrm>
+          <a:prstGeom prst="rect">
+            <a:avLst/>
+          </a:prstGeom>
+          <a:solidFill>
+            <a:srgbClr val="DDE1E7"/>
+          </a:solidFill>
+          <a:ln>
+            <a:noFill/>
+          </a:ln>
+          <a:effectLst/>
+        </p:spPr>
+        <p:style>
+          <a:lnRef idx="1">
+            <a:schemeClr val="accent1"/>
+          </a:lnRef>
+          <a:fillRef idx="3">
+            <a:schemeClr val="accent1"/>
+          </a:fillRef>
+          <a:effectRef idx="2">
+            <a:schemeClr val="accent1"/>
+          </a:effectRef>
+          <a:fontRef idx="minor">
+            <a:schemeClr val="lt1"/>
+          </a:fontRef>
+        </p:style>
+        <p:txBody>
+          <a:bodyPr rtlCol="0" anchor="ctr"/>
+          <a:lstStyle/>
+          <a:p>
+            <a:pPr algn="ctr"/>
+          </a:p>
+        </p:txBody>
+      </p:sp>
+      <p:sp>
+        <p:nvSpPr>
+          <p:cNvPr id="11" name="TextBox 10"/>
+          <p:cNvSpPr txBox="1"/>
+          <p:nvPr/>
+        </p:nvSpPr>
+        <p:spPr>
+          <a:xfrm>
+            <a:off x="512064" y="2212848"/>
+            <a:ext cx="4572000" cy="274320"/>
+          </a:xfrm>
+          <a:prstGeom prst="rect">
+            <a:avLst/>
+          </a:prstGeom>
+          <a:noFill/>
+        </p:spPr>
+        <p:txBody>
+          <a:bodyPr wrap="square" lIns="0" rIns="0" tIns="0" bIns="0">
+            <a:spAutoFit/>
+          </a:bodyPr>
+          <a:lstStyle/>
+          <a:p>
+            <a:r>
+              <a:rPr sz="900" b="1">
+                <a:solidFill>
+                  <a:srgbClr val="556A83"/>
+                </a:solidFill>
+                <a:latin typeface="Arial"/>
+              </a:rPr>
+              <a:t>PEER-REVIEWED STUDIES</a:t>
+            </a:r>
+          </a:p>
+        </p:txBody>
+      </p:sp>
+      <p:sp>
+        <p:nvSpPr>
+          <p:cNvPr id="12" name="TextBox 11"/>
+          <p:cNvSpPr txBox="1"/>
+          <p:nvPr/>
+        </p:nvSpPr>
+        <p:spPr>
+          <a:xfrm>
+            <a:off x="5440680" y="2212848"/>
+            <a:ext cx="3886200" cy="274320"/>
+          </a:xfrm>
+          <a:prstGeom prst="rect">
+            <a:avLst/>
+          </a:prstGeom>
+          <a:noFill/>
+        </p:spPr>
+        <p:txBody>
+          <a:bodyPr wrap="square" lIns="0" rIns="0" tIns="0" bIns="0">
+            <a:spAutoFit/>
+          </a:bodyPr>
+          <a:lstStyle/>
+          <a:p>
+            <a:r>
+              <a:rPr sz="900" b="1">
+                <a:solidFill>
+                  <a:srgbClr val="556A83"/>
+                </a:solidFill>
+                <a:latin typeface="Arial"/>
+              </a:rPr>
+              <a:t>BOOK  ·  MARKET DATA  ·  REPORTING</a:t>
+            </a:r>
+          </a:p>
+        </p:txBody>
+      </p:sp>
+      <p:sp>
+        <p:nvSpPr>
+          <p:cNvPr id="13" name="TextBox 12"/>
+          <p:cNvSpPr txBox="1"/>
+          <p:nvPr/>
+        </p:nvSpPr>
+        <p:spPr>
+          <a:xfrm>
+            <a:off x="512064" y="2560320"/>
+            <a:ext cx="4617720" cy="3840480"/>
+          </a:xfrm>
+          <a:prstGeom prst="rect">
+            <a:avLst/>
+          </a:prstGeom>
+          <a:noFill/>
+        </p:spPr>
+        <p:txBody>
+          <a:bodyPr wrap="square" lIns="0" rIns="0" tIns="0" bIns="0">
+            <a:spAutoFit/>
+          </a:bodyPr>
+          <a:lstStyle/>
+          <a:p>
+            <a:pPr>
+              <a:spcAft>
+                <a:spcPts val="240"/>
+              </a:spcAft>
+            </a:pPr>
+            <a:r>
+              <a:rPr sz="740" b="1">
+                <a:solidFill>
+                  <a:srgbClr val="314359"/>
+                </a:solidFill>
+                <a:latin typeface="Arial"/>
+              </a:rPr>
+              <a:t>Miller, E. M. (1977).</a:t>
+            </a:r>
+            <a:r>
+              <a:rPr sz="740" b="0">
+                <a:solidFill>
+                  <a:srgbClr val="0E1620"/>
+                </a:solidFill>
+                <a:latin typeface="Arial"/>
+              </a:rPr>
+              <a:t> Risk, Uncertainty, and Divergence of Opinion. Journal of Finance 32(4): 1151–1168.</a:t>
+            </a:r>
+          </a:p>
+          <a:p>
+            <a:pPr>
+              <a:spcAft>
+                <a:spcPts val="240"/>
+              </a:spcAft>
+            </a:pPr>
+            <a:r>
+              <a:rPr sz="740" b="1">
+                <a:solidFill>
+                  <a:srgbClr val="314359"/>
+                </a:solidFill>
+                <a:latin typeface="Arial"/>
+              </a:rPr>
+              <a:t>Scheinkman, J. A. &amp; Xiong, W. (2003).</a:t>
+            </a:r>
+            <a:r>
+              <a:rPr sz="740" b="0">
+                <a:solidFill>
+                  <a:srgbClr val="0E1620"/>
+                </a:solidFill>
+                <a:latin typeface="Arial"/>
+              </a:rPr>
+              <a:t> Overconfidence and Speculative Bubbles. Journal of Political Economy 111(6): 1183–1219.</a:t>
+            </a:r>
+          </a:p>
+          <a:p>
+            <a:pPr>
+              <a:spcAft>
+                <a:spcPts val="240"/>
+              </a:spcAft>
+            </a:pPr>
+            <a:r>
+              <a:rPr sz="740" b="1">
+                <a:solidFill>
+                  <a:srgbClr val="314359"/>
+                </a:solidFill>
+                <a:latin typeface="Arial"/>
+              </a:rPr>
+              <a:t>Hong, H. &amp; Stein, J. C. (2007).</a:t>
+            </a:r>
+            <a:r>
+              <a:rPr sz="740" b="0">
+                <a:solidFill>
+                  <a:srgbClr val="0E1620"/>
+                </a:solidFill>
+                <a:latin typeface="Arial"/>
+              </a:rPr>
+              <a:t> Disagreement and the Stock Market. Journal of Economic Perspectives 21(2): 109–128.</a:t>
+            </a:r>
+          </a:p>
+          <a:p>
+            <a:pPr>
+              <a:spcAft>
+                <a:spcPts val="240"/>
+              </a:spcAft>
+            </a:pPr>
+            <a:r>
+              <a:rPr sz="740" b="1">
+                <a:solidFill>
+                  <a:srgbClr val="314359"/>
+                </a:solidFill>
+                <a:latin typeface="Arial"/>
+              </a:rPr>
+              <a:t>Diether, K. B., Malloy, C. J. &amp; Scherbina, A. (2002).</a:t>
+            </a:r>
+            <a:r>
+              <a:rPr sz="740" b="0">
+                <a:solidFill>
+                  <a:srgbClr val="0E1620"/>
+                </a:solidFill>
+                <a:latin typeface="Arial"/>
+              </a:rPr>
+              <a:t> Differences of Opinion and the Cross-Section of Stock Returns. Journal of Finance 57(5): 2113–2141.</a:t>
+            </a:r>
+          </a:p>
+          <a:p>
+            <a:pPr>
+              <a:spcAft>
+                <a:spcPts val="240"/>
+              </a:spcAft>
+            </a:pPr>
+            <a:r>
+              <a:rPr sz="740" b="1">
+                <a:solidFill>
+                  <a:srgbClr val="314359"/>
+                </a:solidFill>
+                <a:latin typeface="Arial"/>
+              </a:rPr>
+              <a:t>Pástor, Ľ. &amp; Veronesi, P. (2009).</a:t>
+            </a:r>
+            <a:r>
+              <a:rPr sz="740" b="0">
+                <a:solidFill>
+                  <a:srgbClr val="0E1620"/>
+                </a:solidFill>
+                <a:latin typeface="Arial"/>
+              </a:rPr>
+              <a:t> Technological Revolutions and Stock Prices. American Economic Review 99(4): 1451–1483.</a:t>
+            </a:r>
+          </a:p>
+          <a:p>
+            <a:pPr>
+              <a:spcAft>
+                <a:spcPts val="240"/>
+              </a:spcAft>
+            </a:pPr>
+            <a:r>
+              <a:rPr sz="740" b="1">
+                <a:solidFill>
+                  <a:srgbClr val="314359"/>
+                </a:solidFill>
+                <a:latin typeface="Arial"/>
+              </a:rPr>
+              <a:t>Pástor, Ľ. &amp; Veronesi, P. (2006).</a:t>
+            </a:r>
+            <a:r>
+              <a:rPr sz="740" b="0">
+                <a:solidFill>
+                  <a:srgbClr val="0E1620"/>
+                </a:solidFill>
+                <a:latin typeface="Arial"/>
+              </a:rPr>
+              <a:t> Was There a Nasdaq Bubble in the Late 1990s? Journal of Financial Economics 81(1): 61–100.</a:t>
+            </a:r>
+          </a:p>
+          <a:p>
+            <a:pPr>
+              <a:spcAft>
+                <a:spcPts val="240"/>
+              </a:spcAft>
+            </a:pPr>
+            <a:r>
+              <a:rPr sz="740" b="1">
+                <a:solidFill>
+                  <a:srgbClr val="314359"/>
+                </a:solidFill>
+                <a:latin typeface="Arial"/>
+              </a:rPr>
+              <a:t>Ofek, E. &amp; Richardson, M. (2003).</a:t>
+            </a:r>
+            <a:r>
+              <a:rPr sz="740" b="0">
+                <a:solidFill>
+                  <a:srgbClr val="0E1620"/>
+                </a:solidFill>
+                <a:latin typeface="Arial"/>
+              </a:rPr>
+              <a:t> DotCom Mania: The Rise and Fall of Internet Stock Prices. Journal of Finance 58(3): 1113–1137.</a:t>
+            </a:r>
+          </a:p>
+          <a:p>
+            <a:pPr>
+              <a:spcAft>
+                <a:spcPts val="240"/>
+              </a:spcAft>
+            </a:pPr>
+            <a:r>
+              <a:rPr sz="740" b="1">
+                <a:solidFill>
+                  <a:srgbClr val="314359"/>
+                </a:solidFill>
+                <a:latin typeface="Arial"/>
+              </a:rPr>
+              <a:t>Lamont, O. A. &amp; Thaler, R. H. (2003).</a:t>
+            </a:r>
+            <a:r>
+              <a:rPr sz="740" b="0">
+                <a:solidFill>
+                  <a:srgbClr val="0E1620"/>
+                </a:solidFill>
+                <a:latin typeface="Arial"/>
+              </a:rPr>
+              <a:t> Can the Market Add and Subtract? Journal of Political Economy 111(2): 227–268.</a:t>
+            </a:r>
+          </a:p>
+          <a:p>
+            <a:pPr>
+              <a:spcAft>
+                <a:spcPts val="240"/>
+              </a:spcAft>
+            </a:pPr>
+            <a:r>
+              <a:rPr sz="740" b="1">
+                <a:solidFill>
+                  <a:srgbClr val="314359"/>
+                </a:solidFill>
+                <a:latin typeface="Arial"/>
+              </a:rPr>
+              <a:t>Brunnermeier, M. K. &amp; Nagel, S. (2004).</a:t>
+            </a:r>
+            <a:r>
+              <a:rPr sz="740" b="0">
+                <a:solidFill>
+                  <a:srgbClr val="0E1620"/>
+                </a:solidFill>
+                <a:latin typeface="Arial"/>
+              </a:rPr>
+              <a:t> Hedge Funds and the Technology Bubble. Journal of Finance 59(5): 2013–2040.</a:t>
+            </a:r>
+          </a:p>
+          <a:p>
+            <a:pPr>
+              <a:spcAft>
+                <a:spcPts val="240"/>
+              </a:spcAft>
+            </a:pPr>
+            <a:r>
+              <a:rPr sz="740" b="1">
+                <a:solidFill>
+                  <a:srgbClr val="314359"/>
+                </a:solidFill>
+                <a:latin typeface="Arial"/>
+              </a:rPr>
+              <a:t>Abreu, D. &amp; Brunnermeier, M. K. (2003).</a:t>
+            </a:r>
+            <a:r>
+              <a:rPr sz="740" b="0">
+                <a:solidFill>
+                  <a:srgbClr val="0E1620"/>
+                </a:solidFill>
+                <a:latin typeface="Arial"/>
+              </a:rPr>
+              <a:t> Bubbles and Crashes. Econometrica 71(1): 173–204.</a:t>
+            </a:r>
+          </a:p>
+          <a:p>
+            <a:pPr>
+              <a:spcAft>
+                <a:spcPts val="240"/>
+              </a:spcAft>
+            </a:pPr>
+            <a:r>
+              <a:rPr sz="740" b="1">
+                <a:solidFill>
+                  <a:srgbClr val="314359"/>
+                </a:solidFill>
+                <a:latin typeface="Arial"/>
+              </a:rPr>
+              <a:t>Ritter, J. R. (1991).</a:t>
+            </a:r>
+            <a:r>
+              <a:rPr sz="740" b="0">
+                <a:solidFill>
+                  <a:srgbClr val="0E1620"/>
+                </a:solidFill>
+                <a:latin typeface="Arial"/>
+              </a:rPr>
+              <a:t> The Long-Run Performance of Initial Public Offerings. Journal of Finance 46(1): 3–27.</a:t>
+            </a:r>
+          </a:p>
+          <a:p>
+            <a:pPr>
+              <a:spcAft>
+                <a:spcPts val="240"/>
+              </a:spcAft>
+            </a:pPr>
+            <a:r>
+              <a:rPr sz="740" b="1">
+                <a:solidFill>
+                  <a:srgbClr val="314359"/>
+                </a:solidFill>
+                <a:latin typeface="Arial"/>
+              </a:rPr>
+              <a:t>Loughran, T. &amp; Ritter, J. R. (1995).</a:t>
+            </a:r>
+            <a:r>
+              <a:rPr sz="740" b="0">
+                <a:solidFill>
+                  <a:srgbClr val="0E1620"/>
+                </a:solidFill>
+                <a:latin typeface="Arial"/>
+              </a:rPr>
+              <a:t> The New Issues Puzzle. Journal of Finance 50(1): 23–51.</a:t>
+            </a:r>
+          </a:p>
+          <a:p>
+            <a:pPr>
+              <a:spcAft>
+                <a:spcPts val="240"/>
+              </a:spcAft>
+            </a:pPr>
+            <a:r>
+              <a:rPr sz="740" b="1">
+                <a:solidFill>
+                  <a:srgbClr val="314359"/>
+                </a:solidFill>
+                <a:latin typeface="Arial"/>
+              </a:rPr>
+              <a:t>Ritter, J. R. &amp; Welch, I. (2002).</a:t>
+            </a:r>
+            <a:r>
+              <a:rPr sz="740" b="0">
+                <a:solidFill>
+                  <a:srgbClr val="0E1620"/>
+                </a:solidFill>
+                <a:latin typeface="Arial"/>
+              </a:rPr>
+              <a:t> A Review of IPO Activity, Pricing, and Allocations. Journal of Finance 57(4): 1795–1828.</a:t>
+            </a:r>
+          </a:p>
+          <a:p>
+            <a:pPr>
+              <a:spcAft>
+                <a:spcPts val="240"/>
+              </a:spcAft>
+            </a:pPr>
+            <a:r>
+              <a:rPr sz="740" b="1">
+                <a:solidFill>
+                  <a:srgbClr val="314359"/>
+                </a:solidFill>
+                <a:latin typeface="Arial"/>
+              </a:rPr>
+              <a:t>Ibbotson, R. G. &amp; Jaffe, J. F. (1975).</a:t>
+            </a:r>
+            <a:r>
+              <a:rPr sz="740" b="0">
+                <a:solidFill>
+                  <a:srgbClr val="0E1620"/>
+                </a:solidFill>
+                <a:latin typeface="Arial"/>
+              </a:rPr>
+              <a:t> “Hot Issue” Markets. Journal of Finance 30(4): 1027–1042.</a:t>
+            </a:r>
+          </a:p>
+          <a:p>
+            <a:pPr>
+              <a:spcAft>
+                <a:spcPts val="240"/>
+              </a:spcAft>
+            </a:pPr>
+            <a:r>
+              <a:rPr sz="740" b="1">
+                <a:solidFill>
+                  <a:srgbClr val="314359"/>
+                </a:solidFill>
+                <a:latin typeface="Arial"/>
+              </a:rPr>
+              <a:t>Greenwood, R., Shleifer, A. &amp; You, Y. (2019).</a:t>
+            </a:r>
+            <a:r>
+              <a:rPr sz="740" b="0">
+                <a:solidFill>
+                  <a:srgbClr val="0E1620"/>
+                </a:solidFill>
+                <a:latin typeface="Arial"/>
+              </a:rPr>
+              <a:t> Bubbles for Fama. Journal of Financial Economics 131(1): 20–43.</a:t>
+            </a:r>
+          </a:p>
+          <a:p>
+            <a:pPr>
+              <a:spcAft>
+                <a:spcPts val="240"/>
+              </a:spcAft>
+            </a:pPr>
+            <a:r>
+              <a:rPr sz="740" b="1">
+                <a:solidFill>
+                  <a:srgbClr val="314359"/>
+                </a:solidFill>
+                <a:latin typeface="Arial"/>
+              </a:rPr>
+              <a:t>Campbell, J. Y. &amp; Shiller, R. J. (1988).</a:t>
+            </a:r>
+            <a:r>
+              <a:rPr sz="740" b="0">
+                <a:solidFill>
+                  <a:srgbClr val="0E1620"/>
+                </a:solidFill>
+                <a:latin typeface="Arial"/>
+              </a:rPr>
+              <a:t> Stock Prices, Earnings, and Expected Dividends. Journal of Finance 43(3): 661–676.</a:t>
+            </a:r>
+          </a:p>
+        </p:txBody>
+      </p:sp>
+      <p:sp>
+        <p:nvSpPr>
+          <p:cNvPr id="14" name="TextBox 13"/>
+          <p:cNvSpPr txBox="1"/>
+          <p:nvPr/>
+        </p:nvSpPr>
+        <p:spPr>
+          <a:xfrm>
+            <a:off x="5440680" y="2560320"/>
+            <a:ext cx="3886200" cy="3840480"/>
+          </a:xfrm>
+          <a:prstGeom prst="rect">
+            <a:avLst/>
+          </a:prstGeom>
+          <a:noFill/>
+        </p:spPr>
+        <p:txBody>
+          <a:bodyPr wrap="square" lIns="0" rIns="0" tIns="0" bIns="0">
+            <a:spAutoFit/>
+          </a:bodyPr>
+          <a:lstStyle/>
+          <a:p>
+            <a:pPr>
+              <a:spcAft>
+                <a:spcPts val="200"/>
+              </a:spcAft>
+            </a:pPr>
+            <a:r>
+              <a:rPr sz="800" b="1">
+                <a:solidFill>
+                  <a:srgbClr val="314359"/>
+                </a:solidFill>
+                <a:latin typeface="Arial"/>
+              </a:rPr>
+              <a:t>BOOK</a:t>
+            </a:r>
+          </a:p>
+          <a:p>
+            <a:pPr>
+              <a:spcAft>
+                <a:spcPts val="260"/>
+              </a:spcAft>
+            </a:pPr>
+          </a:p>
+          <a:p>
+            <a:pPr>
+              <a:spcAft>
+                <a:spcPts val="260"/>
+              </a:spcAft>
+            </a:pPr>
+            <a:r>
+              <a:rPr sz="760" b="1">
+                <a:solidFill>
+                  <a:srgbClr val="314359"/>
+                </a:solidFill>
+                <a:latin typeface="Arial"/>
+              </a:rPr>
+              <a:t>Shiller, R. J. (2000, rev. 2015).</a:t>
+            </a:r>
+            <a:r>
+              <a:rPr sz="760" b="0">
+                <a:solidFill>
+                  <a:srgbClr val="0E1620"/>
+                </a:solidFill>
+                <a:latin typeface="Arial"/>
+              </a:rPr>
+              <a:t> Irrational Exuberance. Princeton University Press — not peer-reviewed.</a:t>
+            </a:r>
+          </a:p>
+          <a:p>
+            <a:pPr>
+              <a:spcBef>
+                <a:spcPts val="800"/>
+              </a:spcBef>
+              <a:spcAft>
+                <a:spcPts val="200"/>
+              </a:spcAft>
+            </a:pPr>
+            <a:r>
+              <a:rPr sz="800" b="1">
+                <a:solidFill>
+                  <a:srgbClr val="314359"/>
+                </a:solidFill>
+                <a:latin typeface="Arial"/>
+              </a:rPr>
+              <a:t>MARKET DATA &amp; REPORTING · 2025–26</a:t>
+            </a:r>
+          </a:p>
+          <a:p>
+            <a:pPr>
+              <a:spcAft>
+                <a:spcPts val="260"/>
+              </a:spcAft>
+            </a:pPr>
+            <a:r>
+              <a:rPr sz="760" b="1">
+                <a:solidFill>
+                  <a:srgbClr val="314359"/>
+                </a:solidFill>
+                <a:latin typeface="Arial"/>
+              </a:rPr>
+              <a:t>Shiller CAPE (~40, 2026):</a:t>
+            </a:r>
+            <a:r>
+              <a:rPr sz="760" b="0">
+                <a:solidFill>
+                  <a:srgbClr val="0E1620"/>
+                </a:solidFill>
+                <a:latin typeface="Arial"/>
+              </a:rPr>
+              <a:t> multpl.com; GuruFocus.</a:t>
+            </a:r>
+          </a:p>
+          <a:p>
+            <a:pPr>
+              <a:spcAft>
+                <a:spcPts val="260"/>
+              </a:spcAft>
+            </a:pPr>
+            <a:r>
+              <a:rPr sz="760" b="1">
+                <a:solidFill>
+                  <a:srgbClr val="314359"/>
+                </a:solidFill>
+                <a:latin typeface="Arial"/>
+              </a:rPr>
+              <a:t>“Magnificent Seven” ~35% of the S&amp;P 500 (2026):</a:t>
+            </a:r>
+            <a:r>
+              <a:rPr sz="760" b="0">
+                <a:solidFill>
+                  <a:srgbClr val="0E1620"/>
+                </a:solidFill>
+                <a:latin typeface="Arial"/>
+              </a:rPr>
+              <a:t> S&amp;P; Motley Fool; MacroMicro.</a:t>
+            </a:r>
+          </a:p>
+          <a:p>
+            <a:pPr>
+              <a:spcAft>
+                <a:spcPts val="260"/>
+              </a:spcAft>
+            </a:pPr>
+            <a:r>
+              <a:rPr sz="760" b="1">
+                <a:solidFill>
+                  <a:srgbClr val="314359"/>
+                </a:solidFill>
+                <a:latin typeface="Arial"/>
+              </a:rPr>
+              <a:t>Global / US IPO activity (2025–26):</a:t>
+            </a:r>
+            <a:r>
+              <a:rPr sz="760" b="0">
+                <a:solidFill>
+                  <a:srgbClr val="0E1620"/>
+                </a:solidFill>
+                <a:latin typeface="Arial"/>
+              </a:rPr>
+              <a:t> Cleary Gottlieb, Global IPO Trends.</a:t>
+            </a:r>
+          </a:p>
+          <a:p>
+            <a:pPr>
+              <a:spcAft>
+                <a:spcPts val="260"/>
+              </a:spcAft>
+            </a:pPr>
+            <a:r>
+              <a:rPr sz="760" b="1">
+                <a:solidFill>
+                  <a:srgbClr val="314359"/>
+                </a:solidFill>
+                <a:latin typeface="Arial"/>
+              </a:rPr>
+              <a:t>SpaceX IPO (Jun 2026, reported ~$1.8tn):</a:t>
+            </a:r>
+            <a:r>
+              <a:rPr sz="760" b="0">
+                <a:solidFill>
+                  <a:srgbClr val="0E1620"/>
+                </a:solidFill>
+                <a:latin typeface="Arial"/>
+              </a:rPr>
+              <a:t> NPR; CNBC.</a:t>
+            </a:r>
+          </a:p>
+          <a:p>
+            <a:pPr>
+              <a:spcAft>
+                <a:spcPts val="260"/>
+              </a:spcAft>
+            </a:pPr>
+            <a:r>
+              <a:rPr sz="760" b="1">
+                <a:solidFill>
+                  <a:srgbClr val="314359"/>
+                </a:solidFill>
+                <a:latin typeface="Arial"/>
+              </a:rPr>
+              <a:t>OpenAI &amp; Anthropic private valuations (2026):</a:t>
+            </a:r>
+            <a:r>
+              <a:rPr sz="760" b="0">
+                <a:solidFill>
+                  <a:srgbClr val="0E1620"/>
+                </a:solidFill>
+                <a:latin typeface="Arial"/>
+              </a:rPr>
+              <a:t> company releases; CNBC; WSJ.</a:t>
+            </a:r>
+          </a:p>
+          <a:p>
+            <a:pPr>
+              <a:spcAft>
+                <a:spcPts val="260"/>
+              </a:spcAft>
+            </a:pPr>
+            <a:r>
+              <a:rPr sz="760" b="1">
+                <a:solidFill>
+                  <a:srgbClr val="314359"/>
+                </a:solidFill>
+                <a:latin typeface="Arial"/>
+              </a:rPr>
+              <a:t>IMF &amp; Bank of England AI-valuation warnings (Oct 2025):</a:t>
+            </a:r>
+            <a:r>
+              <a:rPr sz="760" b="0">
+                <a:solidFill>
+                  <a:srgbClr val="0E1620"/>
+                </a:solidFill>
+                <a:latin typeface="Arial"/>
+              </a:rPr>
+              <a:t> CNBC.</a:t>
+            </a:r>
+          </a:p>
+        </p:txBody>
+      </p:sp>
+      <p:sp>
+        <p:nvSpPr>
+          <p:cNvPr id="15" name="TextBox 14"/>
+          <p:cNvSpPr txBox="1"/>
+          <p:nvPr/>
+        </p:nvSpPr>
+        <p:spPr>
+          <a:xfrm>
+            <a:off x="512064" y="6492240"/>
+            <a:ext cx="8778240" cy="365760"/>
+          </a:xfrm>
+          <a:prstGeom prst="rect">
+            <a:avLst/>
+          </a:prstGeom>
+          <a:noFill/>
+        </p:spPr>
+        <p:txBody>
+          <a:bodyPr wrap="square" lIns="0" rIns="0" tIns="0" bIns="0">
+            <a:spAutoFit/>
+          </a:bodyPr>
+          <a:lstStyle/>
+          <a:p>
+            <a:r>
+              <a:rPr sz="630" b="0">
+                <a:solidFill>
+                  <a:srgbClr val="8A939F"/>
+                </a:solidFill>
+                <a:latin typeface="Arial"/>
+              </a:rPr>
+              <a:t>Peer-reviewed journal articles unless marked. Contemporary valuations are reported/press figures (2026), including private funding rounds, and may be revised; full URLs available on request.</a:t>
             </a:r>
           </a:p>
         </p:txBody>

</xml_diff>